<commit_message>
Registro de cambios, etiquetas de versión y versión en la presentación
- CHANGELOG.md con las versiones 1.0.0 a 1.5.0: título, nuevas funciones,
  correcciones y otros cambios de cada una.
- Proceso de versiones documentado en docs/desarrollo.md: con cada cambio de
  versión se actualizan el CHANGELOG y la portada de la presentación, y después
  de fusionar se crean la etiqueta vX.Y.Z y la publicación en GitHub.
- docs/herramientas/notas_version.py: título y notas de una versión para la
  publicación. docs/herramientas/version_presentacion.py: versión en la portada
  de la presentación y PDF exportado con PowerPoint.
- Portada de la presentación con "Versión 1.5.0" (PowerPoint y PDF).
- Enlaces al registro de cambios en README.md y docs/README.md.
</commit_message>
<xml_diff>
--- a/docs/presentacion-jefes-de-proyecto.pptx
+++ b/docs/presentacion-jefes-de-proyecto.pptx
@@ -11415,6 +11415,51 @@
                 <a:latin typeface="Calibri"/>
               </a:rPr>
               <a:t>  ·  PV, EV y AC  ·  MS Project  ·  Excel</a:t>
+            </a:r>
+            <a:endParaRPr lang="es-ES" sz="1400"/>
+          </a:p>
+        </p:txBody>
+      </p:sp>
+      <p:sp>
+        <p:nvSpPr>
+          <p:cNvPr id="19" name="Versión"/>
+          <p:cNvSpPr txBox="1"/>
+          <p:nvPr/>
+        </p:nvSpPr>
+        <p:spPr>
+          <a:xfrm>
+            <a:off x="548640" y="6217920"/>
+            <a:ext cx="5486400" cy="365760"/>
+          </a:xfrm>
+          <a:prstGeom prst="rect">
+            <a:avLst/>
+          </a:prstGeom>
+          <a:noFill/>
+        </p:spPr>
+        <p:txBody>
+          <a:bodyPr wrap="square" lIns="0" rIns="0" tIns="0" bIns="0" anchor="t">
+            <a:noAutofit/>
+          </a:bodyPr>
+          <a:lstStyle/>
+          <a:p>
+            <a:pPr algn="l"/>
+            <a:r>
+              <a:rPr sz="1400" b="1" i="0" lang="es-ES">
+                <a:solidFill>
+                  <a:srgbClr val="F2B134"/>
+                </a:solidFill>
+                <a:latin typeface="Calibri"/>
+              </a:rPr>
+              <a:t>Versión 1.5.0</a:t>
+            </a:r>
+            <a:r>
+              <a:rPr sz="1400" b="0" i="0" lang="es-ES">
+                <a:solidFill>
+                  <a:srgbClr val="C9D3E3"/>
+                </a:solidFill>
+                <a:latin typeface="Calibri"/>
+              </a:rPr>
+              <a:t>  ·  Exportador EVM</a:t>
             </a:r>
             <a:endParaRPr lang="es-ES" sz="1400"/>
           </a:p>

</xml_diff>

<commit_message>
Registro de cambios, etiquetas de versión y versión en la presentación (#13)
- CHANGELOG.md con las versiones 1.0.0 a 1.5.0: título, nuevas funciones,
  correcciones y otros cambios de cada una.
- Proceso de versiones documentado en docs/desarrollo.md: con cada cambio de
  versión se actualizan el CHANGELOG y la portada de la presentación, y después
  de fusionar se crean la etiqueta vX.Y.Z y la publicación en GitHub.
- docs/herramientas/notas_version.py: título y notas de una versión para la
  publicación. docs/herramientas/version_presentacion.py: versión en la portada
  de la presentación y PDF exportado con PowerPoint.
- Portada de la presentación con "Versión 1.5.0" (PowerPoint y PDF).
- Enlaces al registro de cambios en README.md y docs/README.md.
</commit_message>
<xml_diff>
--- a/docs/presentacion-jefes-de-proyecto.pptx
+++ b/docs/presentacion-jefes-de-proyecto.pptx
@@ -11415,6 +11415,51 @@
                 <a:latin typeface="Calibri"/>
               </a:rPr>
               <a:t>  ·  PV, EV y AC  ·  MS Project  ·  Excel</a:t>
+            </a:r>
+            <a:endParaRPr lang="es-ES" sz="1400"/>
+          </a:p>
+        </p:txBody>
+      </p:sp>
+      <p:sp>
+        <p:nvSpPr>
+          <p:cNvPr id="19" name="Versión"/>
+          <p:cNvSpPr txBox="1"/>
+          <p:nvPr/>
+        </p:nvSpPr>
+        <p:spPr>
+          <a:xfrm>
+            <a:off x="548640" y="6217920"/>
+            <a:ext cx="5486400" cy="365760"/>
+          </a:xfrm>
+          <a:prstGeom prst="rect">
+            <a:avLst/>
+          </a:prstGeom>
+          <a:noFill/>
+        </p:spPr>
+        <p:txBody>
+          <a:bodyPr wrap="square" lIns="0" rIns="0" tIns="0" bIns="0" anchor="t">
+            <a:noAutofit/>
+          </a:bodyPr>
+          <a:lstStyle/>
+          <a:p>
+            <a:pPr algn="l"/>
+            <a:r>
+              <a:rPr sz="1400" b="1" i="0" lang="es-ES">
+                <a:solidFill>
+                  <a:srgbClr val="F2B134"/>
+                </a:solidFill>
+                <a:latin typeface="Calibri"/>
+              </a:rPr>
+              <a:t>Versión 1.5.0</a:t>
+            </a:r>
+            <a:r>
+              <a:rPr sz="1400" b="0" i="0" lang="es-ES">
+                <a:solidFill>
+                  <a:srgbClr val="C9D3E3"/>
+                </a:solidFill>
+                <a:latin typeface="Calibri"/>
+              </a:rPr>
+              <a:t>  ·  Exportador EVM</a:t>
             </a:r>
             <a:endParaRPr lang="es-ES" sz="1400"/>
           </a:p>

</xml_diff>

<commit_message>
Presentación: cómo se define el método de cada paquete
- Nueva diapositiva 24, Cómo se define el método de cada paquete: cinco pasos con el rol
  responsable de cada uno (PMO, responsable de paquete, Jefe de Proyecto), registro de los
  métodos y cambios de método por control de cambios, con notas para el presentador.
- El libro Excel (ahora diapositiva 30): la regla del método pasa de "editable en la columna C"
  a "en MS Project; columna C solo para cambios aprobados", también en las notas.
- Tiempos de las notas: 0:40 para la diapositiva nueva y 0:10 menos en las diapositivas 21 a 23
  y 25; el total sigue en 26:00. Números de página actualizados y PDF exportado de nuevo.
- Índice de docs (37 diapositivas) y CHANGELOG.
</commit_message>
<xml_diff>
--- a/docs/presentacion-jefes-de-proyecto.pptx
+++ b/docs/presentacion-jefes-de-proyecto.pptx
@@ -28,6 +28,7 @@
     <p:sldId id="276" r:id="rId27"/>
     <p:sldId id="277" r:id="rId28"/>
     <p:sldId id="278" r:id="rId29"/>
+    <p:sldId id="292" r:id="rId44"/>
     <p:sldId id="279" r:id="rId30"/>
     <p:sldId id="280" r:id="rId31"/>
     <p:sldId id="281" r:id="rId32"/>
@@ -5804,7 +5805,7 @@
           <a:p>
             <a:r>
               <a:rPr lang="es-ES"/>
-              <a:t>Tiempo: 1:10 min  ·  Acumulado: 16:15 min</a:t>
+              <a:t>Tiempo: 1:00 min  ·  Acumulado: 16:05 min</a:t>
             </a:r>
           </a:p>
           <a:p/>
@@ -5933,7 +5934,7 @@
           <a:p>
             <a:r>
               <a:rPr lang="es-ES"/>
-              <a:t>Tiempo: 0:50 min  ·  Acumulado: 17:05 min</a:t>
+              <a:t>Tiempo: 0:40 min  ·  Acumulado: 16:45 min</a:t>
             </a:r>
           </a:p>
           <a:p/>
@@ -6081,7 +6082,7 @@
           <a:p>
             <a:r>
               <a:rPr lang="es-ES"/>
-              <a:t>Tiempo: 0:30 min  ·  Acumulado: 17:35 min</a:t>
+              <a:t>Tiempo: 0:20 min  ·  Acumulado: 17:05 min</a:t>
             </a:r>
           </a:p>
           <a:p/>
@@ -6210,7 +6211,7 @@
           <a:p>
             <a:r>
               <a:rPr lang="es-ES"/>
-              <a:t>Tiempo: 0:50 min  ·  Acumulado: 18:25 min</a:t>
+              <a:t>Tiempo: 0:40 min  ·  Acumulado: 18:25 min</a:t>
             </a:r>
           </a:p>
           <a:p/>
@@ -6753,7 +6754,7 @@
           <a:p/>
           <a:p>
             <a:r>
-              <a:t>Reglas de uso (derecha): no insertar, borrar ni ordenar filas o columnas, porque actualizar ubica cada fila por su posición; para cambiar la EDT se cambia MS Project y se regenera con --migrar-desde. No escribir sobre subtotales ni fórmulas. El método de medición se puede cambiar en la columna C de la hoja PV.</a:t>
+              <a:t>Reglas de uso (derecha): no insertar, borrar ni ordenar filas o columnas, porque actualizar ubica cada fila por su posición; para cambiar la EDT se cambia MS Project y se regenera con --migrar-desde. No escribir sobre subtotales ni fórmulas. El método de medición se define en MS Project: generar lo copia a la columna C de la hoja PV, que es la que usa actualizar. La columna C solo se edita para aplicar un cambio de método aprobado, que se escribe también en MS Project; si no, los dos quedan distintos y el programa no lo advierte.</a:t>
             </a:r>
           </a:p>
           <a:p/>
@@ -7596,6 +7597,125 @@
           <a:p>
             <a:r>
               <a:t>La hoja se imprime en horizontal y se adjunta al informe junto con el Cuadro de Mando.</a:t>
+            </a:r>
+          </a:p>
+        </p:txBody>
+      </p:sp>
+      <p:sp>
+        <p:nvSpPr>
+          <p:cNvPr id="4" name="Slide Number Placeholder 3"/>
+          <p:cNvSpPr>
+            <a:spLocks noGrp="1"/>
+          </p:cNvSpPr>
+          <p:nvPr>
+            <p:ph type="sldNum" idx="5" sz="quarter"/>
+          </p:nvPr>
+        </p:nvSpPr>
+        <p:spPr/>
+      </p:sp>
+    </p:spTree>
+  </p:cSld>
+  <p:clrMapOvr>
+    <a:masterClrMapping/>
+  </p:clrMapOvr>
+</p:notes>
+</file>
+
+<file path=ppt/notesSlides/notesSlide37.xml><?xml version="1.0" encoding="utf-8"?>
+<p:notes xmlns:a="http://schemas.openxmlformats.org/drawingml/2006/main" xmlns:p="http://schemas.openxmlformats.org/presentationml/2006/main" xmlns:r="http://schemas.openxmlformats.org/officeDocument/2006/relationships">
+  <p:cSld>
+    <p:spTree>
+      <p:nvGrpSpPr>
+        <p:cNvPr id="1" name=""/>
+        <p:cNvGrpSpPr/>
+        <p:nvPr/>
+      </p:nvGrpSpPr>
+      <p:grpSpPr>
+        <a:xfrm>
+          <a:off x="0" y="0"/>
+          <a:ext cx="0" cy="0"/>
+          <a:chOff x="0" y="0"/>
+          <a:chExt cx="0" cy="0"/>
+        </a:xfrm>
+      </p:grpSpPr>
+      <p:sp>
+        <p:nvSpPr>
+          <p:cNvPr id="2" name="Slide Image Placeholder 1"/>
+          <p:cNvSpPr>
+            <a:spLocks noGrp="1"/>
+          </p:cNvSpPr>
+          <p:nvPr>
+            <p:ph type="sldImg" idx="2"/>
+          </p:nvPr>
+        </p:nvSpPr>
+        <p:spPr/>
+      </p:sp>
+      <p:sp>
+        <p:nvSpPr>
+          <p:cNvPr id="3" name="Notes Placeholder 2"/>
+          <p:cNvSpPr>
+            <a:spLocks noGrp="1"/>
+          </p:cNvSpPr>
+          <p:nvPr>
+            <p:ph type="body" idx="3" sz="quarter"/>
+          </p:nvPr>
+        </p:nvSpPr>
+        <p:spPr/>
+        <p:txBody>
+          <a:bodyPr/>
+          <a:lstStyle/>
+          <a:p>
+            <a:r>
+              <a:t>Tiempo: 0:40 min  ·  Acumulado: 17:45 min</a:t>
+            </a:r>
+          </a:p>
+          <a:p/>
+          <a:p>
+            <a:r>
+              <a:t>El método no lo decide una sola persona: se define durante la planificación, antes de guardar la línea base, y se aprueba con ella. Cinco pasos, cada uno con su responsable (el color del círculo: azul el PMO, ámbar el responsable de paquete y verde el Jefe de Proyecto):</a:t>
+            </a:r>
+          </a:p>
+          <a:p>
+            <a:r>
+              <a:t>1. Revisar los paquetes (PMO): el método se asigna al paquete de trabajo, no a sus tareas ni a sus hitos. Cada paquete con responsable, presupuesto y duración acotada. Un paquete largo sin entregables intermedios conviene dividirlo antes de recurrir a un porcentaje estimado.</a:t>
+            </a:r>
+          </a:p>
+          <a:p>
+            <a:r>
+              <a:t>2. Proponer el método (PMO), con la guía que acabamos de ver.</a:t>
+            </a:r>
+          </a:p>
+          <a:p>
+            <a:r>
+              <a:t>3. Definir el criterio de medición (responsable de paquete): con hitos ponderados, qué hitos, qué pesos y qué evidencia da cada uno por cumplido; con % físico o unidades, qué se mide y de dónde sale la medición; con LOE, por qué el paquete no tiene entregables medibles.</a:t>
+            </a:r>
+          </a:p>
+          <a:p>
+            <a:r>
+              <a:t>4. Aprobar con la línea base (Jefe de Proyecto). Antes se revisa el conjunto: cuánto del BAC queda en LOE y en % completado (conviene acordar un tope), al menos un hito por mes y ningún paquete largo con 0/100. Si el EVM se informa al cliente, conviene acordar con él los criterios de medición.</a:t>
+            </a:r>
+          </a:p>
+          <a:p>
+            <a:r>
+              <a:t>5. Cargar y verificar (PMO): el método en el campo Método EVM, los pesos en Peso hito y el criterio en las Notas del paquete o del hito. Después de generar, la hoja Validación no debe mostrar métodos por definir.</a:t>
+            </a:r>
+          </a:p>
+          <a:p/>
+          <a:p>
+            <a:r>
+              <a:t>Registro: una tabla en el plan de gestión con paquete, responsable, BAC, método y criterio de medición. Es la referencia para medir cada mes y para explicar el informe.</a:t>
+            </a:r>
+          </a:p>
+          <a:p/>
+          <a:p>
+            <a:r>
+              <a:t>Cambio de método: solo por control de cambios, como la línea base. Se cambia en MS Project y también en la columna C de la hoja PV, que es la que usa actualizar. El EV del paquete se recalcula con el método nuevo y toda la diferencia cae en el mes del cambio: hay que explicarlo en el informe.</a:t>
+            </a:r>
+          </a:p>
+          <a:p/>
+          <a:p>
+            <a:r>
+              <a:t>Detalle en la documentación: Métodos de medición, sección 5.</a:t>
             </a:r>
           </a:p>
         </p:txBody>
@@ -28325,7 +28445,7 @@
                 </a:solidFill>
                 <a:latin typeface="Calibri"/>
               </a:rPr>
-              <a:t>24</a:t>
+              <a:t>25</a:t>
             </a:fld>
             <a:endParaRPr lang="es-ES" sz="1000"/>
           </a:p>
@@ -30456,7 +30576,7 @@
                 </a:solidFill>
                 <a:latin typeface="Calibri"/>
               </a:rPr>
-              <a:t>25</a:t>
+              <a:t>26</a:t>
             </a:fld>
             <a:endParaRPr lang="es-ES" sz="1000"/>
           </a:p>
@@ -30827,7 +30947,7 @@
                 </a:solidFill>
                 <a:latin typeface="Calibri"/>
               </a:rPr>
-              <a:t>26</a:t>
+              <a:t>27</a:t>
             </a:fld>
             <a:endParaRPr lang="es-ES" sz="1000"/>
           </a:p>
@@ -31918,7 +32038,7 @@
                 </a:solidFill>
                 <a:latin typeface="Calibri"/>
               </a:rPr>
-              <a:t>27</a:t>
+              <a:t>28</a:t>
             </a:fld>
             <a:endParaRPr lang="es-ES" sz="1000"/>
           </a:p>
@@ -33114,7 +33234,7 @@
                 </a:solidFill>
                 <a:latin typeface="Calibri"/>
               </a:rPr>
-              <a:t>28</a:t>
+              <a:t>29</a:t>
             </a:fld>
             <a:endParaRPr lang="es-ES" sz="1000"/>
           </a:p>
@@ -34104,7 +34224,7 @@
                 </a:solidFill>
                 <a:latin typeface="Calibri"/>
               </a:rPr>
-              <a:t>29</a:t>
+              <a:t>30</a:t>
             </a:fld>
             <a:endParaRPr lang="es-ES" sz="1000"/>
           </a:p>
@@ -35163,7 +35283,7 @@
                 </a:solidFill>
                 <a:latin typeface="Calibri"/>
               </a:rPr>
-              <a:t>Método editable</a:t>
+              <a:t>Método: en MS Project</a:t>
             </a:r>
             <a:endParaRPr lang="es-ES" sz="1400"/>
           </a:p>
@@ -35176,7 +35296,7 @@
                 </a:solidFill>
                 <a:latin typeface="Calibri"/>
               </a:rPr>
-              <a:t>en la columna C de la hoja PV</a:t>
+              <a:t>columna C solo para cambios aprobados</a:t>
             </a:r>
             <a:endParaRPr lang="es-ES" sz="1400"/>
           </a:p>
@@ -36612,7 +36732,7 @@
                 </a:solidFill>
                 <a:latin typeface="Calibri"/>
               </a:rPr>
-              <a:t>30</a:t>
+              <a:t>31</a:t>
             </a:fld>
             <a:endParaRPr lang="es-ES" sz="1000"/>
           </a:p>
@@ -37069,7 +37189,7 @@
                 </a:solidFill>
                 <a:latin typeface="Calibri"/>
               </a:rPr>
-              <a:t>31</a:t>
+              <a:t>32</a:t>
             </a:fld>
             <a:endParaRPr lang="es-ES" sz="1000"/>
           </a:p>
@@ -38264,7 +38384,7 @@
                 </a:solidFill>
                 <a:latin typeface="Calibri"/>
               </a:rPr>
-              <a:t>32</a:t>
+              <a:t>33</a:t>
             </a:fld>
             <a:endParaRPr lang="es-ES" sz="1000"/>
           </a:p>
@@ -38765,7 +38885,7 @@
                 </a:solidFill>
                 <a:latin typeface="Calibri"/>
               </a:rPr>
-              <a:t>33</a:t>
+              <a:t>34</a:t>
             </a:fld>
             <a:endParaRPr lang="es-ES" sz="1000"/>
           </a:p>
@@ -40141,7 +40261,7 @@
                 </a:solidFill>
                 <a:latin typeface="Calibri"/>
               </a:rPr>
-              <a:t>34</a:t>
+              <a:t>35</a:t>
             </a:fld>
             <a:endParaRPr lang="es-ES" sz="1000"/>
           </a:p>
@@ -40565,7 +40685,7 @@
                 </a:solidFill>
                 <a:latin typeface="Calibri"/>
               </a:rPr>
-              <a:t>35</a:t>
+              <a:t>36</a:t>
             </a:fld>
             <a:endParaRPr lang="es-ES" sz="1000"/>
           </a:p>
@@ -41848,7 +41968,7 @@
                 </a:solidFill>
                 <a:latin typeface="Calibri"/>
               </a:rPr>
-              <a:t>36</a:t>
+              <a:t>37</a:t>
             </a:fld>
             <a:endParaRPr lang="es-ES" sz="1000"/>
           </a:p>
@@ -42456,6 +42576,1105 @@
               <a:t>¿Preguntas?</a:t>
             </a:r>
             <a:endParaRPr lang="es-ES" sz="4000"/>
+          </a:p>
+        </p:txBody>
+      </p:sp>
+    </p:spTree>
+  </p:cSld>
+  <p:clrMapOvr>
+    <a:masterClrMapping/>
+  </p:clrMapOvr>
+</p:sld>
+</file>
+
+<file path=ppt/slides/slide37.xml><?xml version="1.0" encoding="utf-8"?>
+<p:sld xmlns:a="http://schemas.openxmlformats.org/drawingml/2006/main" xmlns:p="http://schemas.openxmlformats.org/presentationml/2006/main" xmlns:r="http://schemas.openxmlformats.org/officeDocument/2006/relationships">
+  <p:cSld>
+    <p:spTree>
+      <p:nvGrpSpPr>
+        <p:cNvPr id="2" name=""/>
+        <p:cNvGrpSpPr/>
+        <p:nvPr/>
+      </p:nvGrpSpPr>
+      <p:grpSpPr/>
+      <p:sp>
+        <p:nvSpPr>
+          <p:cNvPr id="3" name="Title 1"/>
+          <p:cNvSpPr>
+            <a:spLocks noGrp="1"/>
+          </p:cNvSpPr>
+          <p:nvPr>
+            <p:ph type="title"/>
+          </p:nvPr>
+        </p:nvSpPr>
+        <p:spPr>
+          <a:xfrm>
+            <a:off x="548640" y="566928"/>
+            <a:ext cx="11064240" cy="685800"/>
+          </a:xfrm>
+        </p:spPr>
+        <p:txBody>
+          <a:bodyPr wrap="square" lIns="0" rIns="0" tIns="0" bIns="0" anchor="t">
+            <a:noAutofit/>
+          </a:bodyPr>
+          <a:lstStyle/>
+          <a:p>
+            <a:pPr algn="l"/>
+            <a:r>
+              <a:rPr sz="3200" b="1" i="0" lang="es-ES">
+                <a:solidFill>
+                  <a:srgbClr val="1B2B48"/>
+                </a:solidFill>
+                <a:latin typeface="Calibri"/>
+              </a:rPr>
+              <a:t>Cómo se define el método de cada paquete</a:t>
+            </a:r>
+            <a:endParaRPr lang="es-ES" sz="3200"/>
+          </a:p>
+        </p:txBody>
+      </p:sp>
+      <p:sp>
+        <p:nvSpPr>
+          <p:cNvPr id="4" name="TextBox 2"/>
+          <p:cNvSpPr txBox="1"/>
+          <p:nvPr/>
+        </p:nvSpPr>
+        <p:spPr>
+          <a:xfrm>
+            <a:off x="548640" y="274320"/>
+            <a:ext cx="7315200" cy="274320"/>
+          </a:xfrm>
+          <a:prstGeom prst="rect">
+            <a:avLst/>
+          </a:prstGeom>
+          <a:noFill/>
+        </p:spPr>
+        <p:txBody>
+          <a:bodyPr wrap="square" lIns="0" rIns="0" tIns="0" bIns="0" anchor="t">
+            <a:noAutofit/>
+          </a:bodyPr>
+          <a:lstStyle/>
+          <a:p>
+            <a:pPr algn="l"/>
+            <a:r>
+              <a:rPr sz="1100" b="1" i="0" lang="es-ES" spc="120">
+                <a:solidFill>
+                  <a:srgbClr val="8A5A00"/>
+                </a:solidFill>
+                <a:latin typeface="Calibri"/>
+              </a:rPr>
+              <a:t>MS PROJECT · AVANCE</a:t>
+            </a:r>
+            <a:endParaRPr lang="es-ES" sz="1100"/>
+          </a:p>
+        </p:txBody>
+      </p:sp>
+      <p:sp>
+        <p:nvSpPr>
+          <p:cNvPr id="5" name="TextBox 3"/>
+          <p:cNvSpPr txBox="1"/>
+          <p:nvPr/>
+        </p:nvSpPr>
+        <p:spPr>
+          <a:xfrm>
+            <a:off x="548640" y="6400800"/>
+            <a:ext cx="7315200" cy="274320"/>
+          </a:xfrm>
+          <a:prstGeom prst="rect">
+            <a:avLst/>
+          </a:prstGeom>
+          <a:noFill/>
+        </p:spPr>
+        <p:txBody>
+          <a:bodyPr wrap="square" lIns="0" rIns="0" tIns="0" bIns="0" anchor="t">
+            <a:noAutofit/>
+          </a:bodyPr>
+          <a:lstStyle/>
+          <a:p>
+            <a:pPr algn="l"/>
+            <a:r>
+              <a:rPr sz="1000" b="0" i="0" lang="es-ES">
+                <a:solidFill>
+                  <a:srgbClr val="5A6577"/>
+                </a:solidFill>
+                <a:latin typeface="Calibri"/>
+              </a:rPr>
+              <a:t>Exportador EVM · Sesión para equipo de proyecto</a:t>
+            </a:r>
+            <a:endParaRPr lang="es-ES" sz="1000"/>
+          </a:p>
+        </p:txBody>
+      </p:sp>
+      <p:sp>
+        <p:nvSpPr>
+          <p:cNvPr id="6" name="TextBox 4"/>
+          <p:cNvSpPr txBox="1"/>
+          <p:nvPr/>
+        </p:nvSpPr>
+        <p:spPr>
+          <a:xfrm>
+            <a:off x="10725912" y="6400800"/>
+            <a:ext cx="914400" cy="274320"/>
+          </a:xfrm>
+          <a:prstGeom prst="rect">
+            <a:avLst/>
+          </a:prstGeom>
+          <a:noFill/>
+        </p:spPr>
+        <p:txBody>
+          <a:bodyPr wrap="square" lIns="0" rIns="0" tIns="0" bIns="0" anchor="t">
+            <a:noAutofit/>
+          </a:bodyPr>
+          <a:lstStyle/>
+          <a:p>
+            <a:pPr algn="r"/>
+            <a:fld id="{B6F15528-21DE-4FAA-801E-634DDDAF4B2B}" type="slidenum">
+              <a:rPr lang="es-ES" sz="1000">
+                <a:solidFill>
+                  <a:srgbClr val="5A6577"/>
+                </a:solidFill>
+                <a:latin typeface="Calibri"/>
+              </a:rPr>
+              <a:t>24</a:t>
+            </a:fld>
+            <a:endParaRPr lang="es-ES" sz="1000"/>
+          </a:p>
+        </p:txBody>
+      </p:sp>
+      <p:sp>
+        <p:nvSpPr>
+          <p:cNvPr id="7" name="Paso 1 número"/>
+          <p:cNvSpPr/>
+          <p:nvPr/>
+        </p:nvSpPr>
+        <p:spPr>
+          <a:xfrm>
+            <a:off x="548640" y="1554480"/>
+            <a:ext cx="566928" cy="566928"/>
+          </a:xfrm>
+          <a:prstGeom prst="ellipse">
+            <a:avLst/>
+          </a:prstGeom>
+          <a:solidFill>
+            <a:srgbClr val="2F5597"/>
+          </a:solidFill>
+          <a:ln>
+            <a:noFill/>
+          </a:ln>
+        </p:spPr>
+        <p:txBody>
+          <a:bodyPr wrap="square" lIns="0" rIns="0" tIns="0" bIns="0" anchor="ctr">
+            <a:noAutofit/>
+          </a:bodyPr>
+          <a:lstStyle/>
+          <a:p>
+            <a:pPr algn="ctr"/>
+            <a:r>
+              <a:rPr sz="1800" b="1" i="0" lang="es-ES">
+                <a:solidFill>
+                  <a:srgbClr val="FFFFFF"/>
+                </a:solidFill>
+                <a:latin typeface="Calibri"/>
+              </a:rPr>
+              <a:t>1</a:t>
+            </a:r>
+            <a:endParaRPr lang="es-ES" sz="1800"/>
+          </a:p>
+        </p:txBody>
+      </p:sp>
+      <p:cxnSp>
+        <p:nvCxnSpPr>
+          <p:cNvPr id="8" name="Paso 1 flecha"/>
+          <p:cNvCxnSpPr/>
+          <p:nvPr/>
+        </p:nvCxnSpPr>
+        <p:spPr>
+          <a:xfrm>
+            <a:off x="1225296" y="1837944"/>
+            <a:ext cx="1453896" cy="0"/>
+          </a:xfrm>
+          <a:prstGeom prst="line">
+            <a:avLst/>
+          </a:prstGeom>
+          <a:ln w="25400">
+            <a:solidFill>
+              <a:srgbClr val="D5DBE5"/>
+            </a:solidFill>
+            <a:tailEnd type="triangle" w="med" len="med"/>
+          </a:ln>
+        </p:spPr>
+      </p:cxnSp>
+      <p:sp>
+        <p:nvSpPr>
+          <p:cNvPr id="9" name="Paso 1 título"/>
+          <p:cNvSpPr txBox="1"/>
+          <p:nvPr/>
+        </p:nvSpPr>
+        <p:spPr>
+          <a:xfrm>
+            <a:off x="548640" y="2304288"/>
+            <a:ext cx="2103120" cy="566928"/>
+          </a:xfrm>
+          <a:prstGeom prst="rect">
+            <a:avLst/>
+          </a:prstGeom>
+          <a:noFill/>
+        </p:spPr>
+        <p:txBody>
+          <a:bodyPr wrap="square" lIns="0" rIns="0" tIns="0" bIns="0" anchor="t">
+            <a:noAutofit/>
+          </a:bodyPr>
+          <a:lstStyle/>
+          <a:p>
+            <a:pPr algn="l"/>
+            <a:r>
+              <a:rPr sz="1700" b="1" i="0" lang="es-ES">
+                <a:solidFill>
+                  <a:srgbClr val="1B2B48"/>
+                </a:solidFill>
+                <a:latin typeface="Calibri"/>
+              </a:rPr>
+              <a:t>Revisar los paquetes</a:t>
+            </a:r>
+            <a:endParaRPr lang="es-ES" sz="1700"/>
+          </a:p>
+        </p:txBody>
+      </p:sp>
+      <p:sp>
+        <p:nvSpPr>
+          <p:cNvPr id="10" name="Paso 1 rol"/>
+          <p:cNvSpPr txBox="1"/>
+          <p:nvPr/>
+        </p:nvSpPr>
+        <p:spPr>
+          <a:xfrm>
+            <a:off x="548640" y="2907792"/>
+            <a:ext cx="2103120" cy="292608"/>
+          </a:xfrm>
+          <a:prstGeom prst="rect">
+            <a:avLst/>
+          </a:prstGeom>
+          <a:noFill/>
+        </p:spPr>
+        <p:txBody>
+          <a:bodyPr wrap="square" lIns="0" rIns="0" tIns="0" bIns="0" anchor="t">
+            <a:noAutofit/>
+          </a:bodyPr>
+          <a:lstStyle/>
+          <a:p>
+            <a:pPr algn="l"/>
+            <a:r>
+              <a:rPr sz="1300" b="1" i="0" lang="es-ES">
+                <a:solidFill>
+                  <a:srgbClr val="2F5597"/>
+                </a:solidFill>
+                <a:latin typeface="Calibri"/>
+              </a:rPr>
+              <a:t>PMO / planificador</a:t>
+            </a:r>
+            <a:endParaRPr lang="es-ES" sz="1300"/>
+          </a:p>
+        </p:txBody>
+      </p:sp>
+      <p:sp>
+        <p:nvSpPr>
+          <p:cNvPr id="11" name="Paso 1 detalle"/>
+          <p:cNvSpPr txBox="1"/>
+          <p:nvPr/>
+        </p:nvSpPr>
+        <p:spPr>
+          <a:xfrm>
+            <a:off x="548640" y="3246120"/>
+            <a:ext cx="2103120" cy="1097280"/>
+          </a:xfrm>
+          <a:prstGeom prst="rect">
+            <a:avLst/>
+          </a:prstGeom>
+          <a:noFill/>
+        </p:spPr>
+        <p:txBody>
+          <a:bodyPr wrap="square" lIns="0" rIns="0" tIns="0" bIns="0" anchor="t">
+            <a:noAutofit/>
+          </a:bodyPr>
+          <a:lstStyle/>
+          <a:p>
+            <a:pPr algn="l"/>
+            <a:r>
+              <a:rPr sz="1400" b="0" i="0" lang="es-ES">
+                <a:solidFill>
+                  <a:srgbClr val="5A6577"/>
+                </a:solidFill>
+                <a:latin typeface="Calibri"/>
+              </a:rPr>
+              <a:t>Nivel 3 de la EDT, con responsable, presupuesto y duración acotada</a:t>
+            </a:r>
+            <a:endParaRPr lang="es-ES" sz="1400"/>
+          </a:p>
+        </p:txBody>
+      </p:sp>
+      <p:sp>
+        <p:nvSpPr>
+          <p:cNvPr id="12" name="Paso 2 número"/>
+          <p:cNvSpPr/>
+          <p:nvPr/>
+        </p:nvSpPr>
+        <p:spPr>
+          <a:xfrm>
+            <a:off x="2788920" y="1554480"/>
+            <a:ext cx="566928" cy="566928"/>
+          </a:xfrm>
+          <a:prstGeom prst="ellipse">
+            <a:avLst/>
+          </a:prstGeom>
+          <a:solidFill>
+            <a:srgbClr val="2F5597"/>
+          </a:solidFill>
+          <a:ln>
+            <a:noFill/>
+          </a:ln>
+        </p:spPr>
+        <p:txBody>
+          <a:bodyPr wrap="square" lIns="0" rIns="0" tIns="0" bIns="0" anchor="ctr">
+            <a:noAutofit/>
+          </a:bodyPr>
+          <a:lstStyle/>
+          <a:p>
+            <a:pPr algn="ctr"/>
+            <a:r>
+              <a:rPr sz="1800" b="1" i="0" lang="es-ES">
+                <a:solidFill>
+                  <a:srgbClr val="FFFFFF"/>
+                </a:solidFill>
+                <a:latin typeface="Calibri"/>
+              </a:rPr>
+              <a:t>2</a:t>
+            </a:r>
+            <a:endParaRPr lang="es-ES" sz="1800"/>
+          </a:p>
+        </p:txBody>
+      </p:sp>
+      <p:cxnSp>
+        <p:nvCxnSpPr>
+          <p:cNvPr id="13" name="Paso 2 flecha"/>
+          <p:cNvCxnSpPr/>
+          <p:nvPr/>
+        </p:nvCxnSpPr>
+        <p:spPr>
+          <a:xfrm>
+            <a:off x="3465576" y="1837944"/>
+            <a:ext cx="1453896" cy="0"/>
+          </a:xfrm>
+          <a:prstGeom prst="line">
+            <a:avLst/>
+          </a:prstGeom>
+          <a:ln w="25400">
+            <a:solidFill>
+              <a:srgbClr val="D5DBE5"/>
+            </a:solidFill>
+            <a:tailEnd type="triangle" w="med" len="med"/>
+          </a:ln>
+        </p:spPr>
+      </p:cxnSp>
+      <p:sp>
+        <p:nvSpPr>
+          <p:cNvPr id="14" name="Paso 2 título"/>
+          <p:cNvSpPr txBox="1"/>
+          <p:nvPr/>
+        </p:nvSpPr>
+        <p:spPr>
+          <a:xfrm>
+            <a:off x="2788920" y="2304288"/>
+            <a:ext cx="2103120" cy="566928"/>
+          </a:xfrm>
+          <a:prstGeom prst="rect">
+            <a:avLst/>
+          </a:prstGeom>
+          <a:noFill/>
+        </p:spPr>
+        <p:txBody>
+          <a:bodyPr wrap="square" lIns="0" rIns="0" tIns="0" bIns="0" anchor="t">
+            <a:noAutofit/>
+          </a:bodyPr>
+          <a:lstStyle/>
+          <a:p>
+            <a:pPr algn="l"/>
+            <a:r>
+              <a:rPr sz="1700" b="1" i="0" lang="es-ES">
+                <a:solidFill>
+                  <a:srgbClr val="1B2B48"/>
+                </a:solidFill>
+                <a:latin typeface="Calibri"/>
+              </a:rPr>
+              <a:t>Proponer el método</a:t>
+            </a:r>
+            <a:endParaRPr lang="es-ES" sz="1700"/>
+          </a:p>
+        </p:txBody>
+      </p:sp>
+      <p:sp>
+        <p:nvSpPr>
+          <p:cNvPr id="15" name="Paso 2 rol"/>
+          <p:cNvSpPr txBox="1"/>
+          <p:nvPr/>
+        </p:nvSpPr>
+        <p:spPr>
+          <a:xfrm>
+            <a:off x="2788920" y="2907792"/>
+            <a:ext cx="2103120" cy="292608"/>
+          </a:xfrm>
+          <a:prstGeom prst="rect">
+            <a:avLst/>
+          </a:prstGeom>
+          <a:noFill/>
+        </p:spPr>
+        <p:txBody>
+          <a:bodyPr wrap="square" lIns="0" rIns="0" tIns="0" bIns="0" anchor="t">
+            <a:noAutofit/>
+          </a:bodyPr>
+          <a:lstStyle/>
+          <a:p>
+            <a:pPr algn="l"/>
+            <a:r>
+              <a:rPr sz="1300" b="1" i="0" lang="es-ES">
+                <a:solidFill>
+                  <a:srgbClr val="2F5597"/>
+                </a:solidFill>
+                <a:latin typeface="Calibri"/>
+              </a:rPr>
+              <a:t>PMO / planificador</a:t>
+            </a:r>
+            <a:endParaRPr lang="es-ES" sz="1300"/>
+          </a:p>
+        </p:txBody>
+      </p:sp>
+      <p:sp>
+        <p:nvSpPr>
+          <p:cNvPr id="16" name="Paso 2 detalle"/>
+          <p:cNvSpPr txBox="1"/>
+          <p:nvPr/>
+        </p:nvSpPr>
+        <p:spPr>
+          <a:xfrm>
+            <a:off x="2788920" y="3246120"/>
+            <a:ext cx="2103120" cy="1097280"/>
+          </a:xfrm>
+          <a:prstGeom prst="rect">
+            <a:avLst/>
+          </a:prstGeom>
+          <a:noFill/>
+        </p:spPr>
+        <p:txBody>
+          <a:bodyPr wrap="square" lIns="0" rIns="0" tIns="0" bIns="0" anchor="t">
+            <a:noAutofit/>
+          </a:bodyPr>
+          <a:lstStyle/>
+          <a:p>
+            <a:pPr algn="l"/>
+            <a:r>
+              <a:rPr sz="1400" b="0" i="0" lang="es-ES">
+                <a:solidFill>
+                  <a:srgbClr val="5A6577"/>
+                </a:solidFill>
+                <a:latin typeface="Calibri"/>
+              </a:rPr>
+              <a:t>Con la guía, según la duración y el tipo de trabajo</a:t>
+            </a:r>
+            <a:endParaRPr lang="es-ES" sz="1400"/>
+          </a:p>
+        </p:txBody>
+      </p:sp>
+      <p:sp>
+        <p:nvSpPr>
+          <p:cNvPr id="17" name="Paso 3 número"/>
+          <p:cNvSpPr/>
+          <p:nvPr/>
+        </p:nvSpPr>
+        <p:spPr>
+          <a:xfrm>
+            <a:off x="5029200" y="1554480"/>
+            <a:ext cx="566928" cy="566928"/>
+          </a:xfrm>
+          <a:prstGeom prst="ellipse">
+            <a:avLst/>
+          </a:prstGeom>
+          <a:solidFill>
+            <a:srgbClr val="F2B134"/>
+          </a:solidFill>
+          <a:ln>
+            <a:noFill/>
+          </a:ln>
+        </p:spPr>
+        <p:txBody>
+          <a:bodyPr wrap="square" lIns="0" rIns="0" tIns="0" bIns="0" anchor="ctr">
+            <a:noAutofit/>
+          </a:bodyPr>
+          <a:lstStyle/>
+          <a:p>
+            <a:pPr algn="ctr"/>
+            <a:r>
+              <a:rPr sz="1800" b="1" i="0" lang="es-ES">
+                <a:solidFill>
+                  <a:srgbClr val="1B2B48"/>
+                </a:solidFill>
+                <a:latin typeface="Calibri"/>
+              </a:rPr>
+              <a:t>3</a:t>
+            </a:r>
+            <a:endParaRPr lang="es-ES" sz="1800"/>
+          </a:p>
+        </p:txBody>
+      </p:sp>
+      <p:cxnSp>
+        <p:nvCxnSpPr>
+          <p:cNvPr id="18" name="Paso 3 flecha"/>
+          <p:cNvCxnSpPr/>
+          <p:nvPr/>
+        </p:nvCxnSpPr>
+        <p:spPr>
+          <a:xfrm>
+            <a:off x="5705856" y="1837944"/>
+            <a:ext cx="1453896" cy="0"/>
+          </a:xfrm>
+          <a:prstGeom prst="line">
+            <a:avLst/>
+          </a:prstGeom>
+          <a:ln w="25400">
+            <a:solidFill>
+              <a:srgbClr val="D5DBE5"/>
+            </a:solidFill>
+            <a:tailEnd type="triangle" w="med" len="med"/>
+          </a:ln>
+        </p:spPr>
+      </p:cxnSp>
+      <p:sp>
+        <p:nvSpPr>
+          <p:cNvPr id="19" name="Paso 3 título"/>
+          <p:cNvSpPr txBox="1"/>
+          <p:nvPr/>
+        </p:nvSpPr>
+        <p:spPr>
+          <a:xfrm>
+            <a:off x="5029200" y="2304288"/>
+            <a:ext cx="2103120" cy="566928"/>
+          </a:xfrm>
+          <a:prstGeom prst="rect">
+            <a:avLst/>
+          </a:prstGeom>
+          <a:noFill/>
+        </p:spPr>
+        <p:txBody>
+          <a:bodyPr wrap="square" lIns="0" rIns="0" tIns="0" bIns="0" anchor="t">
+            <a:noAutofit/>
+          </a:bodyPr>
+          <a:lstStyle/>
+          <a:p>
+            <a:pPr algn="l"/>
+            <a:r>
+              <a:rPr sz="1700" b="1" i="0" lang="es-ES">
+                <a:solidFill>
+                  <a:srgbClr val="1B2B48"/>
+                </a:solidFill>
+                <a:latin typeface="Calibri"/>
+              </a:rPr>
+              <a:t>Definir el criterio de medición</a:t>
+            </a:r>
+            <a:endParaRPr lang="es-ES" sz="1700"/>
+          </a:p>
+        </p:txBody>
+      </p:sp>
+      <p:sp>
+        <p:nvSpPr>
+          <p:cNvPr id="20" name="Paso 3 rol"/>
+          <p:cNvSpPr txBox="1"/>
+          <p:nvPr/>
+        </p:nvSpPr>
+        <p:spPr>
+          <a:xfrm>
+            <a:off x="5029200" y="2907792"/>
+            <a:ext cx="2103120" cy="292608"/>
+          </a:xfrm>
+          <a:prstGeom prst="rect">
+            <a:avLst/>
+          </a:prstGeom>
+          <a:noFill/>
+        </p:spPr>
+        <p:txBody>
+          <a:bodyPr wrap="square" lIns="0" rIns="0" tIns="0" bIns="0" anchor="t">
+            <a:noAutofit/>
+          </a:bodyPr>
+          <a:lstStyle/>
+          <a:p>
+            <a:pPr algn="l"/>
+            <a:r>
+              <a:rPr sz="1300" b="1" i="0" lang="es-ES">
+                <a:solidFill>
+                  <a:srgbClr val="8A5A00"/>
+                </a:solidFill>
+                <a:latin typeface="Calibri"/>
+              </a:rPr>
+              <a:t>Responsable de paquete</a:t>
+            </a:r>
+            <a:endParaRPr lang="es-ES" sz="1300"/>
+          </a:p>
+        </p:txBody>
+      </p:sp>
+      <p:sp>
+        <p:nvSpPr>
+          <p:cNvPr id="21" name="Paso 3 detalle"/>
+          <p:cNvSpPr txBox="1"/>
+          <p:nvPr/>
+        </p:nvSpPr>
+        <p:spPr>
+          <a:xfrm>
+            <a:off x="5029200" y="3246120"/>
+            <a:ext cx="2103120" cy="1097280"/>
+          </a:xfrm>
+          <a:prstGeom prst="rect">
+            <a:avLst/>
+          </a:prstGeom>
+          <a:noFill/>
+        </p:spPr>
+        <p:txBody>
+          <a:bodyPr wrap="square" lIns="0" rIns="0" tIns="0" bIns="0" anchor="t">
+            <a:noAutofit/>
+          </a:bodyPr>
+          <a:lstStyle/>
+          <a:p>
+            <a:pPr algn="l"/>
+            <a:r>
+              <a:rPr sz="1400" b="0" i="0" lang="es-ES">
+                <a:solidFill>
+                  <a:srgbClr val="5A6577"/>
+                </a:solidFill>
+                <a:latin typeface="Calibri"/>
+              </a:rPr>
+              <a:t>Hitos, pesos y evidencia; o qué se mide y de dónde sale la medición</a:t>
+            </a:r>
+            <a:endParaRPr lang="es-ES" sz="1400"/>
+          </a:p>
+        </p:txBody>
+      </p:sp>
+      <p:sp>
+        <p:nvSpPr>
+          <p:cNvPr id="22" name="Paso 4 número"/>
+          <p:cNvSpPr/>
+          <p:nvPr/>
+        </p:nvSpPr>
+        <p:spPr>
+          <a:xfrm>
+            <a:off x="7269480" y="1554480"/>
+            <a:ext cx="566928" cy="566928"/>
+          </a:xfrm>
+          <a:prstGeom prst="ellipse">
+            <a:avLst/>
+          </a:prstGeom>
+          <a:solidFill>
+            <a:srgbClr val="4E8A3E"/>
+          </a:solidFill>
+          <a:ln>
+            <a:noFill/>
+          </a:ln>
+        </p:spPr>
+        <p:txBody>
+          <a:bodyPr wrap="square" lIns="0" rIns="0" tIns="0" bIns="0" anchor="ctr">
+            <a:noAutofit/>
+          </a:bodyPr>
+          <a:lstStyle/>
+          <a:p>
+            <a:pPr algn="ctr"/>
+            <a:r>
+              <a:rPr sz="1800" b="1" i="0" lang="es-ES">
+                <a:solidFill>
+                  <a:srgbClr val="FFFFFF"/>
+                </a:solidFill>
+                <a:latin typeface="Calibri"/>
+              </a:rPr>
+              <a:t>4</a:t>
+            </a:r>
+            <a:endParaRPr lang="es-ES" sz="1800"/>
+          </a:p>
+        </p:txBody>
+      </p:sp>
+      <p:cxnSp>
+        <p:nvCxnSpPr>
+          <p:cNvPr id="23" name="Paso 4 flecha"/>
+          <p:cNvCxnSpPr/>
+          <p:nvPr/>
+        </p:nvCxnSpPr>
+        <p:spPr>
+          <a:xfrm>
+            <a:off x="7946136" y="1837944"/>
+            <a:ext cx="1453896" cy="0"/>
+          </a:xfrm>
+          <a:prstGeom prst="line">
+            <a:avLst/>
+          </a:prstGeom>
+          <a:ln w="25400">
+            <a:solidFill>
+              <a:srgbClr val="D5DBE5"/>
+            </a:solidFill>
+            <a:tailEnd type="triangle" w="med" len="med"/>
+          </a:ln>
+        </p:spPr>
+      </p:cxnSp>
+      <p:sp>
+        <p:nvSpPr>
+          <p:cNvPr id="24" name="Paso 4 título"/>
+          <p:cNvSpPr txBox="1"/>
+          <p:nvPr/>
+        </p:nvSpPr>
+        <p:spPr>
+          <a:xfrm>
+            <a:off x="7269480" y="2304288"/>
+            <a:ext cx="2103120" cy="566928"/>
+          </a:xfrm>
+          <a:prstGeom prst="rect">
+            <a:avLst/>
+          </a:prstGeom>
+          <a:noFill/>
+        </p:spPr>
+        <p:txBody>
+          <a:bodyPr wrap="square" lIns="0" rIns="0" tIns="0" bIns="0" anchor="t">
+            <a:noAutofit/>
+          </a:bodyPr>
+          <a:lstStyle/>
+          <a:p>
+            <a:pPr algn="l"/>
+            <a:r>
+              <a:rPr sz="1700" b="1" i="0" lang="es-ES">
+                <a:solidFill>
+                  <a:srgbClr val="1B2B48"/>
+                </a:solidFill>
+                <a:latin typeface="Calibri"/>
+              </a:rPr>
+              <a:t>Aprobar con la línea base</a:t>
+            </a:r>
+            <a:endParaRPr lang="es-ES" sz="1700"/>
+          </a:p>
+        </p:txBody>
+      </p:sp>
+      <p:sp>
+        <p:nvSpPr>
+          <p:cNvPr id="25" name="Paso 4 rol"/>
+          <p:cNvSpPr txBox="1"/>
+          <p:nvPr/>
+        </p:nvSpPr>
+        <p:spPr>
+          <a:xfrm>
+            <a:off x="7269480" y="2907792"/>
+            <a:ext cx="2103120" cy="292608"/>
+          </a:xfrm>
+          <a:prstGeom prst="rect">
+            <a:avLst/>
+          </a:prstGeom>
+          <a:noFill/>
+        </p:spPr>
+        <p:txBody>
+          <a:bodyPr wrap="square" lIns="0" rIns="0" tIns="0" bIns="0" anchor="t">
+            <a:noAutofit/>
+          </a:bodyPr>
+          <a:lstStyle/>
+          <a:p>
+            <a:pPr algn="l"/>
+            <a:r>
+              <a:rPr sz="1300" b="1" i="0" lang="es-ES">
+                <a:solidFill>
+                  <a:srgbClr val="4E8A3E"/>
+                </a:solidFill>
+                <a:latin typeface="Calibri"/>
+              </a:rPr>
+              <a:t>Jefe de Proyecto</a:t>
+            </a:r>
+            <a:endParaRPr lang="es-ES" sz="1300"/>
+          </a:p>
+        </p:txBody>
+      </p:sp>
+      <p:sp>
+        <p:nvSpPr>
+          <p:cNvPr id="26" name="Paso 4 detalle"/>
+          <p:cNvSpPr txBox="1"/>
+          <p:nvPr/>
+        </p:nvSpPr>
+        <p:spPr>
+          <a:xfrm>
+            <a:off x="7269480" y="3246120"/>
+            <a:ext cx="2103120" cy="1097280"/>
+          </a:xfrm>
+          <a:prstGeom prst="rect">
+            <a:avLst/>
+          </a:prstGeom>
+          <a:noFill/>
+        </p:spPr>
+        <p:txBody>
+          <a:bodyPr wrap="square" lIns="0" rIns="0" tIns="0" bIns="0" anchor="t">
+            <a:noAutofit/>
+          </a:bodyPr>
+          <a:lstStyle/>
+          <a:p>
+            <a:pPr algn="l"/>
+            <a:r>
+              <a:rPr sz="1400" b="0" i="0" lang="es-ES">
+                <a:solidFill>
+                  <a:srgbClr val="5A6577"/>
+                </a:solidFill>
+                <a:latin typeface="Calibri"/>
+              </a:rPr>
+              <a:t>Conjunto revisado: LOE acotado y al menos un hito por mes</a:t>
+            </a:r>
+            <a:endParaRPr lang="es-ES" sz="1400"/>
+          </a:p>
+        </p:txBody>
+      </p:sp>
+      <p:sp>
+        <p:nvSpPr>
+          <p:cNvPr id="27" name="Paso 5 número"/>
+          <p:cNvSpPr/>
+          <p:nvPr/>
+        </p:nvSpPr>
+        <p:spPr>
+          <a:xfrm>
+            <a:off x="9509760" y="1554480"/>
+            <a:ext cx="566928" cy="566928"/>
+          </a:xfrm>
+          <a:prstGeom prst="ellipse">
+            <a:avLst/>
+          </a:prstGeom>
+          <a:solidFill>
+            <a:srgbClr val="2F5597"/>
+          </a:solidFill>
+          <a:ln>
+            <a:noFill/>
+          </a:ln>
+        </p:spPr>
+        <p:txBody>
+          <a:bodyPr wrap="square" lIns="0" rIns="0" tIns="0" bIns="0" anchor="ctr">
+            <a:noAutofit/>
+          </a:bodyPr>
+          <a:lstStyle/>
+          <a:p>
+            <a:pPr algn="ctr"/>
+            <a:r>
+              <a:rPr sz="1800" b="1" i="0" lang="es-ES">
+                <a:solidFill>
+                  <a:srgbClr val="FFFFFF"/>
+                </a:solidFill>
+                <a:latin typeface="Calibri"/>
+              </a:rPr>
+              <a:t>5</a:t>
+            </a:r>
+            <a:endParaRPr lang="es-ES" sz="1800"/>
+          </a:p>
+        </p:txBody>
+      </p:sp>
+      <p:sp>
+        <p:nvSpPr>
+          <p:cNvPr id="28" name="Paso 5 título"/>
+          <p:cNvSpPr txBox="1"/>
+          <p:nvPr/>
+        </p:nvSpPr>
+        <p:spPr>
+          <a:xfrm>
+            <a:off x="9509760" y="2304288"/>
+            <a:ext cx="2103120" cy="566928"/>
+          </a:xfrm>
+          <a:prstGeom prst="rect">
+            <a:avLst/>
+          </a:prstGeom>
+          <a:noFill/>
+        </p:spPr>
+        <p:txBody>
+          <a:bodyPr wrap="square" lIns="0" rIns="0" tIns="0" bIns="0" anchor="t">
+            <a:noAutofit/>
+          </a:bodyPr>
+          <a:lstStyle/>
+          <a:p>
+            <a:pPr algn="l"/>
+            <a:r>
+              <a:rPr sz="1700" b="1" i="0" lang="es-ES">
+                <a:solidFill>
+                  <a:srgbClr val="1B2B48"/>
+                </a:solidFill>
+                <a:latin typeface="Calibri"/>
+              </a:rPr>
+              <a:t>Cargar y verificar</a:t>
+            </a:r>
+            <a:endParaRPr lang="es-ES" sz="1700"/>
+          </a:p>
+        </p:txBody>
+      </p:sp>
+      <p:sp>
+        <p:nvSpPr>
+          <p:cNvPr id="29" name="Paso 5 rol"/>
+          <p:cNvSpPr txBox="1"/>
+          <p:nvPr/>
+        </p:nvSpPr>
+        <p:spPr>
+          <a:xfrm>
+            <a:off x="9509760" y="2907792"/>
+            <a:ext cx="2103120" cy="292608"/>
+          </a:xfrm>
+          <a:prstGeom prst="rect">
+            <a:avLst/>
+          </a:prstGeom>
+          <a:noFill/>
+        </p:spPr>
+        <p:txBody>
+          <a:bodyPr wrap="square" lIns="0" rIns="0" tIns="0" bIns="0" anchor="t">
+            <a:noAutofit/>
+          </a:bodyPr>
+          <a:lstStyle/>
+          <a:p>
+            <a:pPr algn="l"/>
+            <a:r>
+              <a:rPr sz="1300" b="1" i="0" lang="es-ES">
+                <a:solidFill>
+                  <a:srgbClr val="2F5597"/>
+                </a:solidFill>
+                <a:latin typeface="Calibri"/>
+              </a:rPr>
+              <a:t>PMO / planificador</a:t>
+            </a:r>
+            <a:endParaRPr lang="es-ES" sz="1300"/>
+          </a:p>
+        </p:txBody>
+      </p:sp>
+      <p:sp>
+        <p:nvSpPr>
+          <p:cNvPr id="30" name="Paso 5 detalle"/>
+          <p:cNvSpPr txBox="1"/>
+          <p:nvPr/>
+        </p:nvSpPr>
+        <p:spPr>
+          <a:xfrm>
+            <a:off x="9509760" y="3246120"/>
+            <a:ext cx="2103120" cy="1097280"/>
+          </a:xfrm>
+          <a:prstGeom prst="rect">
+            <a:avLst/>
+          </a:prstGeom>
+          <a:noFill/>
+        </p:spPr>
+        <p:txBody>
+          <a:bodyPr wrap="square" lIns="0" rIns="0" tIns="0" bIns="0" anchor="t">
+            <a:noAutofit/>
+          </a:bodyPr>
+          <a:lstStyle/>
+          <a:p>
+            <a:pPr algn="l"/>
+            <a:r>
+              <a:rPr sz="1400" b="0" i="0" lang="es-ES">
+                <a:solidFill>
+                  <a:srgbClr val="5A6577"/>
+                </a:solidFill>
+                <a:latin typeface="Calibri"/>
+              </a:rPr>
+              <a:t>Método EVM y Peso hito en MS Project, criterio en Notas; Validación sin métodos por definir</a:t>
+            </a:r>
+            <a:endParaRPr lang="es-ES" sz="1400"/>
+          </a:p>
+        </p:txBody>
+      </p:sp>
+      <p:sp>
+        <p:nvSpPr>
+          <p:cNvPr id="31" name="Registro"/>
+          <p:cNvSpPr/>
+          <p:nvPr/>
+        </p:nvSpPr>
+        <p:spPr>
+          <a:xfrm>
+            <a:off x="548640" y="4617720"/>
+            <a:ext cx="5440680" cy="1417320"/>
+          </a:xfrm>
+          <a:prstGeom prst="roundRect">
+            <a:avLst>
+              <a:gd name="adj" fmla="val 12000"/>
+            </a:avLst>
+          </a:prstGeom>
+          <a:solidFill>
+            <a:srgbClr val="F3F5F9"/>
+          </a:solidFill>
+          <a:ln>
+            <a:noFill/>
+          </a:ln>
+        </p:spPr>
+        <p:txBody>
+          <a:bodyPr wrap="square" lIns="201168" rIns="201168" tIns="201168" bIns="201168" anchor="ctr">
+            <a:noAutofit/>
+          </a:bodyPr>
+          <a:lstStyle/>
+          <a:p>
+            <a:pPr algn="l"/>
+            <a:r>
+              <a:rPr sz="1400" b="1" i="0" lang="es-ES">
+                <a:solidFill>
+                  <a:srgbClr val="1B2B48"/>
+                </a:solidFill>
+                <a:latin typeface="Calibri"/>
+              </a:rPr>
+              <a:t>Registro: </a:t>
+            </a:r>
+            <a:r>
+              <a:rPr sz="1400" b="0" i="0" lang="es-ES">
+                <a:solidFill>
+                  <a:srgbClr val="1B2B48"/>
+                </a:solidFill>
+                <a:latin typeface="Calibri"/>
+              </a:rPr>
+              <a:t>una tabla del plan de gestión con paquete, responsable, BAC, método y criterio de medición. Es la referencia para medir cada mes y para explicar el informe.</a:t>
+            </a:r>
+            <a:endParaRPr lang="es-ES" sz="1400"/>
+          </a:p>
+        </p:txBody>
+      </p:sp>
+      <p:sp>
+        <p:nvSpPr>
+          <p:cNvPr id="32" name="Cambio de método"/>
+          <p:cNvSpPr/>
+          <p:nvPr/>
+        </p:nvSpPr>
+        <p:spPr>
+          <a:xfrm>
+            <a:off x="6172200" y="4617720"/>
+            <a:ext cx="5440680" cy="1417320"/>
+          </a:xfrm>
+          <a:prstGeom prst="roundRect">
+            <a:avLst>
+              <a:gd name="adj" fmla="val 12000"/>
+            </a:avLst>
+          </a:prstGeom>
+          <a:solidFill>
+            <a:srgbClr val="FFF4D9"/>
+          </a:solidFill>
+          <a:ln>
+            <a:noFill/>
+          </a:ln>
+        </p:spPr>
+        <p:txBody>
+          <a:bodyPr wrap="square" lIns="201168" rIns="201168" tIns="201168" bIns="201168" anchor="ctr">
+            <a:noAutofit/>
+          </a:bodyPr>
+          <a:lstStyle/>
+          <a:p>
+            <a:pPr algn="l"/>
+            <a:r>
+              <a:rPr sz="1400" b="1" i="0" lang="es-ES">
+                <a:solidFill>
+                  <a:srgbClr val="1B2B48"/>
+                </a:solidFill>
+                <a:latin typeface="Calibri"/>
+              </a:rPr>
+              <a:t>Cambiar el método = control de cambios. </a:t>
+            </a:r>
+            <a:r>
+              <a:rPr sz="1400" b="0" i="0" lang="es-ES">
+                <a:solidFill>
+                  <a:srgbClr val="1B2B48"/>
+                </a:solidFill>
+                <a:latin typeface="Calibri"/>
+              </a:rPr>
+              <a:t>Se cambia en MS Project y en la columna C de la hoja PV. El EV del paquete se recalcula: el salto cae en el mes del cambio y se explica en el informe.</a:t>
+            </a:r>
+            <a:endParaRPr lang="es-ES" sz="1400"/>
           </a:p>
         </p:txBody>
       </p:sp>

</xml_diff>

<commit_message>
Documentación, capturas y presentación del modo porcentaje (versión 2.0.0)
- docs/modo-porcentaje.md: modo por defecto, pesos de tareas e hitos, multi-empresa, hojas, cierre
  mensual, cambios de BAC y diferencias con el modo costo.
- README, tutorial, configuración, multi-empresa, preparación en MS Project, métodos, libro Excel,
  comandos, validaciones, proceso de reporte, varios archivos, glosario y desarrollo actualizados;
  los documentos del modo costo indican que se aplican a ese modo.
- Capturas del libro regeneradas en el modo porcentaje (nuevas: % PV, % EV, % PV-EmpresaA).
- Presentación: presupuesto en el libro, curva por duración e hitos, cifras del ejemplo y capturas
  nuevas; portada con la versión 2.0.0 y PDF.
- Versión 2.0.0 y su entrada en CHANGELOG.md.
</commit_message>
<xml_diff>
--- a/docs/presentacion-jefes-de-proyecto.pptx
+++ b/docs/presentacion-jefes-de-proyecto.pptx
@@ -243,184 +243,184 @@
                 <c:formatCode>General</c:formatCode>
                 <c:ptCount val="61"/>
                 <c:pt idx="0">
-                  <c:v>2026</c:v>
+                  <c:v>2026.0</c:v>
                 </c:pt>
                 <c:pt idx="1">
-                  <c:v>2026.0833</c:v>
+                  <c:v>2026.0833333333333</c:v>
                 </c:pt>
                 <c:pt idx="2">
-                  <c:v>2026.1667</c:v>
+                  <c:v>2026.1666666666667</c:v>
                 </c:pt>
                 <c:pt idx="3">
                   <c:v>2026.25</c:v>
                 </c:pt>
                 <c:pt idx="4">
-                  <c:v>2026.3333</c:v>
+                  <c:v>2026.3333333333333</c:v>
                 </c:pt>
                 <c:pt idx="5">
-                  <c:v>2026.4167</c:v>
+                  <c:v>2026.4166666666667</c:v>
                 </c:pt>
                 <c:pt idx="6">
                   <c:v>2026.5</c:v>
                 </c:pt>
                 <c:pt idx="7">
-                  <c:v>2026.5833</c:v>
+                  <c:v>2026.5833333333333</c:v>
                 </c:pt>
                 <c:pt idx="8">
-                  <c:v>2026.6667</c:v>
+                  <c:v>2026.6666666666667</c:v>
                 </c:pt>
                 <c:pt idx="9">
                   <c:v>2026.75</c:v>
                 </c:pt>
                 <c:pt idx="10">
-                  <c:v>2026.8333</c:v>
+                  <c:v>2026.8333333333333</c:v>
                 </c:pt>
                 <c:pt idx="11">
-                  <c:v>2026.9167</c:v>
+                  <c:v>2026.9166666666667</c:v>
                 </c:pt>
                 <c:pt idx="12">
                   <c:v>2027.0</c:v>
                 </c:pt>
                 <c:pt idx="13">
-                  <c:v>2027.0833</c:v>
+                  <c:v>2027.0833333333333</c:v>
                 </c:pt>
                 <c:pt idx="14">
-                  <c:v>2027.1667</c:v>
+                  <c:v>2027.1666666666667</c:v>
                 </c:pt>
                 <c:pt idx="15">
                   <c:v>2027.25</c:v>
                 </c:pt>
                 <c:pt idx="16">
-                  <c:v>2027.3333</c:v>
+                  <c:v>2027.3333333333333</c:v>
                 </c:pt>
                 <c:pt idx="17">
-                  <c:v>2027.4167</c:v>
+                  <c:v>2027.4166666666667</c:v>
                 </c:pt>
                 <c:pt idx="18">
                   <c:v>2027.5</c:v>
                 </c:pt>
                 <c:pt idx="19">
-                  <c:v>2027.5833</c:v>
+                  <c:v>2027.5833333333333</c:v>
                 </c:pt>
                 <c:pt idx="20">
-                  <c:v>2027.6667</c:v>
+                  <c:v>2027.6666666666667</c:v>
                 </c:pt>
                 <c:pt idx="21">
                   <c:v>2027.75</c:v>
                 </c:pt>
                 <c:pt idx="22">
-                  <c:v>2027.8333</c:v>
+                  <c:v>2027.8333333333333</c:v>
                 </c:pt>
                 <c:pt idx="23">
-                  <c:v>2027.9167</c:v>
+                  <c:v>2027.9166666666667</c:v>
                 </c:pt>
                 <c:pt idx="24">
                   <c:v>2028.0</c:v>
                 </c:pt>
                 <c:pt idx="25">
-                  <c:v>2028.0833</c:v>
+                  <c:v>2028.0833333333333</c:v>
                 </c:pt>
                 <c:pt idx="26">
-                  <c:v>2028.1667</c:v>
+                  <c:v>2028.1666666666667</c:v>
                 </c:pt>
                 <c:pt idx="27">
                   <c:v>2028.25</c:v>
                 </c:pt>
                 <c:pt idx="28">
-                  <c:v>2028.3333</c:v>
+                  <c:v>2028.3333333333333</c:v>
                 </c:pt>
                 <c:pt idx="29">
-                  <c:v>2028.4167</c:v>
+                  <c:v>2028.4166666666667</c:v>
                 </c:pt>
                 <c:pt idx="30">
                   <c:v>2028.5</c:v>
                 </c:pt>
                 <c:pt idx="31">
-                  <c:v>2028.5833</c:v>
+                  <c:v>2028.5833333333333</c:v>
                 </c:pt>
                 <c:pt idx="32">
-                  <c:v>2028.6667</c:v>
+                  <c:v>2028.6666666666667</c:v>
                 </c:pt>
                 <c:pt idx="33">
                   <c:v>2028.75</c:v>
                 </c:pt>
                 <c:pt idx="34">
-                  <c:v>2028.8333</c:v>
+                  <c:v>2028.8333333333333</c:v>
                 </c:pt>
                 <c:pt idx="35">
-                  <c:v>2028.9167</c:v>
+                  <c:v>2028.9166666666667</c:v>
                 </c:pt>
                 <c:pt idx="36">
                   <c:v>2029.0</c:v>
                 </c:pt>
                 <c:pt idx="37">
-                  <c:v>2029.0833</c:v>
+                  <c:v>2029.0833333333333</c:v>
                 </c:pt>
                 <c:pt idx="38">
-                  <c:v>2029.1667</c:v>
+                  <c:v>2029.1666666666667</c:v>
                 </c:pt>
                 <c:pt idx="39">
                   <c:v>2029.25</c:v>
                 </c:pt>
                 <c:pt idx="40">
-                  <c:v>2029.3333</c:v>
+                  <c:v>2029.3333333333333</c:v>
                 </c:pt>
                 <c:pt idx="41">
-                  <c:v>2029.4167</c:v>
+                  <c:v>2029.4166666666667</c:v>
                 </c:pt>
                 <c:pt idx="42">
                   <c:v>2029.5</c:v>
                 </c:pt>
                 <c:pt idx="43">
-                  <c:v>2029.5833</c:v>
+                  <c:v>2029.5833333333333</c:v>
                 </c:pt>
                 <c:pt idx="44">
-                  <c:v>2029.6667</c:v>
+                  <c:v>2029.6666666666667</c:v>
                 </c:pt>
                 <c:pt idx="45">
                   <c:v>2029.75</c:v>
                 </c:pt>
                 <c:pt idx="46">
-                  <c:v>2029.8333</c:v>
+                  <c:v>2029.8333333333333</c:v>
                 </c:pt>
                 <c:pt idx="47">
-                  <c:v>2029.9167</c:v>
+                  <c:v>2029.9166666666667</c:v>
                 </c:pt>
                 <c:pt idx="48">
                   <c:v>2030.0</c:v>
                 </c:pt>
                 <c:pt idx="49">
-                  <c:v>2030.0833</c:v>
+                  <c:v>2030.0833333333333</c:v>
                 </c:pt>
                 <c:pt idx="50">
-                  <c:v>2030.1667</c:v>
+                  <c:v>2030.1666666666667</c:v>
                 </c:pt>
                 <c:pt idx="51">
                   <c:v>2030.25</c:v>
                 </c:pt>
                 <c:pt idx="52">
-                  <c:v>2030.3333</c:v>
+                  <c:v>2030.3333333333333</c:v>
                 </c:pt>
                 <c:pt idx="53">
-                  <c:v>2030.4167</c:v>
+                  <c:v>2030.4166666666667</c:v>
                 </c:pt>
                 <c:pt idx="54">
                   <c:v>2030.5</c:v>
                 </c:pt>
                 <c:pt idx="55">
-                  <c:v>2030.5833</c:v>
+                  <c:v>2030.5833333333333</c:v>
                 </c:pt>
                 <c:pt idx="56">
-                  <c:v>2030.6667</c:v>
+                  <c:v>2030.6666666666667</c:v>
                 </c:pt>
                 <c:pt idx="57">
                   <c:v>2030.75</c:v>
                 </c:pt>
                 <c:pt idx="58">
-                  <c:v>2030.8333</c:v>
+                  <c:v>2030.8333333333333</c:v>
                 </c:pt>
                 <c:pt idx="59">
-                  <c:v>2030.9167</c:v>
+                  <c:v>2030.9166666666667</c:v>
                 </c:pt>
                 <c:pt idx="60">
                   <c:v>2031.0</c:v>
@@ -435,7 +435,7 @@
                 <c:formatCode>General</c:formatCode>
                 <c:ptCount val="61"/>
                 <c:pt idx="0">
-                  <c:v>0</c:v>
+                  <c:v>0.0</c:v>
                 </c:pt>
                 <c:pt idx="1">
                   <c:v>0.069</c:v>
@@ -447,16 +447,16 @@
                   <c:v>0.33</c:v>
                 </c:pt>
                 <c:pt idx="4">
-                  <c:v>0.67</c:v>
+                  <c:v>0.533</c:v>
                 </c:pt>
                 <c:pt idx="5">
-                  <c:v>0.974</c:v>
+                  <c:v>0.877</c:v>
                 </c:pt>
                 <c:pt idx="6">
-                  <c:v>1.166</c:v>
+                  <c:v>0.925</c:v>
                 </c:pt>
                 <c:pt idx="7">
-                  <c:v>1.578</c:v>
+                  <c:v>1.392</c:v>
                 </c:pt>
                 <c:pt idx="8">
                   <c:v>1.926</c:v>
@@ -498,37 +498,37 @@
                   <c:v>7.68</c:v>
                 </c:pt>
                 <c:pt idx="21">
-                  <c:v>9.172</c:v>
+                  <c:v>8.602</c:v>
                 </c:pt>
                 <c:pt idx="22">
-                  <c:v>10.682</c:v>
+                  <c:v>9.482</c:v>
                 </c:pt>
                 <c:pt idx="23">
-                  <c:v>12.683</c:v>
+                  <c:v>10.747</c:v>
                 </c:pt>
                 <c:pt idx="24">
-                  <c:v>14.714</c:v>
+                  <c:v>12.092</c:v>
                 </c:pt>
                 <c:pt idx="25">
-                  <c:v>16.52</c:v>
+                  <c:v>13.34</c:v>
                 </c:pt>
                 <c:pt idx="26">
-                  <c:v>17.943</c:v>
+                  <c:v>14.133</c:v>
                 </c:pt>
                 <c:pt idx="27">
-                  <c:v>19.258</c:v>
+                  <c:v>14.758</c:v>
                 </c:pt>
                 <c:pt idx="28">
-                  <c:v>20.401</c:v>
+                  <c:v>15.301</c:v>
                 </c:pt>
                 <c:pt idx="29">
-                  <c:v>22.21</c:v>
+                  <c:v>16.42</c:v>
                 </c:pt>
                 <c:pt idx="30">
-                  <c:v>23.928</c:v>
+                  <c:v>20.35</c:v>
                 </c:pt>
                 <c:pt idx="31">
-                  <c:v>25.517</c:v>
+                  <c:v>21.467</c:v>
                 </c:pt>
                 <c:pt idx="32">
                   <c:v>26.83</c:v>
@@ -653,7 +653,7 @@
                 <c:formatCode>General</c:formatCode>
                 <c:ptCount val="25"/>
                 <c:pt idx="0">
-                  <c:v>2026</c:v>
+                  <c:v>2026.0</c:v>
                 </c:pt>
                 <c:pt idx="1">
                   <c:v>2026.0833</c:v>
@@ -737,7 +737,7 @@
                 <c:formatCode>General</c:formatCode>
                 <c:ptCount val="25"/>
                 <c:pt idx="0">
-                  <c:v>0</c:v>
+                  <c:v>0.0</c:v>
                 </c:pt>
                 <c:pt idx="1">
                   <c:v>0.039</c:v>
@@ -847,7 +847,7 @@
                 <c:formatCode>General</c:formatCode>
                 <c:ptCount val="25"/>
                 <c:pt idx="0">
-                  <c:v>2026</c:v>
+                  <c:v>2026.0</c:v>
                 </c:pt>
                 <c:pt idx="1">
                   <c:v>2026.0833</c:v>
@@ -931,7 +931,7 @@
                 <c:formatCode>General</c:formatCode>
                 <c:ptCount val="25"/>
                 <c:pt idx="0">
-                  <c:v>0</c:v>
+                  <c:v>0.0</c:v>
                 </c:pt>
                 <c:pt idx="1">
                   <c:v>0.054</c:v>
@@ -1042,10 +1042,10 @@
                 <c:formatCode>General</c:formatCode>
                 <c:ptCount val="2"/>
                 <c:pt idx="0">
-                  <c:v>2026</c:v>
+                  <c:v>2026.0</c:v>
                 </c:pt>
                 <c:pt idx="1">
-                  <c:v>2031</c:v>
+                  <c:v>2031.0</c:v>
                 </c:pt>
               </c:numCache>
             </c:numRef>
@@ -1274,7 +1274,7 @@
                         </a:solidFill>
                         <a:latin typeface="Calibri"/>
                       </a:rPr>
-                      <a:t>78,5 M€</a:t>
+                      <a:t>66,9 M€</a:t>
                     </a:r>
                   </a:p>
                 </c:rich>
@@ -1403,7 +1403,7 @@
                 <c:formatCode>General</c:formatCode>
                 <c:ptCount val="4"/>
                 <c:pt idx="0">
-                  <c:v>78.52</c:v>
+                  <c:v>66.93</c:v>
                 </c:pt>
                 <c:pt idx="1">
                   <c:v>58.53</c:v>
@@ -1669,7 +1669,7 @@
                 <c:formatCode>General</c:formatCode>
                 <c:ptCount val="31"/>
                 <c:pt idx="0">
-                  <c:v>0</c:v>
+                  <c:v>0.0</c:v>
                 </c:pt>
                 <c:pt idx="1">
                   <c:v>0.069</c:v>
@@ -1681,16 +1681,16 @@
                   <c:v>0.33</c:v>
                 </c:pt>
                 <c:pt idx="4">
-                  <c:v>0.67</c:v>
+                  <c:v>0.533</c:v>
                 </c:pt>
                 <c:pt idx="5">
-                  <c:v>0.974</c:v>
+                  <c:v>0.877</c:v>
                 </c:pt>
                 <c:pt idx="6">
-                  <c:v>1.166</c:v>
+                  <c:v>0.925</c:v>
                 </c:pt>
                 <c:pt idx="7">
-                  <c:v>1.578</c:v>
+                  <c:v>1.392</c:v>
                 </c:pt>
                 <c:pt idx="8">
                   <c:v>1.926</c:v>
@@ -1732,34 +1732,34 @@
                   <c:v>7.68</c:v>
                 </c:pt>
                 <c:pt idx="21">
-                  <c:v>9.172</c:v>
+                  <c:v>8.602</c:v>
                 </c:pt>
                 <c:pt idx="22">
-                  <c:v>10.682</c:v>
+                  <c:v>9.482</c:v>
                 </c:pt>
                 <c:pt idx="23">
-                  <c:v>12.683</c:v>
+                  <c:v>10.747</c:v>
                 </c:pt>
                 <c:pt idx="24">
-                  <c:v>14.714</c:v>
+                  <c:v>12.092</c:v>
                 </c:pt>
                 <c:pt idx="25">
-                  <c:v>16.52</c:v>
+                  <c:v>13.34</c:v>
                 </c:pt>
                 <c:pt idx="26">
-                  <c:v>17.943</c:v>
+                  <c:v>14.133</c:v>
                 </c:pt>
                 <c:pt idx="27">
-                  <c:v>19.258</c:v>
+                  <c:v>14.758</c:v>
                 </c:pt>
                 <c:pt idx="28">
-                  <c:v>20.401</c:v>
+                  <c:v>15.301</c:v>
                 </c:pt>
                 <c:pt idx="29">
-                  <c:v>22.21</c:v>
+                  <c:v>16.42</c:v>
                 </c:pt>
                 <c:pt idx="30">
-                  <c:v>23.928</c:v>
+                  <c:v>20.35</c:v>
                 </c:pt>
               </c:numCache>
             </c:numRef>
@@ -1806,7 +1806,7 @@
                 <c:formatCode>General</c:formatCode>
                 <c:ptCount val="1"/>
                 <c:pt idx="0">
-                  <c:v>24</c:v>
+                  <c:v>24.0</c:v>
                 </c:pt>
               </c:numCache>
             </c:numRef>
@@ -1865,7 +1865,7 @@
                 <c:formatCode>General</c:formatCode>
                 <c:ptCount val="1"/>
                 <c:pt idx="0">
-                  <c:v>21.67</c:v>
+                  <c:v>22.56</c:v>
                 </c:pt>
               </c:numCache>
             </c:numRef>
@@ -1915,7 +1915,7 @@
                 <c:formatCode>General</c:formatCode>
                 <c:ptCount val="2"/>
                 <c:pt idx="0">
-                  <c:v>21.67</c:v>
+                  <c:v>22.56</c:v>
                 </c:pt>
                 <c:pt idx="1">
                   <c:v>24</c:v>
@@ -1972,10 +1972,10 @@
                 <c:formatCode>General</c:formatCode>
                 <c:ptCount val="2"/>
                 <c:pt idx="0">
-                  <c:v>24</c:v>
+                  <c:v>24.0</c:v>
                 </c:pt>
                 <c:pt idx="1">
-                  <c:v>24</c:v>
+                  <c:v>24.0</c:v>
                 </c:pt>
               </c:numCache>
             </c:numRef>
@@ -1987,7 +1987,7 @@
                 <c:formatCode>General</c:formatCode>
                 <c:ptCount val="2"/>
                 <c:pt idx="0">
-                  <c:v>0</c:v>
+                  <c:v>0.0</c:v>
                 </c:pt>
                 <c:pt idx="1">
                   <c:v>10.191</c:v>
@@ -2029,10 +2029,10 @@
                 <c:formatCode>General</c:formatCode>
                 <c:ptCount val="2"/>
                 <c:pt idx="0">
-                  <c:v>21.67</c:v>
+                  <c:v>22.56</c:v>
                 </c:pt>
                 <c:pt idx="1">
-                  <c:v>21.67</c:v>
+                  <c:v>22.56</c:v>
                 </c:pt>
               </c:numCache>
             </c:numRef>
@@ -2044,7 +2044,7 @@
                 <c:formatCode>General</c:formatCode>
                 <c:ptCount val="2"/>
                 <c:pt idx="0">
-                  <c:v>0</c:v>
+                  <c:v>0.0</c:v>
                 </c:pt>
                 <c:pt idx="1">
                   <c:v>10.191</c:v>
@@ -2777,79 +2777,79 @@
                 <c:formatCode>General</c:formatCode>
                 <c:ptCount val="25"/>
                 <c:pt idx="0">
-                  <c:v>0</c:v>
+                  <c:v>0.0</c:v>
                 </c:pt>
                 <c:pt idx="1">
-                  <c:v>1</c:v>
+                  <c:v>1.0</c:v>
                 </c:pt>
                 <c:pt idx="2">
-                  <c:v>2</c:v>
+                  <c:v>2.0</c:v>
                 </c:pt>
                 <c:pt idx="3">
-                  <c:v>3</c:v>
+                  <c:v>3.0</c:v>
                 </c:pt>
                 <c:pt idx="4">
-                  <c:v>4</c:v>
+                  <c:v>4.0</c:v>
                 </c:pt>
                 <c:pt idx="5">
-                  <c:v>5</c:v>
+                  <c:v>5.0</c:v>
                 </c:pt>
                 <c:pt idx="6">
-                  <c:v>6</c:v>
+                  <c:v>6.0</c:v>
                 </c:pt>
                 <c:pt idx="7">
-                  <c:v>7</c:v>
+                  <c:v>7.0</c:v>
                 </c:pt>
                 <c:pt idx="8">
-                  <c:v>8</c:v>
+                  <c:v>8.0</c:v>
                 </c:pt>
                 <c:pt idx="9">
-                  <c:v>9</c:v>
+                  <c:v>9.0</c:v>
                 </c:pt>
                 <c:pt idx="10">
-                  <c:v>10</c:v>
+                  <c:v>10.0</c:v>
                 </c:pt>
                 <c:pt idx="11">
-                  <c:v>11</c:v>
+                  <c:v>11.0</c:v>
                 </c:pt>
                 <c:pt idx="12">
-                  <c:v>12</c:v>
+                  <c:v>12.0</c:v>
                 </c:pt>
                 <c:pt idx="13">
-                  <c:v>13</c:v>
+                  <c:v>13.0</c:v>
                 </c:pt>
                 <c:pt idx="14">
-                  <c:v>14</c:v>
+                  <c:v>14.0</c:v>
                 </c:pt>
                 <c:pt idx="15">
-                  <c:v>15</c:v>
+                  <c:v>15.0</c:v>
                 </c:pt>
                 <c:pt idx="16">
-                  <c:v>16</c:v>
+                  <c:v>16.0</c:v>
                 </c:pt>
                 <c:pt idx="17">
-                  <c:v>17</c:v>
+                  <c:v>17.0</c:v>
                 </c:pt>
                 <c:pt idx="18">
-                  <c:v>18</c:v>
+                  <c:v>18.0</c:v>
                 </c:pt>
                 <c:pt idx="19">
-                  <c:v>19</c:v>
+                  <c:v>19.0</c:v>
                 </c:pt>
                 <c:pt idx="20">
-                  <c:v>20</c:v>
+                  <c:v>20.0</c:v>
                 </c:pt>
                 <c:pt idx="21">
-                  <c:v>21</c:v>
+                  <c:v>21.0</c:v>
                 </c:pt>
                 <c:pt idx="22">
-                  <c:v>22</c:v>
+                  <c:v>22.0</c:v>
                 </c:pt>
                 <c:pt idx="23">
-                  <c:v>23</c:v>
+                  <c:v>23.0</c:v>
                 </c:pt>
                 <c:pt idx="24">
-                  <c:v>24</c:v>
+                  <c:v>24.0</c:v>
                 </c:pt>
               </c:numCache>
             </c:numRef>
@@ -2861,7 +2861,7 @@
                 <c:formatCode>General</c:formatCode>
                 <c:ptCount val="25"/>
                 <c:pt idx="0">
-                  <c:v>0</c:v>
+                  <c:v>0.0</c:v>
                 </c:pt>
                 <c:pt idx="1">
                   <c:v>0.039</c:v>
@@ -3056,7 +3056,7 @@
                 <c:formatCode>General</c:formatCode>
                 <c:ptCount val="25"/>
                 <c:pt idx="0">
-                  <c:v>0</c:v>
+                  <c:v>0.0</c:v>
                 </c:pt>
                 <c:pt idx="1">
                   <c:v>0.069</c:v>
@@ -3068,16 +3068,16 @@
                   <c:v>0.33</c:v>
                 </c:pt>
                 <c:pt idx="4">
-                  <c:v>0.67</c:v>
+                  <c:v>0.533</c:v>
                 </c:pt>
                 <c:pt idx="5">
-                  <c:v>0.974</c:v>
+                  <c:v>0.877</c:v>
                 </c:pt>
                 <c:pt idx="6">
-                  <c:v>1.166</c:v>
+                  <c:v>0.925</c:v>
                 </c:pt>
                 <c:pt idx="7">
-                  <c:v>1.578</c:v>
+                  <c:v>1.392</c:v>
                 </c:pt>
                 <c:pt idx="8">
                   <c:v>1.926</c:v>
@@ -3119,16 +3119,16 @@
                   <c:v>7.68</c:v>
                 </c:pt>
                 <c:pt idx="21">
-                  <c:v>9.172</c:v>
+                  <c:v>8.602</c:v>
                 </c:pt>
                 <c:pt idx="22">
-                  <c:v>10.682</c:v>
+                  <c:v>9.482</c:v>
                 </c:pt>
                 <c:pt idx="23">
-                  <c:v>12.683</c:v>
+                  <c:v>10.747</c:v>
                 </c:pt>
                 <c:pt idx="24">
-                  <c:v>14.714</c:v>
+                  <c:v>12.092</c:v>
                 </c:pt>
               </c:numCache>
             </c:numRef>
@@ -4478,7 +4478,7 @@
           <a:p>
             <a:r>
               <a:rPr lang="es-ES"/>
-              <a:t>Segundo bloque, el más importante. La herramienta solo puede leer lo que el cronograma contiene. Si la EDT, los costos o la línea base están mal, el informe estará mal, aunque las fórmulas sean perfectas.</a:t>
+              <a:t>Segundo bloque, el más importante. La herramienta solo puede leer lo que el cronograma contiene. Si la EDT, las duraciones, los pesos de los hitos o la línea base están mal, el informe estará mal, aunque las fórmulas sean perfectas.</a:t>
             </a:r>
           </a:p>
           <a:p/>
@@ -4661,7 +4661,7 @@
           <a:p>
             <a:r>
               <a:rPr lang="es-ES"/>
-              <a:t>- Nivel 3: el paquete de trabajo, la unidad de medición del EV. Cada paquete con un responsable, un presupuesto y un método de medición. Es la fila donde se cargan EV y AC.</a:t>
+              <a:t>- Nivel 3: el paquete de trabajo, la unidad de medición del EV. Cada paquete con un responsable, un presupuesto y un método de medición. Es la fila donde se ingresan el BAC y el AC, y donde se calcula el EV.</a:t>
             </a:r>
           </a:p>
           <a:p>
@@ -4770,7 +4770,7 @@
           <a:p>
             <a:r>
               <a:rPr lang="es-ES"/>
-              <a:t>- Peso hito (Número1): el peso de cada hito para el método de hitos ponderados.</a:t>
+              <a:t>- Peso hito (Número1): el % del BAC del paquete que vale cada hito; se usa en el % planificado y en el método de hitos ponderados.</a:t>
             </a:r>
           </a:p>
           <a:p>
@@ -4868,45 +4868,38 @@
           <a:p>
             <a:r>
               <a:rPr lang="es-ES"/>
-              <a:t>El costo de una tarea en MS Project es la suma de sus asignaciones de recursos más su costo fijo. Hay cuatro formas de cargarlo y se pueden combinar:</a:t>
+              <a:t>En el modo por defecto, el modo porcentaje, el cronograma de MS Project no lleva importes. El presupuesto se arma con tres piezas:</a:t>
             </a:r>
           </a:p>
           <a:p>
             <a:r>
               <a:rPr lang="es-ES"/>
-              <a:t>A. Recursos de trabajo: horas × tarifa. Ingeniería y personal propio. El PV sigue al trabajo planificado y el costo real sale de las horas reales. Para revisiones de tarifas, usar tablas de tasas de costo con fecha.</a:t>
+              <a:t>A. Duración de las tareas: cada tarea de detalle pesa dentro de su paquete según su duración de la línea base, repartida entre los meses que abarcan sus fechas. Por eso la duración debe reflejar el trabajo: una tarea larga de poco valor pesa más que una corta de mucho valor.</a:t>
             </a:r>
           </a:p>
           <a:p>
             <a:r>
               <a:rPr lang="es-ES"/>
-              <a:t>B. Recursos materiales: cantidad × precio. Hormigón, acero, equipos. Facilita medir por unidades.</a:t>
+              <a:t>B. Peso de los hitos: el campo Peso hito es el % del BAC del paquete que se planifica en el mes del hito; el resto se reparte entre las tareas por duración. Con pesos que suman 100, el paquete solo tiene valor en sus hitos.</a:t>
             </a:r>
           </a:p>
           <a:p>
             <a:r>
               <a:rPr lang="es-ES"/>
-              <a:t>C. Recursos de costo: un monto por partida. Subcontratos, suministros, licencias, viajes. Es la forma más directa de pasar un presupuesto existente (oferta, ERP) al cronograma; conviene un recurso de costo por cuenta del ERP.</a:t>
+              <a:t>C. BAC en el libro: el presupuesto de cada paquete se escribe en las celdas amarillas de la columna D de la hoja PV (con dos empresas, uno por empresa). El PV de cada mes es ese BAC × el % planificado. Así el cronograma se puede compartir con el cliente o entre las empresas de una unión temporal sin mostrar importes.</a:t>
             </a:r>
           </a:p>
           <a:p>
             <a:r>
               <a:rPr lang="es-ES"/>
-              <a:t>D. Costo fijo de la tarea: un monto único, sin desglose. Tasas, permisos.</a:t>
+              <a:t>D. Modo costo (opcional): si el cronograma ya tiene costos (recursos de trabajo, materiales, de costo o costo fijo), con modo = "costo" el PV sale del costo previsto escalonado de MS Project. La documentación (Presupuesto BAC) explica las cuatro formas de cargarlo.</a:t>
             </a:r>
           </a:p>
           <a:p/>
           <a:p>
             <a:r>
               <a:rPr lang="es-ES"/>
-              <a:t>Recomendación típica: proyectos de ingeniería y servicios, opción A; construcción o EPC, opción C para subcontratos y suministros más A para el personal propio.</a:t>
-            </a:r>
-          </a:p>
-          <a:p/>
-          <a:p>
-            <a:r>
-              <a:rPr lang="es-ES"/>
-              <a:t>Regla de oro: costos solo en tareas de detalle. Un costo en una tarea resumen genera una fila "-D Otros costos" y un aviso.</a:t>
+              <a:t>Regla de oro: el cronograma no lleva importes, y la duración de cada tarea debe reflejar su trabajo.</a:t>
             </a:r>
           </a:p>
         </p:txBody>
@@ -4991,39 +4984,39 @@
           <a:p>
             <a:r>
               <a:rPr lang="es-ES"/>
-              <a:t>El mismo importe puede dar curvas PV muy distintas. Ejemplo: un subcontrato de 300.000 € en una tarea de tres meses, cargado como recurso de costo o costo fijo.</a:t>
+              <a:t>El mismo importe puede dar curvas PV muy distintas. Ejemplo: un paquete de 300.000 € de tres meses.</a:t>
             </a:r>
           </a:p>
           <a:p>
             <a:r>
               <a:rPr lang="es-ES"/>
-              <a:t>- Prorrateo: 100.000 € cada mes. Es la opción recomendada para tarifas.</a:t>
+              <a:t>- Una tarea de tres meses: 100.000 € cada mes, porque su peso se reparte según su duración.</a:t>
             </a:r>
           </a:p>
           <a:p>
             <a:r>
               <a:rPr lang="es-ES"/>
-              <a:t>- Al comienzo: los 300.000 € el primer mes.</a:t>
+              <a:t>- Un hito con Peso hito 100 en el primer mes (por ejemplo, un anticipo): los 300.000 € el primer mes.</a:t>
             </a:r>
           </a:p>
           <a:p>
             <a:r>
               <a:rPr lang="es-ES"/>
-              <a:t>- Al fin: los 300.000 € el último mes.</a:t>
+              <a:t>- Un hito con Peso hito 100 al final (una entrega): los 300.000 € el último mes.</a:t>
             </a:r>
           </a:p>
           <a:p/>
           <a:p>
             <a:r>
               <a:rPr lang="es-ES"/>
-              <a:t>Dónde se configura: en la Hoja de recursos, columna Acumular, para los recursos; en la tabla Costo, columna Acumulación de costos fijos, para el costo fijo.</a:t>
+              <a:t>Para que el PV tenga la forma real se divide el paquete en tareas con sus fechas, o se combinan tareas e hitos: por ejemplo, hitos con pesos 10 y 20, y el 70 % restante repartido entre las tareas según su duración.</a:t>
             </a:r>
           </a:p>
           <a:p/>
           <a:p>
             <a:r>
               <a:rPr lang="es-ES"/>
-              <a:t>Si hay hitos de pago (anticipos, certificaciones), no hay que forzar la acumulación: se divide la partida en varias tareas o asignaciones, cada una con su fecha. Así el PV tiene la forma real del gasto previsto.</a:t>
+              <a:t>En el modo costo, lo mismo se consigue con la acumulación de los costos (prorrateo, al comienzo o al fin).</a:t>
             </a:r>
           </a:p>
         </p:txBody>
@@ -5101,7 +5094,7 @@
           <a:p>
             <a:r>
               <a:rPr lang="es-ES"/>
-              <a:t>La línea base (baseline) es una copia aprobada y congelada del plan: el alcance (las tareas de la EDT), las fechas y el costo de cada tarea. MS Project la guarda en los campos "previstos": Comienzo previsto, Fin previsto y Costo previsto, con su reparto en el tiempo.</a:t>
+              <a:t>La línea base (baseline) es una copia aprobada y congelada del plan: el alcance (las tareas de la EDT) y sus fechas y, en el modo costo, el costo de cada tarea. MS Project la guarda en los campos "previstos": Comienzo previsto, Fin previsto y, si hay costos, Costo previsto.</a:t>
             </a:r>
           </a:p>
           <a:p/>
@@ -5120,19 +5113,19 @@
           <a:p>
             <a:r>
               <a:rPr lang="es-ES"/>
-              <a:t>- El Costo previsto repartido por meses es el PV: lo que se debía haber ejecutado cada mes.</a:t>
+              <a:t>- Con esas fechas y las duraciones, el programa calcula el % planificado de cada mes; multiplicado por el BAC del libro, es el PV: lo que se debía haber ejecutado cada mes (en el modo costo, el Costo previsto repartido por meses).</a:t>
             </a:r>
           </a:p>
           <a:p>
             <a:r>
               <a:rPr lang="es-ES"/>
-              <a:t>- La suma del Costo previsto es el BAC.</a:t>
+              <a:t>- El BAC es el presupuesto de cada paquete, que se ingresa en el libro.</a:t>
             </a:r>
           </a:p>
           <a:p>
             <a:r>
               <a:rPr lang="es-ES"/>
-              <a:t>Sin línea base no hay PV ni BAC y, por tanto, tampoco SV, SPI ni EAC.</a:t>
+              <a:t>Sin línea base no hay PV y, por tanto, tampoco SV, SPI ni EAC.</a:t>
             </a:r>
           </a:p>
           <a:p/>
@@ -5230,7 +5223,7 @@
           <a:p>
             <a:r>
               <a:rPr lang="es-ES"/>
-              <a:t>1. Completar el plan: EDT con código hasta los paquetes de trabajo; lógica entre tareas (predecesoras y sucesoras), sin restricciones innecesarias; duraciones realistas; costos en tareas de detalle; método de medición de cada paquete. Un cronograma con buena lógica da un PV creíble.</a:t>
+              <a:t>1. Completar el plan: EDT con código hasta los paquetes de trabajo; lógica entre tareas (predecesoras y sucesoras), sin restricciones innecesarias; duraciones realistas; hitos con su Peso hito; método de medición de cada paquete. Un cronograma con buena lógica da un PV creíble.</a:t>
             </a:r>
           </a:p>
           <a:p>
@@ -5248,7 +5241,7 @@
           <a:p>
             <a:r>
               <a:rPr lang="es-ES"/>
-              <a:t>4. Verificar: el Costo previsto de la tarea resumen del proyecto (tabla Costo) es el BAC; la vista Uso de tareas con el detalle Costo previsto por meses es el PV. Después, ejecutar generar y revisar la hoja Validación.</a:t>
+              <a:t>4. Verificar: ejecutar generar, ingresar el BAC de cada paquete en el libro y revisar la hoja Validación y la hoja % PV (cada paquete suma 100 %). En el modo costo se compara además el BAC con el Costo previsto de MS Project.</a:t>
             </a:r>
           </a:p>
           <a:p>
@@ -5396,7 +5389,7 @@
           <a:p>
             <a:r>
               <a:rPr lang="es-ES"/>
-              <a:t>6. Generar el libro nuevo con --migrar-desde, que conserva el historial de EV y AC, y registrar en el informe la fecha, el motivo y la variación del BAC.</a:t>
+              <a:t>6. Generar el libro nuevo con --migrar-desde, que conserva el BAC ingresado y el historial de EV y AC, escribir el BAC nuevo de los paquetes afectados y registrar en el informe la fecha, el motivo y la variación del BAC.</a:t>
             </a:r>
           </a:p>
           <a:p/>
@@ -5494,7 +5487,7 @@
           <a:p>
             <a:r>
               <a:rPr lang="es-ES"/>
-              <a:t>- Izquierda, línea base fija: el EV queda 4,5 millones por debajo del PV; SPI 0,69. El atraso se ve y se puede gestionar.</a:t>
+              <a:t>- Izquierda, línea base fija: el EV queda 1,9 millones por debajo del PV; SPI 0,84. El atraso se ve y se puede gestionar.</a:t>
             </a:r>
           </a:p>
           <a:p>
@@ -5616,7 +5609,7 @@
           <a:p>
             <a:r>
               <a:rPr lang="es-ES"/>
-              <a:t>Izquierda: lo que normalmente se hace a mano en Excel cada mes. Derecha: lo que hace el Exportador EVM. Lee el cronograma de MS Project (el archivo .mpp o un XML) y produce un libro Excel con el PV mensual de cada elemento de la EDT, el EV y el AC de cada paquete, los indicadores y los gráficos, todo con fórmulas de Excel.</a:t>
+              <a:t>Izquierda: lo que normalmente se hace a mano en Excel cada mes. Derecha: lo que hace el Exportador EVM. Lee el cronograma de MS Project (el archivo .mpp o un XML), que no necesita importes, y produce un libro Excel con el % planificado y el % ganado de cada elemento de la EDT. Con el BAC que se ingresa en el libro se obtienen el PV y el EV; con el AC del mes, los indicadores y los gráficos, todo con fórmulas de Excel.</a:t>
             </a:r>
           </a:p>
           <a:p/>
@@ -5708,7 +5701,7 @@
           <a:p>
             <a:r>
               <a:rPr lang="es-ES"/>
-              <a:t>Estos son los errores que más se repiten al preparar un proyecto. Todos se detectan en la hoja Validación del libro, así que no hay que buscarlos a mano: basta con leer los avisos después de "generar".</a:t>
+              <a:t>Estos son los errores que más se repiten al preparar un proyecto. Todos se detectan en la hoja Validación del libro o al actualizar, así que no hay que buscarlos a mano: basta con leer los avisos.</a:t>
             </a:r>
           </a:p>
           <a:p/>
@@ -5721,20 +5714,20 @@
           <a:p>
             <a:r>
               <a:rPr lang="es-ES"/>
-              <a:t>- Costos en tareas resumen: muy habitual cuando se pone un costo fijo de gestión en la tarea resumen. Solución: crear una tarea de detalle "Gestión del paquete".</a:t>
+              <a:t>- La duración pesa: el PV de un paquete se reparte según la duración de sus tareas. Una tarea larga de poco valor (por ejemplo, una gestión de doce meses) se lleva gran parte del paquete: conviene separarla en su propio paquete o usar hitos con peso.</a:t>
             </a:r>
           </a:p>
           <a:p>
             <a:r>
               <a:rPr lang="es-ES"/>
-              <a:t>- Tareas agregadas después de guardar la línea base: no tienen costo previsto, así que no aportan PV ni BAC. Si el cambio está aprobado, guardar la línea base solo de esas tareas.</a:t>
+              <a:t>- El BAC sin ingresar: después de generar hay que escribir el BAC de cada paquete; si falta, el PV y el EV quedan en 0 y actualizar lo avisa.</a:t>
             </a:r>
           </a:p>
           <a:p/>
           <a:p>
             <a:r>
               <a:rPr lang="es-ES"/>
-              <a:t>Otro caso: los "recursos presupuestarios" de MS Project no sirven para el BAC; sus montos no forman parte del costo de las tareas.</a:t>
+              <a:t>En el modo costo los errores típicos son otros (costos en tareas resumen, costo previsto escrito a mano, línea base sin resumir): están en la documentación, Presupuesto (BAC).</a:t>
             </a:r>
           </a:p>
         </p:txBody>
@@ -5819,7 +5812,7 @@
           <a:p>
             <a:r>
               <a:rPr lang="es-ES"/>
-              <a:t>El ejemplo (franja superior, de la documentación): un paquete con un BAC de 900.000 € que comenzó y no terminó. Tiene tres subtareas: la memoria de cálculo (300.000 €) terminada, los planos (400.000 €) a la mitad y las especificaciones (200.000 €) sin empezar. Además tiene tres hitos con pesos 30, 30 y 40, de los que dos están cumplidos.</a:t>
+              <a:t>El ejemplo (franja superior, de la documentación): un paquete con un BAC de 900.000 € que comenzó y no terminó. Tiene tres subtareas: la memoria de cálculo (30 días) terminada, los planos (40 días) a la mitad y las especificaciones (20 días) sin empezar. Además tiene tres hitos con pesos 30, 30 y 40, de los que dos están cumplidos.</a:t>
             </a:r>
           </a:p>
           <a:p/>
@@ -5850,7 +5843,7 @@
           <a:p>
             <a:r>
               <a:rPr lang="es-ES"/>
-              <a:t>- % Completado: se suma lo hecho de cada subtarea según su presupuesto: 300.000 al 100 % (300.000) + 400.000 al 50 % (200.000) + 200.000 al 0 % (0) = 500.000 €, el 55,6 % del BAC.</a:t>
+              <a:t>- % Completado: cada subtarea pesa según su duración: (30 días al 100 % + 40 al 50 % + 20 al 0 %) / 90 días = 55,6 % del BAC = 500.000 €. En el modo costo se pondera por el presupuesto de cada subtarea.</a:t>
             </a:r>
           </a:p>
           <a:p>
@@ -6004,7 +5997,7 @@
           <a:p>
             <a:r>
               <a:rPr lang="es-ES"/>
-              <a:t>- CPTR de MS Project: cuando la organización ya gestiona el valor acumulado en MS Project y quiere que el libro coincida con sus tablas.</a:t>
+              <a:t>- CPTR de MS Project (solo en el modo costo): cuando la organización ya gestiona el valor acumulado en MS Project y quiere que el libro coincida con sus tablas.</a:t>
             </a:r>
           </a:p>
           <a:p/>
@@ -6115,13 +6108,13 @@
           <a:p>
             <a:r>
               <a:rPr lang="es-ES"/>
-              <a:t>- El presupuesto se carga en las actividades, no en los hitos.</a:t>
+              <a:t>- En el modo costo, el presupuesto se carga en las actividades, no en los hitos.</a:t>
             </a:r>
           </a:p>
           <a:p>
             <a:r>
               <a:rPr lang="es-ES"/>
-              <a:t>- El peso va en el campo Peso hito; conviene que sumen 100 y que sean proporcionales al trabajo.</a:t>
+              <a:t>- El peso va en el campo Peso hito y es el % del BAC del paquete: en un paquete medido solo con hitos, los pesos suman 100 y su PV queda en los meses de los hitos.</a:t>
             </a:r>
           </a:p>
           <a:p>
@@ -6236,7 +6229,7 @@
           <a:p>
             <a:r>
               <a:rPr lang="es-ES"/>
-              <a:t>3. Costo real: por defecto MS Project lo calcula con el trabajo real y las tarifas. Si el costo real viene del ERP, hay dos opciones: escribirlo en MS Project (desmarcando "Los costos reales siempre se calculan por Project") o, más simple, cargarlo en la hoja AC del libro y ejecutar "actualizar --solo ev".</a:t>
+              <a:t>3. Costo real: se toma del ERP (devengado, con la misma fecha de corte y en la misma base que el BAC) y se carga en la hoja AC del libro, o en las de cada empresa. En el modo costo también lo puede calcular MS Project.</a:t>
             </a:r>
           </a:p>
           <a:p>
@@ -6408,12 +6401,12 @@
           </a:p>
           <a:p>
             <a:r>
-              <a:t>- generar: se ejecuta una vez por línea base. Lee la EDT y la línea base de MS Project y crea el libro Excel con el PV mensual de cada elemento de la EDT (120 meses por defecto) y el BAC.</a:t>
-            </a:r>
-          </a:p>
-          <a:p>
-            <a:r>
-              <a:t>- actualizar: se ejecuta cada mes. Lee el avance a la fecha de estado, calcula el EV y el AC acumulados de cada paquete según su método y escribe el valor del mes en el libro. Indicadores y gráficos se recalculan solos.</a:t>
+              <a:t>- generar: se ejecuta una vez por línea base. Lee la EDT y la línea base de MS Project y crea el libro Excel con el % planificado de cada elemento de la EDT y mes (120 meses por defecto). Después se escribe el BAC de cada paquete en el libro: el PV es el BAC × el %.</a:t>
+            </a:r>
+          </a:p>
+          <a:p>
+            <a:r>
+              <a:t>- actualizar: se ejecuta cada mes. Lee el avance a la fecha de estado, calcula el % ganado acumulado de cada paquete según su método y escribe el % del mes en el libro; el EV es el BAC × el %. El AC del mes se carga a mano. Indicadores y gráficos se recalculan solos.</a:t>
             </a:r>
           </a:p>
           <a:p/>
@@ -6431,7 +6424,7 @@
           <a:p/>
           <a:p>
             <a:r>
-              <a:t>Opcional: modo multi-empresa, con el PV, EV y AC de dos empresas por separado, y varios archivos de MS Project en un mismo libro (secciones [[proyectos]] de la configuración).</a:t>
+              <a:t>Opcional: modo multi-empresa, con el BAC, el PV, el EV y el AC de dos empresas por separado, y varios archivos de MS Project en un mismo libro (secciones [[proyectos]] de la configuración).</a:t>
             </a:r>
           </a:p>
           <a:p/>
@@ -6515,7 +6508,7 @@
           <a:p>
             <a:r>
               <a:rPr lang="es-ES"/>
-              <a:t>Se ejecuta una vez, después de guardar la línea base. La salida en pantalla resume lo leído: planificación, filas de la EDT, horizonte de meses y BAC total, más observaciones informativas.</a:t>
+              <a:t>Se ejecuta una vez, después de guardar la línea base. La salida en pantalla resume lo leído: planificación, filas de la EDT, horizonte de meses y el recordatorio de ingresar el BAC, más observaciones informativas.</a:t>
             </a:r>
           </a:p>
           <a:p/>
@@ -6529,19 +6522,19 @@
           <a:p>
             <a:r>
               <a:rPr lang="es-ES"/>
-              <a:t>Después de generar, tres comprobaciones (derecha):</a:t>
+              <a:t>Después de generar, tres pasos (derecha):</a:t>
             </a:r>
           </a:p>
           <a:p>
             <a:r>
               <a:rPr lang="es-ES"/>
-              <a:t>1. El BAC total del libro coincide con el Costo previsto de la tarea resumen en la tabla Costo de MS Project.</a:t>
+              <a:t>1. Ingresar el BAC de cada paquete en las celdas amarillas de la columna D de la hoja PV (con dos empresas, en la hoja de cada una); la fila TOTAL debe coincidir con el presupuesto aprobado.</a:t>
             </a:r>
           </a:p>
           <a:p>
             <a:r>
               <a:rPr lang="es-ES"/>
-              <a:t>2. El PV de algunos meses coincide con la vista Uso de tareas (detalle Costo previsto, escala en meses).</a:t>
+              <a:t>2. Revisar la hoja % PV: cada paquete suma 100 %, repartido según la duración de sus tareas y el peso de sus hitos.</a:t>
             </a:r>
           </a:p>
           <a:p>
@@ -6640,12 +6633,12 @@
           </a:p>
           <a:p>
             <a:r>
-              <a:t>2. Revisar las observaciones por fila: métodos no definidos, valores del mes negativos (por ejemplo, una corrección de avance), tareas con costo sin fila, diferencias de AC con MS Project. Si algo no es razonable, se corrige en MS Project y se vuelve a simular.</a:t>
-            </a:r>
-          </a:p>
-          <a:p>
-            <a:r>
-              <a:t>3. "actualizar" sin --simular: escribe el valor del mes en las hojas EV y AC. Si el AC viene del ERP, se usa "--solo ev" y el AC se carga a mano en la hoja AC. actualizar también agrega a la hoja Análisis de desviaciones los paquetes fuera de umbral; si el AC se carga a mano después, el comando "analizar" completa esa lista sin volver a leer MS Project.</a:t>
+              <a:t>2. Revisar las observaciones por fila: métodos no definidos, valores del mes negativos (por ejemplo, una corrección de avance), tareas sin fila, filas con avance y sin BAC. Si algo no es razonable, se corrige en MS Project y se vuelve a simular.</a:t>
+            </a:r>
+          </a:p>
+          <a:p>
+            <a:r>
+              <a:t>3. "actualizar" sin --simular: escribe el % ganado del mes en la hoja % EV (el EV es el BAC × ese %). El AC del mes se carga a mano en la hoja AC. actualizar también agrega a la hoja Análisis de desviaciones los paquetes fuera de umbral; si el AC se carga a mano después, el comando "analizar" completa esa lista sin volver a leer MS Project.</a:t>
             </a:r>
           </a:p>
           <a:p/>
@@ -6743,7 +6736,7 @@
           </a:p>
           <a:p>
             <a:r>
-              <a:t>- Ámbar: datos. PV lo crea generar; en EV y AC, las celdas amarillas contienen el valor de cada mes (no el acumulado) y las completa actualizar, o se cargan a mano, por ejemplo el AC del ERP.</a:t>
+              <a:t>- Ámbar: datos. En PV se ingresa el BAC de cada paquete (celdas amarillas); el PV y el EV de cada mes son el BAC × el % de las hojas % PV y % EV, que calculan generar y actualizar. En AC, las celdas amarillas contienen el costo real de cada mes (no el acumulado), que se carga a mano desde el ERP.</a:t>
             </a:r>
           </a:p>
           <a:p>
@@ -7145,7 +7138,7 @@
           </a:p>
           <a:p>
             <a:r>
-              <a:t>- 3.0.0 Construcción (CPI 0,54, SPI 0,50) es el que arrastra al proyecto: hay que bajar a sus paquetes en la hoja Indicadores EDT.</a:t>
+              <a:t>- 3.0.0 Construcción (CPI 0,54, SPI 0,85) es el que arrastra el costo del proyecto: hay que bajar a sus paquetes en la hoja Indicadores EDT. En plazo, el más alejado es 1.2.0 Gestión de contratos (SPI 0,51): las licitaciones no terminaron.</a:t>
             </a:r>
           </a:p>
           <a:p>
@@ -7155,7 +7148,7 @@
           </a:p>
           <a:p>
             <a:r>
-              <a:t>- 3.2.0 Montaje aparece en el límite del gráfico porque su suministro de equipos se mide con hitos ponderados y todavía no cumplió ningún hito: tiene costo real pero EV cero. Es el comportamiento esperado del método, no un error. El valor exacto está en la tabla.</a:t>
+              <a:t>- 3.2.0 Montaje no aparece en el gráfico: su suministro de equipos se mide con hitos ponderados (pesos que suman 100), su PV está en los meses de los hitos, en 2028, y todavía no cumplió ninguno: tiene costo real pero PV y EV cero. Es el comportamiento esperado del método, no un error. Los valores están en la tabla.</a:t>
             </a:r>
           </a:p>
           <a:p/>
@@ -7364,7 +7357,7 @@
           </a:p>
           <a:p>
             <a:r>
-              <a:t>- D+4: actualizar --simular, revisión de observaciones, actualizar y carga del AC si viene del ERP (seguida de analizar).</a:t>
+              <a:t>- D+4: actualizar --simular, revisión de observaciones, actualizar, carga del AC del ERP en el libro y analizar.</a:t>
             </a:r>
           </a:p>
           <a:p>
@@ -7466,7 +7459,7 @@
           </a:p>
           <a:p>
             <a:r>
-              <a:t>2. Costos solo en tareas de detalle, dentro de la EDT exportada.</a:t>
+              <a:t>2. El cronograma no lleva importes: las duraciones y los pesos de los hitos reparten el BAC, que se ingresa en el libro.</a:t>
             </a:r>
           </a:p>
           <a:p>
@@ -7574,7 +7567,7 @@
           </a:p>
           <a:p>
             <a:r>
-              <a:t>- Qué lista: cada mes, actualizar agrega los paquetes con SPI o CPI fuera del rango verde del semáforo, por debajo (atraso, sobrecosto) o por encima (por ejemplo, el CPI 1,11 de la PMO, con puestos sin cubrir). Los valores son fórmulas sobre las hojas PV, EV y AC.</a:t>
+              <a:t>- Qué lista: cada mes, actualizar agrega los paquetes con SPI o CPI fuera del rango verde del semáforo, por debajo (atraso, sobrecosto) o por encima (por ejemplo, el CPI 1,10 de la PMO, con puestos sin cubrir). Los valores son fórmulas sobre las hojas PV, EV y AC.</a:t>
             </a:r>
           </a:p>
           <a:p>
@@ -7930,7 +7923,7 @@
           <a:p>
             <a:r>
               <a:rPr lang="es-ES"/>
-              <a:t>Nota para MS Project en español: el PV se llama CPTP, el EV se llama CPTR ("valor acumulado") y el AC se llama CRTR. El BAC es el Costo previsto de la línea base.</a:t>
+              <a:t>Nota para MS Project en español: el PV se llama CPTP, el EV se llama CPTR ("valor acumulado") y el AC se llama CRTR. El BAC se ingresa en el libro Excel (en el modo costo, es el Costo previsto de la línea base).</a:t>
             </a:r>
           </a:p>
         </p:txBody>
@@ -8256,7 +8249,7 @@
           <a:p>
             <a:r>
               <a:rPr lang="es-ES"/>
-              <a:t>En el ejemplo, el EAC va de 47,5 a 78,5 millones frente a un BAC de 44,2. El TCPI de 1,11 dice que, para terminar dentro del BAC, el trabajo restante debería hacerse con una eficiencia del 111 %, cuando la histórica es del 76 %: el BAC ya no es realista.</a:t>
+              <a:t>En el ejemplo, el EAC va de 47,5 a 66,9 millones frente a un BAC de 44,2. El TCPI de 1,11 dice que, para terminar dentro del BAC, el trabajo restante debería hacerse con una eficiencia del 111 %, cuando la histórica es del 76 %: el BAC ya no es realista.</a:t>
             </a:r>
           </a:p>
           <a:p/>
@@ -8362,14 +8355,14 @@
           <a:p>
             <a:r>
               <a:rPr lang="es-ES"/>
-              <a:t>Cómo se lee el gráfico: a diciembre de 2027 (mes 24, AT = Actual Time) llevamos ganados 10,19 M€. El plan preveía alcanzar ese valor en el mes 21,67 (ES). Vamos 2,33 meses tarde: SV(t) = ES − AT = −2,33 meses, y SPI(t) = ES / AT = 0,90.</a:t>
+              <a:t>Cómo se lee el gráfico: a diciembre de 2027 (mes 24, AT = Actual Time) llevamos ganados 10,19 M€. El plan preveía alcanzar ese valor en el mes 22,56 (ES). Vamos 1,44 meses tarde: SV(t) = ES − AT = −1,44 meses, y SPI(t) = ES / AT = 0,94.</a:t>
             </a:r>
           </a:p>
           <a:p/>
           <a:p>
             <a:r>
               <a:rPr lang="es-ES"/>
-              <a:t>Con una duración planificada de 58 meses, la duración estimada es 58 / 0,90 ≈ 64 meses. Es un dato que la dirección entiende inmediatamente.</a:t>
+              <a:t>Con una duración planificada de 58 meses, la duración estimada es 58 / 0,94 ≈ 62 meses. Es un dato que la dirección entiende inmediatamente.</a:t>
             </a:r>
           </a:p>
         </p:txBody>
@@ -11570,7 +11563,7 @@
                 </a:solidFill>
                 <a:latin typeface="Calibri"/>
               </a:rPr>
-              <a:t>Versión 1.5.1</a:t>
+              <a:t>Versión 2.0.0</a:t>
             </a:r>
             <a:r>
               <a:rPr sz="1400" b="0" i="0" lang="es-ES">
@@ -11782,175 +11775,175 @@
                   <a:pt x="0" y="3189132"/>
                 </a:moveTo>
                 <a:lnTo>
-                  <a:pt x="68580" y="3184141"/>
+                  <a:pt x="68580" y="3184155"/>
                 </a:lnTo>
                 <a:lnTo>
-                  <a:pt x="137160" y="3178824"/>
+                  <a:pt x="137160" y="3178817"/>
                 </a:lnTo>
                 <a:lnTo>
-                  <a:pt x="205740" y="3165362"/>
+                  <a:pt x="205740" y="3165327"/>
                 </a:lnTo>
                 <a:lnTo>
-                  <a:pt x="274320" y="3140782"/>
+                  <a:pt x="274320" y="3150684"/>
                 </a:lnTo>
                 <a:lnTo>
-                  <a:pt x="342900" y="3118868"/>
+                  <a:pt x="342900" y="3125869"/>
                 </a:lnTo>
                 <a:lnTo>
-                  <a:pt x="411479" y="3105046"/>
+                  <a:pt x="411480" y="3122406"/>
                 </a:lnTo>
                 <a:lnTo>
-                  <a:pt x="480060" y="3075274"/>
+                  <a:pt x="480060" y="3088719"/>
                 </a:lnTo>
                 <a:lnTo>
-                  <a:pt x="548640" y="3050226"/>
+                  <a:pt x="548640" y="3050198"/>
                 </a:lnTo>
                 <a:lnTo>
-                  <a:pt x="617220" y="3025677"/>
+                  <a:pt x="617220" y="3025672"/>
                 </a:lnTo>
                 <a:lnTo>
-                  <a:pt x="685800" y="3000610"/>
+                  <a:pt x="685800" y="3000641"/>
                 </a:lnTo>
                 <a:lnTo>
-                  <a:pt x="754379" y="2976136"/>
+                  <a:pt x="754380" y="2976114"/>
                 </a:lnTo>
                 <a:lnTo>
-                  <a:pt x="822960" y="2949232"/>
+                  <a:pt x="822960" y="2949208"/>
                 </a:lnTo>
                 <a:lnTo>
-                  <a:pt x="891540" y="2923326"/>
+                  <a:pt x="891540" y="2923311"/>
                 </a:lnTo>
                 <a:lnTo>
-                  <a:pt x="960120" y="2900957"/>
+                  <a:pt x="960120" y="2900949"/>
                 </a:lnTo>
                 <a:lnTo>
-                  <a:pt x="1028700" y="2866558"/>
+                  <a:pt x="1028700" y="2866540"/>
                 </a:lnTo>
                 <a:lnTo>
-                  <a:pt x="1097279" y="2831787"/>
+                  <a:pt x="1097280" y="2831770"/>
                 </a:lnTo>
                 <a:lnTo>
-                  <a:pt x="1165860" y="2798596"/>
+                  <a:pt x="1165860" y="2798588"/>
                 </a:lnTo>
                 <a:lnTo>
-                  <a:pt x="1234440" y="2763825"/>
+                  <a:pt x="1234440" y="2763818"/>
                 </a:lnTo>
                 <a:lnTo>
-                  <a:pt x="1303020" y="2701641"/>
+                  <a:pt x="1303020" y="2701637"/>
                 </a:lnTo>
                 <a:lnTo>
-                  <a:pt x="1371600" y="2635130"/>
+                  <a:pt x="1371600" y="2635128"/>
                 </a:lnTo>
                 <a:lnTo>
-                  <a:pt x="1440180" y="2527501"/>
+                  <a:pt x="1440180" y="2568618"/>
                 </a:lnTo>
                 <a:lnTo>
-                  <a:pt x="1508760" y="2418568"/>
+                  <a:pt x="1508760" y="2505139"/>
                 </a:lnTo>
                 <a:lnTo>
-                  <a:pt x="1577340" y="2274241"/>
+                  <a:pt x="1577340" y="2413887"/>
                 </a:lnTo>
                 <a:lnTo>
-                  <a:pt x="1645920" y="2127721"/>
+                  <a:pt x="1645920" y="2316864"/>
                 </a:lnTo>
                 <a:lnTo>
-                  <a:pt x="1714500" y="1997412"/>
+                  <a:pt x="1714500" y="2226838"/>
                 </a:lnTo>
                 <a:lnTo>
-                  <a:pt x="1783080" y="1894809"/>
+                  <a:pt x="1783080" y="2169634"/>
                 </a:lnTo>
                 <a:lnTo>
-                  <a:pt x="1851660" y="1799948"/>
+                  <a:pt x="1851660" y="2124549"/>
                 </a:lnTo>
                 <a:lnTo>
-                  <a:pt x="1920240" y="1717460"/>
+                  <a:pt x="1920240" y="2085379"/>
                 </a:lnTo>
                 <a:lnTo>
-                  <a:pt x="1988820" y="1586963"/>
+                  <a:pt x="1988820" y="2004659"/>
                 </a:lnTo>
                 <a:lnTo>
-                  <a:pt x="2057400" y="1463080"/>
+                  <a:pt x="2057400" y="1721165"/>
                 </a:lnTo>
                 <a:lnTo>
-                  <a:pt x="2125980" y="1348442"/>
+                  <a:pt x="2125980" y="1640589"/>
                 </a:lnTo>
                 <a:lnTo>
-                  <a:pt x="2194560" y="1253725"/>
+                  <a:pt x="2194560" y="1253723"/>
                 </a:lnTo>
                 <a:lnTo>
-                  <a:pt x="2263140" y="1181116"/>
+                  <a:pt x="2263140" y="1181083"/>
                 </a:lnTo>
                 <a:lnTo>
-                  <a:pt x="2331720" y="1111309"/>
+                  <a:pt x="2331720" y="1111327"/>
                 </a:lnTo>
                 <a:lnTo>
-                  <a:pt x="2400300" y="1022747"/>
+                  <a:pt x="2400300" y="1022744"/>
                 </a:lnTo>
                 <a:lnTo>
-                  <a:pt x="2468880" y="936419"/>
+                  <a:pt x="2468880" y="936397"/>
                 </a:lnTo>
                 <a:lnTo>
-                  <a:pt x="2537460" y="841870"/>
+                  <a:pt x="2537460" y="841899"/>
                 </a:lnTo>
                 <a:lnTo>
-                  <a:pt x="2606040" y="759654"/>
+                  <a:pt x="2606040" y="759664"/>
                 </a:lnTo>
                 <a:lnTo>
-                  <a:pt x="2674620" y="669216"/>
+                  <a:pt x="2674620" y="669206"/>
                 </a:lnTo>
                 <a:lnTo>
-                  <a:pt x="2743200" y="582888"/>
+                  <a:pt x="2743200" y="582859"/>
                 </a:lnTo>
                 <a:lnTo>
-                  <a:pt x="2811780" y="488339"/>
+                  <a:pt x="2811780" y="488361"/>
                 </a:lnTo>
                 <a:lnTo>
-                  <a:pt x="2880360" y="403888"/>
+                  <a:pt x="2880360" y="403889"/>
                 </a:lnTo>
                 <a:lnTo>
-                  <a:pt x="2948940" y="354711"/>
+                  <a:pt x="2948940" y="354693"/>
                 </a:lnTo>
                 <a:lnTo>
-                  <a:pt x="3017520" y="303300"/>
+                  <a:pt x="3017520" y="303332"/>
                 </a:lnTo>
                 <a:lnTo>
-                  <a:pt x="3086100" y="258594"/>
+                  <a:pt x="3086100" y="258608"/>
                 </a:lnTo>
                 <a:lnTo>
-                  <a:pt x="3154680" y="217032"/>
+                  <a:pt x="3154680" y="217057"/>
                 </a:lnTo>
                 <a:lnTo>
-                  <a:pt x="3223260" y="175035"/>
+                  <a:pt x="3223260" y="175002"/>
                 </a:lnTo>
                 <a:lnTo>
-                  <a:pt x="3291840" y="139167"/>
+                  <a:pt x="3291840" y="139150"/>
                 </a:lnTo>
                 <a:lnTo>
-                  <a:pt x="3360420" y="113343"/>
+                  <a:pt x="3360420" y="113326"/>
                 </a:lnTo>
                 <a:lnTo>
-                  <a:pt x="3429000" y="89110"/>
+                  <a:pt x="3429000" y="89088"/>
                 </a:lnTo>
                 <a:lnTo>
-                  <a:pt x="3497580" y="56572"/>
+                  <a:pt x="3497580" y="56555"/>
                 </a:lnTo>
                 <a:lnTo>
-                  <a:pt x="3566160" y="41818"/>
+                  <a:pt x="3566160" y="41839"/>
                 </a:lnTo>
                 <a:lnTo>
-                  <a:pt x="3634740" y="24711"/>
+                  <a:pt x="3634740" y="24743"/>
                 </a:lnTo>
                 <a:lnTo>
-                  <a:pt x="3703320" y="17310"/>
+                  <a:pt x="3703320" y="17313"/>
                 </a:lnTo>
                 <a:lnTo>
-                  <a:pt x="3771900" y="9339"/>
+                  <a:pt x="3771900" y="9306"/>
                 </a:lnTo>
                 <a:lnTo>
-                  <a:pt x="3840480" y="5166"/>
+                  <a:pt x="3840480" y="5194"/>
                 </a:lnTo>
                 <a:lnTo>
-                  <a:pt x="3909060" y="1979"/>
+                  <a:pt x="3909060" y="1948"/>
                 </a:lnTo>
                 <a:lnTo>
                   <a:pt x="3977640" y="0"/>
@@ -13261,7 +13254,7 @@
                 </a:solidFill>
                 <a:latin typeface="Calibri"/>
               </a:rPr>
-              <a:t>Costos en tareas de detalle</a:t>
+              <a:t>Duraciones y pesos realistas</a:t>
             </a:r>
             <a:endParaRPr lang="es-ES" sz="1600"/>
           </a:p>
@@ -13297,7 +13290,7 @@
                 </a:solidFill>
                 <a:latin typeface="Calibri"/>
               </a:rPr>
-              <a:t>Nunca en tareas resumen</a:t>
+              <a:t>La duración pesa; los hitos, con Peso hito</a:t>
             </a:r>
             <a:endParaRPr lang="es-ES" sz="1400"/>
           </a:p>
@@ -13885,7 +13878,7 @@
                 </a:solidFill>
                 <a:latin typeface="Calibri"/>
               </a:rPr>
-              <a:t> del libro Excel, con la tarea afectada y su costo.</a:t>
+              <a:t> del libro Excel, con la tarea afectada.</a:t>
             </a:r>
             <a:endParaRPr lang="es-ES" sz="1500"/>
           </a:p>
@@ -15873,7 +15866,7 @@
                 </a:solidFill>
                 <a:latin typeface="Calibri"/>
               </a:rPr>
-              <a:t>Peso de cada hito del paquete</a:t>
+              <a:t>% del BAC del paquete en el mes del hito</a:t>
             </a:r>
             <a:endParaRPr lang="es-ES" sz="1300"/>
           </a:p>
@@ -16099,7 +16092,7 @@
                 </a:solidFill>
                 <a:latin typeface="Calibri"/>
               </a:rPr>
-              <a:t>Cuatro formas de cargar el presupuesto</a:t>
+              <a:t>El presupuesto: BAC en el libro, % desde MS Project</a:t>
             </a:r>
             <a:endParaRPr lang="es-ES" sz="3200"/>
           </a:p>
@@ -16135,7 +16128,7 @@
                 </a:solidFill>
                 <a:latin typeface="Calibri"/>
               </a:rPr>
-              <a:t>MS PROJECT · COSTOS</a:t>
+              <a:t>MS PROJECT · PRESUPUESTO</a:t>
             </a:r>
             <a:endParaRPr lang="es-ES" sz="1100"/>
           </a:p>
@@ -16317,7 +16310,7 @@
                 </a:solidFill>
                 <a:latin typeface="Calibri"/>
               </a:rPr>
-              <a:t>Recursos de trabajo</a:t>
+              <a:t>Duración de las tareas</a:t>
             </a:r>
             <a:endParaRPr lang="es-ES" sz="1900"/>
           </a:p>
@@ -16357,7 +16350,7 @@
                 </a:solidFill>
                 <a:latin typeface="Calibri"/>
               </a:rPr>
-              <a:t>Monto: </a:t>
+              <a:t>Peso: </a:t>
             </a:r>
             <a:r>
               <a:rPr sz="1400" b="0" i="0" lang="es-ES">
@@ -16366,7 +16359,7 @@
                 </a:solidFill>
                 <a:latin typeface="Calibri"/>
               </a:rPr>
-              <a:t>Horas × tarifa</a:t>
+              <a:t>Duración de la línea base</a:t>
             </a:r>
             <a:endParaRPr lang="es-ES" sz="1400"/>
           </a:p>
@@ -16392,7 +16385,7 @@
                 </a:solidFill>
                 <a:latin typeface="Calibri"/>
               </a:rPr>
-              <a:t>Sigue al trabajo planificado</a:t>
+              <a:t>Sigue a las fechas de cada tarea</a:t>
             </a:r>
             <a:endParaRPr lang="es-ES" sz="1400"/>
           </a:p>
@@ -16418,7 +16411,7 @@
                 </a:solidFill>
                 <a:latin typeface="Calibri"/>
               </a:rPr>
-              <a:t>Ingeniería, servicios, personal propio</a:t>
+              <a:t>Todas las tareas de detalle</a:t>
             </a:r>
             <a:endParaRPr lang="es-ES" sz="1400"/>
           </a:p>
@@ -16528,7 +16521,7 @@
                 </a:solidFill>
                 <a:latin typeface="Calibri"/>
               </a:rPr>
-              <a:t>Recursos materiales</a:t>
+              <a:t>Peso de los hitos</a:t>
             </a:r>
             <a:endParaRPr lang="es-ES" sz="1900"/>
           </a:p>
@@ -16568,7 +16561,7 @@
                 </a:solidFill>
                 <a:latin typeface="Calibri"/>
               </a:rPr>
-              <a:t>Monto: </a:t>
+              <a:t>Peso: </a:t>
             </a:r>
             <a:r>
               <a:rPr sz="1400" b="0" i="0" lang="es-ES">
@@ -16577,7 +16570,7 @@
                 </a:solidFill>
                 <a:latin typeface="Calibri"/>
               </a:rPr>
-              <a:t>Cantidad × precio</a:t>
+              <a:t>Peso hito = % del BAC</a:t>
             </a:r>
             <a:endParaRPr lang="es-ES" sz="1400"/>
           </a:p>
@@ -16603,7 +16596,7 @@
                 </a:solidFill>
                 <a:latin typeface="Calibri"/>
               </a:rPr>
-              <a:t>Sigue a la cantidad planificada</a:t>
+              <a:t>Entero en el mes del hito</a:t>
             </a:r>
             <a:endParaRPr lang="es-ES" sz="1400"/>
           </a:p>
@@ -16629,7 +16622,7 @@
                 </a:solidFill>
                 <a:latin typeface="Calibri"/>
               </a:rPr>
-              <a:t>Consumibles medidos en unidades</a:t>
+              <a:t>Entregas, pruebas, certificaciones</a:t>
             </a:r>
             <a:endParaRPr lang="es-ES" sz="1400"/>
           </a:p>
@@ -16739,7 +16732,7 @@
                 </a:solidFill>
                 <a:latin typeface="Calibri"/>
               </a:rPr>
-              <a:t>Recursos de costo</a:t>
+              <a:t>BAC en el libro</a:t>
             </a:r>
             <a:endParaRPr lang="es-ES" sz="1900"/>
           </a:p>
@@ -16788,7 +16781,7 @@
                 </a:solidFill>
                 <a:latin typeface="Calibri"/>
               </a:rPr>
-              <a:t>Monto por asignación</a:t>
+              <a:t>Presupuesto de cada paquete</a:t>
             </a:r>
             <a:endParaRPr lang="es-ES" sz="1400"/>
           </a:p>
@@ -16805,7 +16798,7 @@
                 </a:solidFill>
                 <a:latin typeface="Calibri"/>
               </a:rPr>
-              <a:t>Curva PV: </a:t>
+              <a:t>Dónde: </a:t>
             </a:r>
             <a:r>
               <a:rPr sz="1400" b="0" i="0" lang="es-ES">
@@ -16814,7 +16807,7 @@
                 </a:solidFill>
                 <a:latin typeface="Calibri"/>
               </a:rPr>
-              <a:t>Prorrateo, al comienzo o al fin</a:t>
+              <a:t>Columna D de la hoja PV</a:t>
             </a:r>
             <a:endParaRPr lang="es-ES" sz="1400"/>
           </a:p>
@@ -16831,7 +16824,7 @@
                 </a:solidFill>
                 <a:latin typeface="Calibri"/>
               </a:rPr>
-              <a:t>Para: </a:t>
+              <a:t>Dos empresas: </a:t>
             </a:r>
             <a:r>
               <a:rPr sz="1400" b="0" i="0" lang="es-ES">
@@ -16840,7 +16833,7 @@
                 </a:solidFill>
                 <a:latin typeface="Calibri"/>
               </a:rPr>
-              <a:t>Subcontratos, suministros, gastos</a:t>
+              <a:t>Un BAC por empresa</a:t>
             </a:r>
             <a:endParaRPr lang="es-ES" sz="1400"/>
           </a:p>
@@ -16950,7 +16943,7 @@
                 </a:solidFill>
                 <a:latin typeface="Calibri"/>
               </a:rPr>
-              <a:t>Costo fijo de la tarea</a:t>
+              <a:t>Modo costo (opcional)</a:t>
             </a:r>
             <a:endParaRPr lang="es-ES" sz="1900"/>
           </a:p>
@@ -16999,7 +16992,7 @@
                 </a:solidFill>
                 <a:latin typeface="Calibri"/>
               </a:rPr>
-              <a:t>Monto por tarea</a:t>
+              <a:t>Costos cargados en MS Project</a:t>
             </a:r>
             <a:endParaRPr lang="es-ES" sz="1400"/>
           </a:p>
@@ -17025,7 +17018,7 @@
                 </a:solidFill>
                 <a:latin typeface="Calibri"/>
               </a:rPr>
-              <a:t>Prorrateo, al comienzo o al fin</a:t>
+              <a:t>Costo previsto escalonado</a:t>
             </a:r>
             <a:endParaRPr lang="es-ES" sz="1400"/>
           </a:p>
@@ -17042,7 +17035,7 @@
                 </a:solidFill>
                 <a:latin typeface="Calibri"/>
               </a:rPr>
-              <a:t>Para: </a:t>
+              <a:t>Cómo: </a:t>
             </a:r>
             <a:r>
               <a:rPr sz="1400" b="0" i="0" lang="es-ES">
@@ -17051,7 +17044,7 @@
                 </a:solidFill>
                 <a:latin typeface="Calibri"/>
               </a:rPr>
-              <a:t>Montos puntuales sin desglose</a:t>
+              <a:t>Recursos y costo fijo</a:t>
             </a:r>
             <a:endParaRPr lang="es-ES" sz="1400"/>
           </a:p>
@@ -17094,7 +17087,7 @@
                 </a:solidFill>
                 <a:latin typeface="Calibri"/>
               </a:rPr>
-              <a:t>Regla de oro: </a:t>
+              <a:t>Regla de oro: el cronograma no lleva importes; la duración de cada tarea debe reflejar su trabajo</a:t>
             </a:r>
             <a:r>
               <a:rPr sz="1600" b="0" i="0" lang="es-ES">
@@ -17103,7 +17096,7 @@
                 </a:solidFill>
                 <a:latin typeface="Calibri"/>
               </a:rPr>
-              <a:t>costos solo en tareas de detalle, nunca en tareas resumen</a:t>
+              <a:t/>
             </a:r>
             <a:endParaRPr lang="es-ES" sz="1600"/>
           </a:p>
@@ -17165,7 +17158,7 @@
                 </a:solidFill>
                 <a:latin typeface="Calibri"/>
               </a:rPr>
-              <a:t>La acumulación decide la forma de la curva PV</a:t>
+              <a:t>La duración y los hitos deciden la forma de la curva PV</a:t>
             </a:r>
             <a:endParaRPr lang="es-ES" sz="3200"/>
           </a:p>
@@ -17201,7 +17194,7 @@
                 </a:solidFill>
                 <a:latin typeface="Calibri"/>
               </a:rPr>
-              <a:t>MS PROJECT · COSTOS</a:t>
+              <a:t>MS PROJECT · PRESUPUESTO</a:t>
             </a:r>
             <a:endParaRPr lang="es-ES" sz="1100"/>
           </a:p>
@@ -17309,7 +17302,7 @@
                 </a:solidFill>
                 <a:latin typeface="Calibri"/>
               </a:rPr>
-              <a:t>Ejemplo: </a:t>
+              <a:t>Ejemplo: paquete de 300.000 € y 3 meses (miles de euros por mes)</a:t>
             </a:r>
             <a:r>
               <a:rPr sz="1600" b="0" i="0" lang="es-ES">
@@ -17318,7 +17311,7 @@
                 </a:solidFill>
                 <a:latin typeface="Calibri"/>
               </a:rPr>
-              <a:t>subcontrato de 300.000 € en una tarea de 3 meses (miles de euros por mes)</a:t>
+              <a:t/>
             </a:r>
             <a:endParaRPr lang="es-ES" sz="1600"/>
           </a:p>
@@ -17389,7 +17382,7 @@
                 </a:solidFill>
                 <a:latin typeface="Calibri"/>
               </a:rPr>
-              <a:t>Prorrateo</a:t>
+              <a:t>Una tarea de 3 meses</a:t>
             </a:r>
             <a:endParaRPr lang="es-ES" sz="1900"/>
           </a:p>
@@ -17425,7 +17418,7 @@
                 </a:solidFill>
                 <a:latin typeface="Calibri"/>
               </a:rPr>
-              <a:t>Recomendado para tarifas</a:t>
+              <a:t>Peso por duración</a:t>
             </a:r>
             <a:endParaRPr lang="es-ES" sz="1300"/>
           </a:p>
@@ -17514,7 +17507,7 @@
                 </a:solidFill>
                 <a:latin typeface="Calibri"/>
               </a:rPr>
-              <a:t>Al comienzo</a:t>
+              <a:t>Hito al comienzo</a:t>
             </a:r>
             <a:endParaRPr lang="es-ES" sz="1900"/>
           </a:p>
@@ -17550,7 +17543,7 @@
                 </a:solidFill>
                 <a:latin typeface="Calibri"/>
               </a:rPr>
-              <a:t>Todo el primer mes</a:t>
+              <a:t>Peso hito 100 en el mes 1</a:t>
             </a:r>
             <a:endParaRPr lang="es-ES" sz="1300"/>
           </a:p>
@@ -17639,7 +17632,7 @@
                 </a:solidFill>
                 <a:latin typeface="Calibri"/>
               </a:rPr>
-              <a:t>Al fin</a:t>
+              <a:t>Hito al final</a:t>
             </a:r>
             <a:endParaRPr lang="es-ES" sz="1900"/>
           </a:p>
@@ -17675,7 +17668,7 @@
                 </a:solidFill>
                 <a:latin typeface="Calibri"/>
               </a:rPr>
-              <a:t>Todo el último mes</a:t>
+              <a:t>Peso hito 100 en el mes 3</a:t>
             </a:r>
             <a:endParaRPr lang="es-ES" sz="1300"/>
           </a:p>
@@ -17736,7 +17729,7 @@
                 </a:solidFill>
                 <a:latin typeface="Calibri"/>
               </a:rPr>
-              <a:t>Hitos de pago (anticipos, certificaciones): </a:t>
+              <a:t>Para la forma real: dividir el paquete en tareas con sus fechas o usar hitos con peso (anticipos, entregas, certificaciones).</a:t>
             </a:r>
             <a:r>
               <a:rPr sz="1500" b="0" i="0" lang="es-ES">
@@ -17745,7 +17738,7 @@
                 </a:solidFill>
                 <a:latin typeface="Calibri"/>
               </a:rPr>
-              <a:t>dividir la partida en tareas o asignaciones con su propia fecha.</a:t>
+              <a:t/>
             </a:r>
             <a:endParaRPr lang="es-ES" sz="1500"/>
           </a:p>
@@ -19030,7 +19023,7 @@
                 </a:solidFill>
                 <a:latin typeface="Calibri"/>
               </a:rPr>
-              <a:t>Costo previsto por mes</a:t>
+              <a:t>% planificado × BAC</a:t>
             </a:r>
             <a:endParaRPr lang="es-ES" sz="1300"/>
           </a:p>
@@ -19131,7 +19124,7 @@
                 </a:solidFill>
                 <a:latin typeface="Calibri"/>
               </a:rPr>
-              <a:t>Costo previsto total</a:t>
+              <a:t>BAC ingresado en el libro</a:t>
             </a:r>
             <a:endParaRPr lang="es-ES" sz="1300"/>
           </a:p>
@@ -19253,7 +19246,7 @@
                 </a:solidFill>
                 <a:latin typeface="Calibri"/>
               </a:rPr>
-              <a:t>Una copia aprobada y congelada del plan: tareas de la EDT, fechas y costo de cada tarea.</a:t>
+              <a:t>Una copia aprobada y congelada del plan: tareas de la EDT y sus fechas (en el modo costo, también su costo).</a:t>
             </a:r>
             <a:endParaRPr lang="es-ES" sz="1400"/>
           </a:p>
@@ -19275,7 +19268,7 @@
                 </a:solidFill>
                 <a:latin typeface="Calibri"/>
               </a:rPr>
-              <a:t>Comienzo, Fin y Costo previstos</a:t>
+              <a:t>Comienzo y Fin previstos</a:t>
             </a:r>
             <a:r>
               <a:rPr sz="1400" b="0" i="0" lang="es-ES">
@@ -19284,7 +19277,7 @@
                 </a:solidFill>
                 <a:latin typeface="Calibri"/>
               </a:rPr>
-              <a:t>.</a:t>
+              <a:t> (y Costo previsto).</a:t>
             </a:r>
             <a:endParaRPr lang="es-ES" sz="1400"/>
           </a:p>
@@ -19353,7 +19346,7 @@
                 </a:solidFill>
                 <a:latin typeface="Calibri"/>
               </a:rPr>
-              <a:t>Es la referencia para medir: sin ella no hay PV, BAC, SV ni SPI</a:t>
+              <a:t>Es la referencia para medir: sin ella no hay PV, SV ni SPI</a:t>
             </a:r>
             <a:endParaRPr lang="es-ES" sz="1400"/>
           </a:p>
@@ -19677,7 +19670,7 @@
                 </a:solidFill>
                 <a:latin typeface="Calibri"/>
               </a:rPr>
-              <a:t>EDT con código, lógica entre tareas, duraciones realistas, costos en tareas de detalle y método por paquete</a:t>
+              <a:t>EDT con código, lógica entre tareas, duraciones realistas, hitos con peso y método por paquete</a:t>
             </a:r>
             <a:endParaRPr lang="es-ES" sz="1300"/>
           </a:p>
@@ -20016,7 +20009,7 @@
                 </a:solidFill>
                 <a:latin typeface="Calibri"/>
               </a:rPr>
-              <a:t>BAC en la tabla Costo y PV en Uso de tareas; después, generar</a:t>
+              <a:t>generar, ingresar el BAC y revisar la hoja % PV</a:t>
             </a:r>
             <a:endParaRPr lang="es-ES" sz="1300"/>
           </a:p>
@@ -21420,7 +21413,7 @@
                 </a:solidFill>
                 <a:latin typeface="Calibri"/>
               </a:rPr>
-              <a:t>Modificar tareas, duraciones o costos</a:t>
+              <a:t>Modificar tareas, duraciones o pesos de hitos</a:t>
             </a:r>
             <a:endParaRPr lang="es-ES" sz="1400"/>
           </a:p>
@@ -21905,7 +21898,7 @@
                 </a:solidFill>
                 <a:latin typeface="Calibri"/>
               </a:rPr>
-              <a:t>SV = −4,5 M€ · SPI 0,69: el atraso se ve</a:t>
+              <a:t>SV = −1,9 M€ · SPI 0,84: el atraso se ve</a:t>
             </a:r>
             <a:endParaRPr lang="es-ES" sz="1400"/>
           </a:p>
@@ -22787,7 +22780,7 @@
                 </a:solidFill>
                 <a:latin typeface="Calibri"/>
               </a:rPr>
-              <a:t>PV mensual leído de la línea base de MS Project</a:t>
+              <a:t>% planificado y % ganado de MS Project × BAC del libro</a:t>
             </a:r>
             <a:endParaRPr lang="es-ES" sz="1600"/>
           </a:p>
@@ -22850,7 +22843,7 @@
                 </a:solidFill>
                 <a:latin typeface="Calibri"/>
               </a:rPr>
-              <a:t>Validaciones automáticas de la EDT y los costos</a:t>
+              <a:t>Validaciones automáticas de la EDT, la línea base y los pesos</a:t>
             </a:r>
             <a:endParaRPr lang="es-ES" sz="1600"/>
           </a:p>
@@ -23000,7 +22993,7 @@
                 </a:solidFill>
                 <a:latin typeface="Calibri"/>
               </a:rPr>
-              <a:t>Errores frecuentes en costos y línea base</a:t>
+              <a:t>Errores frecuentes al preparar el cronograma</a:t>
             </a:r>
             <a:endParaRPr lang="es-ES" sz="3200"/>
           </a:p>
@@ -23036,7 +23029,7 @@
                 </a:solidFill>
                 <a:latin typeface="Calibri"/>
               </a:rPr>
-              <a:t>MS PROJECT · COSTOS</a:t>
+              <a:t>MS PROJECT · PRESUPUESTO</a:t>
             </a:r>
             <a:endParaRPr lang="es-ES" sz="1100"/>
           </a:p>
@@ -23326,7 +23319,7 @@
                 </a:solidFill>
                 <a:latin typeface="Calibri"/>
               </a:rPr>
-              <a:t>Costos en tareas resumen</a:t>
+              <a:t>Hitos con pesos que suman más de 100</a:t>
             </a:r>
             <a:endParaRPr lang="es-ES" sz="1400"/>
           </a:p>
@@ -23362,7 +23355,7 @@
                 </a:solidFill>
                 <a:latin typeface="Calibri"/>
               </a:rPr>
-              <a:t>Fila «-D Otros costos» y aviso</a:t>
+              <a:t>Se escalan a 100 %; las tareas quedan sin PV</a:t>
             </a:r>
             <a:endParaRPr lang="es-ES" sz="1400"/>
           </a:p>
@@ -23439,7 +23432,7 @@
                 </a:solidFill>
                 <a:latin typeface="Calibri"/>
               </a:rPr>
-              <a:t>Moverlos a una tarea de detalle</a:t>
+              <a:t>Revisar los pesos: que sumen 100 o menos</a:t>
             </a:r>
             <a:endParaRPr lang="es-ES" sz="1400"/>
           </a:p>
@@ -23551,7 +23544,7 @@
                 </a:solidFill>
                 <a:latin typeface="Calibri"/>
               </a:rPr>
-              <a:t>Tareas con costo agregadas después de la línea base</a:t>
+              <a:t>Tareas agregadas después de la línea base</a:t>
             </a:r>
             <a:endParaRPr lang="es-ES" sz="1400"/>
           </a:p>
@@ -23587,7 +23580,7 @@
                 </a:solidFill>
                 <a:latin typeface="Calibri"/>
               </a:rPr>
-              <a:t>Sin PV ni BAC</a:t>
+              <a:t>Se usan sus fechas actuales (aviso)</a:t>
             </a:r>
             <a:endParaRPr lang="es-ES" sz="1400"/>
           </a:p>
@@ -23774,7 +23767,7 @@
                 </a:solidFill>
                 <a:latin typeface="Calibri"/>
               </a:rPr>
-              <a:t>Costo previsto escrito a mano</a:t>
+              <a:t>Tareas largas de poco valor</a:t>
             </a:r>
             <a:endParaRPr lang="es-ES" sz="1400"/>
           </a:p>
@@ -23810,7 +23803,7 @@
                 </a:solidFill>
                 <a:latin typeface="Calibri"/>
               </a:rPr>
-              <a:t>Sin distribución mensual: reparto lineal</a:t>
+              <a:t>La curva PV pesa la duración, no el valor</a:t>
             </a:r>
             <a:endParaRPr lang="es-ES" sz="1400"/>
           </a:p>
@@ -23887,7 +23880,7 @@
                 </a:solidFill>
                 <a:latin typeface="Calibri"/>
               </a:rPr>
-              <a:t>Cargar el costo en la tarea y guardar la línea base</a:t>
+              <a:t>Dividir el paquete o usar hitos con peso</a:t>
             </a:r>
             <a:endParaRPr lang="es-ES" sz="1400"/>
           </a:p>
@@ -23999,7 +23992,7 @@
                 </a:solidFill>
                 <a:latin typeface="Calibri"/>
               </a:rPr>
-              <a:t>Línea base sin resumir</a:t>
+              <a:t>BAC sin ingresar en el libro</a:t>
             </a:r>
             <a:endParaRPr lang="es-ES" sz="1400"/>
           </a:p>
@@ -24035,7 +24028,7 @@
                 </a:solidFill>
                 <a:latin typeface="Calibri"/>
               </a:rPr>
-              <a:t>La tarea resumen no suma sus subtareas</a:t>
+              <a:t>PV y EV en 0; actualizar avisa</a:t>
             </a:r>
             <a:endParaRPr lang="es-ES" sz="1400"/>
           </a:p>
@@ -24112,7 +24105,7 @@
                 </a:solidFill>
                 <a:latin typeface="Calibri"/>
               </a:rPr>
-              <a:t>Guardar con «Para todas las tareas de resumen»</a:t>
+              <a:t>Ingresarlo en la columna D (celdas amarillas)</a:t>
             </a:r>
             <a:endParaRPr lang="es-ES" sz="1400"/>
           </a:p>
@@ -24222,7 +24215,7 @@
                 </a:solidFill>
                 <a:latin typeface="Calibri"/>
               </a:rPr>
-              <a:t>Tareas con costo sin código EDT ni elemento superior</a:t>
+              <a:t>Tareas sin código EDT ni elemento superior</a:t>
             </a:r>
             <a:endParaRPr lang="es-ES" sz="1400"/>
           </a:p>
@@ -24258,7 +24251,7 @@
                 </a:solidFill>
                 <a:latin typeface="Calibri"/>
               </a:rPr>
-              <a:t>Se omiten (aviso con su costo)</a:t>
+              <a:t>Se omiten (aviso)</a:t>
             </a:r>
             <a:endParaRPr lang="es-ES" sz="1400"/>
           </a:p>
@@ -24695,7 +24688,7 @@
                 </a:solidFill>
                 <a:latin typeface="Calibri"/>
               </a:rPr>
-              <a:t>300.000 €</a:t>
+              <a:t>30 días  ·  100 % hecho</a:t>
             </a:r>
             <a:r>
               <a:rPr sz="1300" b="1" i="0" lang="es-ES">
@@ -24704,7 +24697,7 @@
                 </a:solidFill>
                 <a:latin typeface="Calibri"/>
               </a:rPr>
-              <a:t>  ·  100 % hecho</a:t>
+              <a:t/>
             </a:r>
             <a:endParaRPr lang="es-ES" sz="1300"/>
           </a:p>
@@ -24840,7 +24833,7 @@
                 </a:solidFill>
                 <a:latin typeface="Calibri"/>
               </a:rPr>
-              <a:t>400.000 €</a:t>
+              <a:t>40 días  ·  50 % hecho</a:t>
             </a:r>
             <a:r>
               <a:rPr sz="1300" b="1" i="0" lang="es-ES">
@@ -24849,7 +24842,7 @@
                 </a:solidFill>
                 <a:latin typeface="Calibri"/>
               </a:rPr>
-              <a:t>  ·  50 % hecho</a:t>
+              <a:t/>
             </a:r>
             <a:endParaRPr lang="es-ES" sz="1300"/>
           </a:p>
@@ -24985,7 +24978,7 @@
                 </a:solidFill>
                 <a:latin typeface="Calibri"/>
               </a:rPr>
-              <a:t>200.000 €</a:t>
+              <a:t>20 días  ·  0 % hecho</a:t>
             </a:r>
             <a:r>
               <a:rPr sz="1300" b="1" i="0" lang="es-ES">
@@ -24994,7 +24987,7 @@
                 </a:solidFill>
                 <a:latin typeface="Calibri"/>
               </a:rPr>
-              <a:t>  ·  0 % hecho</a:t>
+              <a:t/>
             </a:r>
             <a:endParaRPr lang="es-ES" sz="1300"/>
           </a:p>
@@ -25822,7 +25815,7 @@
                 </a:solidFill>
                 <a:latin typeface="Calibri"/>
               </a:rPr>
-              <a:t>300.000 × 100 % + 400.000 × 50 % + 200.000 × 0 %</a:t>
+              <a:t>(30 × 100 % + 40 × 50 % + 20 × 0 %) / 90 × 900.000</a:t>
             </a:r>
             <a:endParaRPr lang="es-ES" sz="1400"/>
           </a:p>
@@ -31376,7 +31369,7 @@
                 </a:solidFill>
                 <a:latin typeface="Calibri"/>
               </a:rPr>
-              <a:t>Calculado por MS Project o del ERP (en MS Project, o en el libro con actualizar --solo ev)</a:t>
+              <a:t>Del ERP de cada empresa: se carga en la hoja AC del libro</a:t>
             </a:r>
             <a:endParaRPr lang="es-ES" sz="1400"/>
           </a:p>
@@ -32195,7 +32188,7 @@
                 </a:solidFill>
                 <a:latin typeface="Calibri"/>
               </a:rPr>
-              <a:t>EDT y costos</a:t>
+              <a:t>EDT y pesos de hitos</a:t>
             </a:r>
             <a:endParaRPr lang="es-ES" sz="1400"/>
           </a:p>
@@ -32214,7 +32207,7 @@
                 </a:solidFill>
                 <a:latin typeface="Calibri"/>
               </a:rPr>
-              <a:t>Línea base</a:t>
+              <a:t>Línea base (fechas)</a:t>
             </a:r>
             <a:endParaRPr lang="es-ES" sz="1400"/>
           </a:p>
@@ -32233,7 +32226,7 @@
                 </a:solidFill>
                 <a:latin typeface="Calibri"/>
               </a:rPr>
-              <a:t>Avance y costo real</a:t>
+              <a:t>Avance</a:t>
             </a:r>
             <a:endParaRPr lang="es-ES" sz="1400"/>
           </a:p>
@@ -32368,7 +32361,7 @@
                 </a:solidFill>
                 <a:latin typeface="Calibri"/>
               </a:rPr>
-              <a:t>una vez por línea base  ·  PV mensual y BAC</a:t>
+              <a:t>una vez por línea base  ·  % planificado</a:t>
             </a:r>
             <a:endParaRPr lang="es-ES" sz="1300"/>
           </a:p>
@@ -32440,7 +32433,7 @@
                 </a:solidFill>
                 <a:latin typeface="Calibri"/>
               </a:rPr>
-              <a:t>cada mes  ·  EV y AC del mes y desviaciones</a:t>
+              <a:t>cada mes  ·  % ganado del mes y desviaciones</a:t>
             </a:r>
             <a:endParaRPr lang="es-ES" sz="1300"/>
           </a:p>
@@ -32958,7 +32951,7 @@
                 </a:solidFill>
                 <a:latin typeface="Consolas"/>
               </a:rPr>
-              <a:t>config.toml</a:t>
+              <a:t>config.toml indica el modo (porcentaje o costo), los campos (Item EDT, Método EVM, Peso hito), la planificación, el semáforo y, si hay varios, los archivos de MS Project</a:t>
             </a:r>
             <a:r>
               <a:rPr sz="1400" b="0" i="0" lang="es-ES">
@@ -32967,7 +32960,7 @@
                 </a:solidFill>
                 <a:latin typeface="Calibri"/>
               </a:rPr>
-              <a:t> indica los campos (Item EDT, Método EVM, Peso hito), la planificación, el semáforo y, si hay varios, los archivos de MS Project</a:t>
+              <a:t/>
             </a:r>
             <a:endParaRPr lang="es-ES" sz="1400"/>
           </a:p>
@@ -33029,7 +33022,7 @@
                 </a:solidFill>
                 <a:latin typeface="Calibri"/>
               </a:rPr>
-              <a:t>Generar: el libro con el PV y el BAC</a:t>
+              <a:t>Generar: el libro con el % planificado</a:t>
             </a:r>
             <a:endParaRPr lang="es-ES" sz="3200"/>
           </a:p>
@@ -33312,7 +33305,24 @@
                 </a:solidFill>
                 <a:latin typeface="Consolas"/>
               </a:rPr>
-              <a:t>  BAC total: 44,210,000.00</a:t>
+              <a:t>  Modo porcentaje: se debe ingresar el BAC de</a:t>
+            </a:r>
+            <a:endParaRPr lang="es-ES" sz="1200"/>
+          </a:p>
+          <a:p>
+            <a:pPr algn="l">
+              <a:spcAft>
+                <a:spcPts val="100"/>
+              </a:spcAft>
+            </a:pPr>
+            <a:r>
+              <a:rPr sz="1200" b="0" i="0" lang="es-ES">
+                <a:solidFill>
+                  <a:srgbClr val="9BD48A"/>
+                </a:solidFill>
+                <a:latin typeface="Consolas"/>
+              </a:rPr>
+              <a:t>      cada fila en la columna D de PV</a:t>
             </a:r>
             <a:endParaRPr lang="es-ES" sz="1200"/>
           </a:p>
@@ -33709,7 +33719,7 @@
                 </a:solidFill>
                 <a:latin typeface="Calibri"/>
               </a:rPr>
-              <a:t>BAC total </a:t>
+              <a:t>Ingresar el BAC de cada paquete (columna D de PV)</a:t>
             </a:r>
             <a:r>
               <a:rPr sz="1400" b="0" i="0" lang="es-ES">
@@ -33718,7 +33728,7 @@
                 </a:solidFill>
                 <a:latin typeface="Calibri"/>
               </a:rPr>
-              <a:t>= Costo previsto del proyecto (tabla Costo)</a:t>
+              <a:t/>
             </a:r>
             <a:endParaRPr lang="es-ES" sz="1400"/>
           </a:p>
@@ -33795,7 +33805,7 @@
                 </a:solidFill>
                 <a:latin typeface="Calibri"/>
               </a:rPr>
-              <a:t>PV de algunos meses </a:t>
+              <a:t>Hoja % PV: cada paquete suma 100 %</a:t>
             </a:r>
             <a:r>
               <a:rPr sz="1400" b="0" i="0" lang="es-ES">
@@ -33804,7 +33814,7 @@
                 </a:solidFill>
                 <a:latin typeface="Calibri"/>
               </a:rPr>
-              <a:t>= vista Uso de tareas, detalle Costo previsto</a:t>
+              <a:t/>
             </a:r>
             <a:endParaRPr lang="es-ES" sz="1400"/>
           </a:p>
@@ -34084,7 +34094,7 @@
                 </a:solidFill>
                 <a:latin typeface="Calibri"/>
               </a:rPr>
-              <a:t>Tareas con costo pero sin línea base: no aportan PV</a:t>
+              <a:t>Tareas sin fechas de línea base: se usan las actuales</a:t>
             </a:r>
             <a:endParaRPr lang="es-ES" sz="1200"/>
           </a:p>
@@ -34163,7 +34173,7 @@
                 </a:solidFill>
                 <a:latin typeface="Calibri"/>
               </a:rPr>
-              <a:t>Tarea resumen con costo propio: fila «-D Otros costos»</a:t>
+              <a:t>Pesos de hitos que suman más de 100: se escalan</a:t>
             </a:r>
             <a:endParaRPr lang="es-ES" sz="1200"/>
           </a:p>
@@ -34225,7 +34235,7 @@
                 </a:solidFill>
                 <a:latin typeface="Calibri"/>
               </a:rPr>
-              <a:t>Actualizar: EV y AC del mes</a:t>
+              <a:t>Actualizar: % ganado y EV del mes</a:t>
             </a:r>
             <a:endParaRPr lang="es-ES" sz="3200"/>
           </a:p>
@@ -34653,7 +34663,7 @@
                 </a:solidFill>
                 <a:latin typeface="Calibri"/>
               </a:rPr>
-              <a:t>Métodos sin definir, valores del mes negativos, tareas sin fila, diferencias de AC</a:t>
+              <a:t>Métodos sin definir, valores del mes negativos, tareas sin fila, filas sin BAC</a:t>
             </a:r>
             <a:endParaRPr lang="es-ES" sz="1300"/>
           </a:p>
@@ -34788,7 +34798,7 @@
                 </a:solidFill>
                 <a:latin typeface="Consolas"/>
               </a:rPr>
-              <a:t>actualizar  [--solo ev]</a:t>
+              <a:t>actualizar</a:t>
             </a:r>
             <a:endParaRPr lang="es-ES" sz="1300"/>
           </a:p>
@@ -34824,7 +34834,7 @@
                 </a:solidFill>
                 <a:latin typeface="Calibri"/>
               </a:rPr>
-              <a:t>Escribe EV y AC del mes y lista las desviaciones. Si el AC viene del ERP, se carga después y se ejecuta analizar</a:t>
+              <a:t>Escribe el % ganado del mes y lista las desviaciones. Luego se carga el AC del ERP y se ejecuta analizar</a:t>
             </a:r>
             <a:endParaRPr lang="es-ES" sz="1300"/>
           </a:p>
@@ -35016,7 +35026,7 @@
                 </a:solidFill>
                 <a:latin typeface="Consolas"/>
               </a:rPr>
-              <a:t>PV acumulado     14,714,032   % planificado 33.3 %</a:t>
+              <a:t>PV acumulado     12,092,032   % planificado 27.4 %</a:t>
             </a:r>
             <a:endParaRPr lang="es-ES" sz="1200"/>
           </a:p>
@@ -35067,7 +35077,7 @@
                 </a:solidFill>
                 <a:latin typeface="Consolas"/>
               </a:rPr>
-              <a:t>SV = EV - PV     -4,523,492   SPI = 0.69</a:t>
+              <a:t>SV = EV - PV     -1,901,492   SPI = 0.84</a:t>
             </a:r>
             <a:endParaRPr lang="es-ES" sz="1200"/>
           </a:p>
@@ -35658,7 +35668,7 @@
                 </a:solidFill>
                 <a:latin typeface="Calibri"/>
               </a:rPr>
-              <a:t>EDT, costos, línea base, métodos de medición y avance</a:t>
+              <a:t>EDT, presupuesto, línea base, métodos de medición y avance</a:t>
             </a:r>
             <a:endParaRPr lang="es-ES" sz="1400"/>
           </a:p>
@@ -37113,7 +37123,7 @@
                 </a:solidFill>
                 <a:latin typeface="Calibri"/>
               </a:rPr>
-              <a:t>Datos: PV, y EV y AC del mes</a:t>
+              <a:t>Datos: BAC y AC a mano; % PV y % EV</a:t>
             </a:r>
             <a:endParaRPr lang="es-ES" sz="1300"/>
           </a:p>
@@ -37324,7 +37334,7 @@
                 </a:solidFill>
                 <a:latin typeface="Calibri"/>
               </a:rPr>
-              <a:t>Celdas amarillas = valor del mes</a:t>
+              <a:t>Celdas amarillas = BAC y AC del mes</a:t>
             </a:r>
             <a:endParaRPr lang="es-ES" sz="1400"/>
           </a:p>
@@ -37427,7 +37437,7 @@
                 </a:solidFill>
                 <a:latin typeface="Calibri"/>
               </a:rPr>
-              <a:t>filas o columnas en PV, EV y AC</a:t>
+              <a:t>filas o columnas en las hojas de datos</a:t>
             </a:r>
             <a:endParaRPr lang="es-ES" sz="1400"/>
           </a:p>
@@ -38303,7 +38313,7 @@
           <p:nvPr/>
         </p:nvPicPr>
         <p:blipFill>
-          <a:blip r:embed="rId2"/>
+          <a:blip r:embed="rId4"/>
           <a:stretch>
             <a:fillRect/>
           </a:stretch>
@@ -39498,7 +39508,7 @@
           <p:nvPr/>
         </p:nvPicPr>
         <p:blipFill>
-          <a:blip r:embed="rId2"/>
+          <a:blip r:embed="rId4"/>
           <a:stretch>
             <a:fillRect/>
           </a:stretch>
@@ -39647,7 +39657,7 @@
                 </a:solidFill>
                 <a:latin typeface="Calibri"/>
               </a:rPr>
-              <a:t>CPI 0,54 · SPI 0,50</a:t>
+              <a:t>CPI 0,54 · SPI 0,85</a:t>
             </a:r>
             <a:endParaRPr lang="es-ES" sz="1400"/>
           </a:p>
@@ -39660,7 +39670,7 @@
                 </a:solidFill>
                 <a:latin typeface="Calibri"/>
               </a:rPr>
-              <a:t>Explica la desviación: bajar a sus paquetes en Indicadores EDT.</a:t>
+              <a:t>Explica el sobrecosto: bajar a sus paquetes en Indicadores EDT.</a:t>
             </a:r>
             <a:endParaRPr lang="es-ES" sz="1400"/>
           </a:p>
@@ -39801,7 +39811,7 @@
                 </a:solidFill>
                 <a:latin typeface="Calibri"/>
               </a:rPr>
-              <a:t>en el límite (0,5; 0,5)</a:t>
+              <a:t>sin punto en el gráfico</a:t>
             </a:r>
             <a:endParaRPr lang="es-ES" sz="1400"/>
           </a:p>
@@ -39814,7 +39824,7 @@
                 </a:solidFill>
                 <a:latin typeface="Calibri"/>
               </a:rPr>
-              <a:t>Hitos ponderados sin hitos cumplidos todavía: esperado del método.</a:t>
+              <a:t>Su PV está en los meses de sus hitos (2028): SPI sin valor y CPI 0.</a:t>
             </a:r>
             <a:endParaRPr lang="es-ES" sz="1400"/>
           </a:p>
@@ -41600,7 +41610,7 @@
           <p:nvPr/>
         </p:nvPicPr>
         <p:blipFill>
-          <a:blip r:embed="rId2"/>
+          <a:blip r:embed="rId4"/>
           <a:stretch>
             <a:fillRect/>
           </a:stretch>
@@ -42444,7 +42454,7 @@
                 </a:solidFill>
                 <a:latin typeface="Calibri"/>
               </a:rPr>
-              <a:t>actualizar --simular, revisión y actualizar</a:t>
+              <a:t>actualizar, carga del AC y analizar</a:t>
             </a:r>
             <a:endParaRPr lang="es-ES" sz="1400"/>
           </a:p>
@@ -43221,7 +43231,7 @@
                 </a:solidFill>
                 <a:latin typeface="Calibri"/>
               </a:rPr>
-              <a:t>Costos solo en tareas de detalle, dentro de la EDT exportada</a:t>
+              <a:t>Cronograma sin importes: duraciones y pesos de hitos; el BAC, en el libro</a:t>
             </a:r>
             <a:endParaRPr lang="es-ES" sz="1600"/>
           </a:p>
@@ -45326,7 +45336,7 @@
                 </a:solidFill>
                 <a:latin typeface="Calibri"/>
               </a:rPr>
-              <a:t>Budget at Completion: suma del PV de todos los meses (Costo previsto en MS Project)</a:t>
+              <a:t>Budget at Completion: suma del PV de todos los meses (se ingresa en el libro Excel)</a:t>
             </a:r>
             <a:endParaRPr lang="es-ES" sz="1400"/>
           </a:p>
@@ -45663,7 +45673,7 @@
                 </a:solidFill>
                 <a:latin typeface="Calibri"/>
               </a:rPr>
-              <a:t>14,7 M€</a:t>
+              <a:t>12,1 M€</a:t>
             </a:r>
             <a:endParaRPr lang="es-ES" sz="2600"/>
           </a:p>
@@ -45699,7 +45709,7 @@
                 </a:solidFill>
                 <a:latin typeface="Calibri"/>
               </a:rPr>
-              <a:t>33 % planificado</a:t>
+              <a:t>27 % planificado</a:t>
             </a:r>
             <a:endParaRPr lang="es-ES" sz="1300"/>
           </a:p>
@@ -46316,7 +46326,7 @@
                 </a:solidFill>
                 <a:latin typeface="Calibri"/>
               </a:rPr>
-              <a:t>−4,52 M€</a:t>
+              <a:t>−1,90 M€</a:t>
             </a:r>
             <a:endParaRPr lang="es-ES" sz="3000"/>
           </a:p>
@@ -46674,7 +46684,7 @@
                 </a:solidFill>
                 <a:latin typeface="Calibri"/>
               </a:rPr>
-              <a:t>0,69</a:t>
+              <a:t>0,84</a:t>
             </a:r>
             <a:endParaRPr lang="es-ES" sz="3000"/>
           </a:p>
@@ -46710,7 +46720,7 @@
                 </a:solidFill>
                 <a:latin typeface="Calibri"/>
               </a:rPr>
-              <a:t>Se ganaron 0,69 € por cada euro planificado</a:t>
+              <a:t>Se ganaron 0,84 € por cada euro planificado</a:t>
             </a:r>
             <a:endParaRPr lang="es-ES" sz="1300"/>
           </a:p>
@@ -48442,7 +48452,7 @@
                 </a:solidFill>
                 <a:latin typeface="Calibri"/>
               </a:rPr>
-              <a:t>ES = 21,67</a:t>
+              <a:t>ES = 22,56</a:t>
             </a:r>
             <a:endParaRPr lang="es-ES" sz="1500"/>
           </a:p>
@@ -48514,7 +48524,7 @@
                 </a:solidFill>
                 <a:latin typeface="Calibri"/>
               </a:rPr>
-              <a:t>−2,33 meses</a:t>
+              <a:t>−1,44 meses</a:t>
             </a:r>
             <a:endParaRPr lang="es-ES" sz="2600"/>
           </a:p>
@@ -48586,7 +48596,7 @@
                 </a:solidFill>
                 <a:latin typeface="Calibri"/>
               </a:rPr>
-              <a:t>0,90</a:t>
+              <a:t>0,94</a:t>
             </a:r>
             <a:endParaRPr lang="es-ES" sz="2600"/>
           </a:p>
@@ -48658,7 +48668,7 @@
                 </a:solidFill>
                 <a:latin typeface="Calibri"/>
               </a:rPr>
-              <a:t>58 / 0,90 ≈ 64 meses</a:t>
+              <a:t>58 / 0,94 ≈ 62 meses</a:t>
             </a:r>
             <a:endParaRPr lang="es-ES" sz="2600"/>
           </a:p>

</xml_diff>

<commit_message>
Presentación: textos que caben en cada diapositiva y ejemplos de multi-empresa generales
- Diapositiva 2: viñetas más cortas (la última quedaba tapada por el recuadro inferior).
- Diapositivas 14, 15, 21 y 28: se restaura el formato de las etiquetas en negrita.
- Diapositivas 13, 16, 25, 27 y 37: textos más cortos o con el formato original.
- PDF exportado de nuevo.
- Multi-empresa, modo porcentaje y README: ejemplos de dos empresas en términos generales.
</commit_message>
<xml_diff>
--- a/docs/presentacion-jefes-de-proyecto.pptx
+++ b/docs/presentacion-jefes-de-proyecto.pptx
@@ -4886,7 +4886,7 @@
           <a:p>
             <a:r>
               <a:rPr lang="es-ES"/>
-              <a:t>C. BAC en el libro: el presupuesto de cada paquete se escribe en las celdas amarillas de la columna D de la hoja PV (con dos empresas, uno por empresa). El PV de cada mes es ese BAC × el % planificado. Así el cronograma se puede compartir con el cliente o entre las empresas de una unión temporal sin mostrar importes.</a:t>
+              <a:t>C. BAC en el libro: el presupuesto de cada paquete se escribe en las celdas amarillas de la columna D de la hoja PV (con dos empresas, uno por empresa). El PV de cada mes es ese BAC × el % planificado. Así el cronograma se puede compartir con el cliente o entre las empresas que ejecutan el proyecto sin mostrar importes.</a:t>
             </a:r>
           </a:p>
           <a:p>
@@ -6418,7 +6418,7 @@
           <a:p/>
           <a:p>
             <a:r>
-              <a:t>La configuración (config.toml) indica los nombres de los campos: Item EDT, Método EVM, Peso hito, la planificación a exportar y los umbrales del semáforo.</a:t>
+              <a:t>La configuración (config.toml) indica los nombres de los campos: Item EDT, Método EVM, Peso hito, la planificación a exportar y los umbrales del semáforo. También indica el modo de cálculo: porcentaje (por defecto) o costo.</a:t>
             </a:r>
           </a:p>
           <a:p/>
@@ -15866,7 +15866,7 @@
                 </a:solidFill>
                 <a:latin typeface="Calibri"/>
               </a:rPr>
-              <a:t>% del BAC del paquete en el mes del hito</a:t>
+              <a:t>% del BAC en el mes del hito</a:t>
             </a:r>
             <a:endParaRPr lang="es-ES" sz="1300"/>
           </a:p>
@@ -17087,7 +17087,7 @@
                 </a:solidFill>
                 <a:latin typeface="Calibri"/>
               </a:rPr>
-              <a:t>Regla de oro: el cronograma no lleva importes; la duración de cada tarea debe reflejar su trabajo</a:t>
+              <a:t>Regla de oro: </a:t>
             </a:r>
             <a:r>
               <a:rPr sz="1600" b="0" i="0" lang="es-ES">
@@ -17096,7 +17096,7 @@
                 </a:solidFill>
                 <a:latin typeface="Calibri"/>
               </a:rPr>
-              <a:t/>
+              <a:t>el cronograma no lleva importes; la duración de cada tarea debe reflejar su trabajo</a:t>
             </a:r>
             <a:endParaRPr lang="es-ES" sz="1600"/>
           </a:p>
@@ -17302,7 +17302,7 @@
                 </a:solidFill>
                 <a:latin typeface="Calibri"/>
               </a:rPr>
-              <a:t>Ejemplo: paquete de 300.000 € y 3 meses (miles de euros por mes)</a:t>
+              <a:t>Ejemplo: </a:t>
             </a:r>
             <a:r>
               <a:rPr sz="1600" b="0" i="0" lang="es-ES">
@@ -17311,7 +17311,7 @@
                 </a:solidFill>
                 <a:latin typeface="Calibri"/>
               </a:rPr>
-              <a:t/>
+              <a:t>paquete de 300.000 € y 3 meses (miles de euros por mes)</a:t>
             </a:r>
             <a:endParaRPr lang="es-ES" sz="1600"/>
           </a:p>
@@ -17729,7 +17729,7 @@
                 </a:solidFill>
                 <a:latin typeface="Calibri"/>
               </a:rPr>
-              <a:t>Para la forma real: dividir el paquete en tareas con sus fechas o usar hitos con peso (anticipos, entregas, certificaciones).</a:t>
+              <a:t>Para la forma real: </a:t>
             </a:r>
             <a:r>
               <a:rPr sz="1500" b="0" i="0" lang="es-ES">
@@ -17738,7 +17738,7 @@
                 </a:solidFill>
                 <a:latin typeface="Calibri"/>
               </a:rPr>
-              <a:t/>
+              <a:t>dividir el paquete en tareas con sus fechas o usar hitos con peso (anticipos, entregas, certificaciones).</a:t>
             </a:r>
             <a:endParaRPr lang="es-ES" sz="1500"/>
           </a:p>
@@ -19246,7 +19246,7 @@
                 </a:solidFill>
                 <a:latin typeface="Calibri"/>
               </a:rPr>
-              <a:t>Una copia aprobada y congelada del plan: tareas de la EDT y sus fechas (en el modo costo, también su costo).</a:t>
+              <a:t>Copia aprobada y congelada del plan: tareas de la EDT y sus fechas (y su costo, en el modo costo).</a:t>
             </a:r>
             <a:endParaRPr lang="es-ES" sz="1400"/>
           </a:p>
@@ -22780,7 +22780,7 @@
                 </a:solidFill>
                 <a:latin typeface="Calibri"/>
               </a:rPr>
-              <a:t>% planificado y % ganado de MS Project × BAC del libro</a:t>
+              <a:t>% planificado y ganado leídos de MS Project</a:t>
             </a:r>
             <a:endParaRPr lang="es-ES" sz="1600"/>
           </a:p>
@@ -22802,7 +22802,7 @@
                 </a:solidFill>
                 <a:latin typeface="Calibri"/>
               </a:rPr>
-              <a:t>EV y AC de cada paquete según su método de medición</a:t>
+              <a:t>EV de cada paquete según su método de medición</a:t>
             </a:r>
             <a:endParaRPr lang="es-ES" sz="1600"/>
           </a:p>
@@ -22843,7 +22843,7 @@
                 </a:solidFill>
                 <a:latin typeface="Calibri"/>
               </a:rPr>
-              <a:t>Validaciones automáticas de la EDT, la línea base y los pesos</a:t>
+              <a:t>Validaciones automáticas de la EDT y los pesos</a:t>
             </a:r>
             <a:endParaRPr lang="es-ES" sz="1600"/>
           </a:p>
@@ -24688,7 +24688,7 @@
                 </a:solidFill>
                 <a:latin typeface="Calibri"/>
               </a:rPr>
-              <a:t>30 días  ·  100 % hecho</a:t>
+              <a:t>30 días</a:t>
             </a:r>
             <a:r>
               <a:rPr sz="1300" b="1" i="0" lang="es-ES">
@@ -24697,7 +24697,7 @@
                 </a:solidFill>
                 <a:latin typeface="Calibri"/>
               </a:rPr>
-              <a:t/>
+              <a:t>  ·  100 % hecho</a:t>
             </a:r>
             <a:endParaRPr lang="es-ES" sz="1300"/>
           </a:p>
@@ -24833,7 +24833,7 @@
                 </a:solidFill>
                 <a:latin typeface="Calibri"/>
               </a:rPr>
-              <a:t>40 días  ·  50 % hecho</a:t>
+              <a:t>40 días</a:t>
             </a:r>
             <a:r>
               <a:rPr sz="1300" b="1" i="0" lang="es-ES">
@@ -24842,7 +24842,7 @@
                 </a:solidFill>
                 <a:latin typeface="Calibri"/>
               </a:rPr>
-              <a:t/>
+              <a:t>  ·  50 % hecho</a:t>
             </a:r>
             <a:endParaRPr lang="es-ES" sz="1300"/>
           </a:p>
@@ -24978,7 +24978,7 @@
                 </a:solidFill>
                 <a:latin typeface="Calibri"/>
               </a:rPr>
-              <a:t>20 días  ·  0 % hecho</a:t>
+              <a:t>20 días</a:t>
             </a:r>
             <a:r>
               <a:rPr sz="1300" b="1" i="0" lang="es-ES">
@@ -24987,7 +24987,7 @@
                 </a:solidFill>
                 <a:latin typeface="Calibri"/>
               </a:rPr>
-              <a:t/>
+              <a:t>  ·  0 % hecho</a:t>
             </a:r>
             <a:endParaRPr lang="es-ES" sz="1300"/>
           </a:p>
@@ -31369,7 +31369,7 @@
                 </a:solidFill>
                 <a:latin typeface="Calibri"/>
               </a:rPr>
-              <a:t>Del ERP de cada empresa: se carga en la hoja AC del libro</a:t>
+              <a:t>Del ERP (costo devengado): se carga en la hoja AC del libro</a:t>
             </a:r>
             <a:endParaRPr lang="es-ES" sz="1400"/>
           </a:p>
@@ -32951,7 +32951,7 @@
                 </a:solidFill>
                 <a:latin typeface="Consolas"/>
               </a:rPr>
-              <a:t>config.toml indica el modo (porcentaje o costo), los campos (Item EDT, Método EVM, Peso hito), la planificación, el semáforo y, si hay varios, los archivos de MS Project</a:t>
+              <a:t>config.toml</a:t>
             </a:r>
             <a:r>
               <a:rPr sz="1400" b="0" i="0" lang="es-ES">
@@ -32960,7 +32960,7 @@
                 </a:solidFill>
                 <a:latin typeface="Calibri"/>
               </a:rPr>
-              <a:t/>
+              <a:t> indica los campos (Item EDT, Método EVM, Peso hito), la planificación, el semáforo y, si hay varios, los archivos de MS Project</a:t>
             </a:r>
             <a:endParaRPr lang="es-ES" sz="1400"/>
           </a:p>
@@ -33719,7 +33719,7 @@
                 </a:solidFill>
                 <a:latin typeface="Calibri"/>
               </a:rPr>
-              <a:t>Ingresar el BAC de cada paquete (columna D de PV)</a:t>
+              <a:t>Ingresar el BAC </a:t>
             </a:r>
             <a:r>
               <a:rPr sz="1400" b="0" i="0" lang="es-ES">
@@ -33728,7 +33728,7 @@
                 </a:solidFill>
                 <a:latin typeface="Calibri"/>
               </a:rPr>
-              <a:t/>
+              <a:t>de cada paquete (columna D de PV)</a:t>
             </a:r>
             <a:endParaRPr lang="es-ES" sz="1400"/>
           </a:p>
@@ -33805,7 +33805,7 @@
                 </a:solidFill>
                 <a:latin typeface="Calibri"/>
               </a:rPr>
-              <a:t>Hoja % PV: cada paquete suma 100 %</a:t>
+              <a:t>Hoja % PV: </a:t>
             </a:r>
             <a:r>
               <a:rPr sz="1400" b="0" i="0" lang="es-ES">
@@ -33814,7 +33814,7 @@
                 </a:solidFill>
                 <a:latin typeface="Calibri"/>
               </a:rPr>
-              <a:t/>
+              <a:t>cada paquete suma 100 %</a:t>
             </a:r>
             <a:endParaRPr lang="es-ES" sz="1400"/>
           </a:p>
@@ -43231,7 +43231,7 @@
                 </a:solidFill>
                 <a:latin typeface="Calibri"/>
               </a:rPr>
-              <a:t>Cronograma sin importes: duraciones y pesos de hitos; el BAC, en el libro</a:t>
+              <a:t>Sin importes en el cronograma: el BAC se ingresa en el libro</a:t>
             </a:r>
             <a:endParaRPr lang="es-ES" sz="1600"/>
           </a:p>

</xml_diff>

<commit_message>
Revisión de coherencia de la documentación y la presentación
- validar y generar-fichas en el README, el índice, el proceso de reporte,
  el tutorial, varios archivos, multi-empresa, el glosario y la presentación.
- Cierre mensual en el mismo orden en todos los documentos: fecha de estado,
  avance, reprogramación y validar.
- Detalles que no coincidían con el programa: --nivel-max en actualizar,
  valores por defecto de las opciones, códigos de salida de validar, peso de
  las tareas con distribucion = "calendario", feriados con XML, mes 1, filas
  -D, campo Visible después de generar, Cronograma Ganado y análisis de un
  mes anterior.
- Presentación: ejemplo de % Completado con hitos que pesan 100, pestañas
  % PV y % EV, extracto actual de la hoja AC, validar en el proceso; PDF
  regenerado.
- Plantillas de tickets sin --solo ev y con generar-fichas (parte de #18);
  punto de cambio de versión en la plantilla de Pull Request.
</commit_message>
<xml_diff>
--- a/docs/presentacion-jefes-de-proyecto.pptx
+++ b/docs/presentacion-jefes-de-proyecto.pptx
@@ -4379,7 +4379,7 @@
           <a:p>
             <a:r>
               <a:rPr lang="es-ES"/>
-              <a:t>Bienvenida y presentación. Objetivo: que al terminar sepan qué hay que preparar en MS Project para que el informe EVM (Earned Value Management) sea fiable, y cómo se obtiene ese informe en Excel con el Exportador EVM en dos comandos.</a:t>
+              <a:t>Bienvenida y presentación. Objetivo: que al terminar sepan qué hay que preparar en MS Project para que el informe EVM (Earned Value Management) sea fiable, y cómo se obtiene ese informe en Excel con el Exportador EVM y unos pocos comandos.</a:t>
             </a:r>
           </a:p>
           <a:p/>
@@ -4570,7 +4570,7 @@
           <a:p>
             <a:r>
               <a:rPr lang="es-ES"/>
-              <a:t>Las vamos a ver una a una en las siguientes diapositivas. Lo práctico: cada condición que no se cumple aparece como aviso en la hoja Validación del libro, así que no hay que revisarlo todo a mano.</a:t>
+              <a:t>Las vamos a ver una a una en las siguientes diapositivas. Lo práctico: validar revisa en la terminal el archivo de MS Project (códigos EDT, fechas y duraciones, pesos, métodos, avance a la fecha de estado y lógica del cronograma), y generar deja en la hoja Validación los avisos que afectan al libro, así que no hay que revisarlo todo a mano. Lo que ningún control puede juzgar es si las duraciones y los pesos son realistas: eso es tarea del equipo.</a:t>
             </a:r>
           </a:p>
         </p:txBody>
@@ -4670,6 +4670,12 @@
               <a:t>- Lo que está debajo (actividades, hitos) no necesita código: se suma en su paquete.</a:t>
             </a:r>
           </a:p>
+          <a:p>
+            <a:r>
+              <a:rPr lang="es-ES"/>
+              <a:t>validar y la hoja Validación comprueban que el código de cada tarea dependa del de su tarea superior: bajo 2.1.0 van 2.1.1, 2.1.2...; un 1.14.2 bajo 1.2.0 es un error.</a:t>
+            </a:r>
+          </a:p>
           <a:p/>
           <a:p>
             <a:r>
@@ -4776,7 +4782,7 @@
           <a:p>
             <a:r>
               <a:rPr lang="es-ES"/>
-              <a:t>(Opcional: Empresa y % Reparto si el proyecto se ejecuta entre dos empresas.)</a:t>
+              <a:t>(Opcionales: Empresa y % Reparto si el proyecto se ejecuta entre dos empresas, y Visible para mostrar más o menos detalle en cada rama.)</a:t>
             </a:r>
           </a:p>
           <a:p/>
@@ -4977,7 +4983,7 @@
           <a:p>
             <a:r>
               <a:rPr lang="es-ES"/>
-              <a:t>(Opcional si vas justo de tiempo.)</a:t>
+              <a:t>(Opcional si el tiempo es justo.)</a:t>
             </a:r>
           </a:p>
           <a:p/>
@@ -5118,7 +5124,7 @@
           <a:p>
             <a:r>
               <a:rPr lang="es-ES"/>
-              <a:t>Sin línea base no hay PV y, por tanto, tampoco SV, SPI ni EAC.</a:t>
+              <a:t>Sin línea base, el programa usa las fechas actuales y lo advierte: el PV se movería con cada reprogramación y la SV y el SPI perderían sentido.</a:t>
             </a:r>
           </a:p>
           <a:p/>
@@ -5234,7 +5240,7 @@
           <a:p>
             <a:r>
               <a:rPr lang="es-ES"/>
-              <a:t>4. Verificar: ejecutar generar, ingresar el BAC de cada paquete en el libro y revisar la hoja Validación y la hoja % PV (cada paquete suma 100 %).</a:t>
+              <a:t>4. Verificar: ejecutar validar y corregir en MS Project los errores (códigos EDT, fechas, pesos, métodos); después, ejecutar generar, ingresar el BAC de cada paquete en el libro y revisar la hoja Validación y la hoja % PV (cada paquete suma 100 %).</a:t>
             </a:r>
           </a:p>
           <a:p>
@@ -5382,7 +5388,7 @@
           <a:p>
             <a:r>
               <a:rPr lang="es-ES"/>
-              <a:t>6. Generar el libro nuevo con --migrar-desde, que conserva el BAC ingresado y el historial de EV y AC, escribir el BAC nuevo de los paquetes afectados y registrar en el informe la fecha, el motivo y la variación del BAC.</a:t>
+              <a:t>6. Generar el libro nuevo con --migrar-desde, que conserva el BAC ingresado y el historial de EV y AC, escribir el BAC nuevo de los paquetes afectados y registrar en el informe la fecha, el motivo y la variación del BAC. Si se entregaron fichas de tareas al cliente, se vuelven a crear con generar-fichas.</a:t>
             </a:r>
           </a:p>
           <a:p/>
@@ -5616,7 +5622,7 @@
           <a:p>
             <a:r>
               <a:rPr lang="es-ES"/>
-              <a:t>Transición: antes de ver la herramienta, repasemos en cinco minutos el vocabulario EVM.</a:t>
+              <a:t>Transición: veamos cómo se reparte la sesión.</a:t>
             </a:r>
           </a:p>
         </p:txBody>
@@ -5694,7 +5700,7 @@
           <a:p>
             <a:r>
               <a:rPr lang="es-ES"/>
-              <a:t>Estos son los errores que más se repiten al preparar un proyecto. Todos se detectan en la hoja Validación del libro o al actualizar, así que no hay que buscarlos a mano: basta con leer los avisos.</a:t>
+              <a:t>Estos son los errores que más se repiten al preparar un proyecto. Casi todos se detectan con validar antes de generar, o en la hoja Validación y al actualizar, así que no hay que buscarlos a mano: basta con leer los avisos. Las tareas largas de poco valor no las detecta ningún control: se revisan al planificar.</a:t>
             </a:r>
           </a:p>
           <a:p/>
@@ -5829,7 +5835,7 @@
           <a:p>
             <a:r>
               <a:rPr lang="es-ES"/>
-              <a:t>- % Completado: cada subtarea pesa según su duración: (30 días al 100 % + 40 al 50 % + 20 al 0 %) / 90 días = 55,6 % del BAC = 500.000 €.</a:t>
+              <a:t>- % Completado: si los hitos no tuvieran Peso hito, cada subtarea pesaría según su duración: (30 días al 100 % + 40 al 50 % + 20 al 0 %) / 90 días = 55,6 % del BAC = 500.000 €. Con los pesos de este paquete (30, 30 y 40, que suman 100) las tareas no pesan y el % Completado daría lo mismo que los hitos ponderados: 540.000 €.</a:t>
             </a:r>
           </a:p>
           <a:p>
@@ -6061,7 +6067,7 @@
           <a:p>
             <a:r>
               <a:rPr lang="es-ES"/>
-              <a:t>(Opcional si vas justo de tiempo: mostrar solo el gráfico.)</a:t>
+              <a:t>(Opcional si el tiempo es justo: mostrar solo el gráfico.)</a:t>
             </a:r>
           </a:p>
           <a:p/>
@@ -6190,25 +6196,31 @@
           <a:p>
             <a:r>
               <a:rPr lang="es-ES"/>
-              <a:t>1. Registrar el avance a la fecha de estado (no a la fecha en que se actualiza): % completado o duración real, % físico completado, comienzo y fin reales, y los hitos cumplidos al 100 %.</a:t>
+              <a:t>1. Fijar la fecha de estado en el último día del mes (Proyecto &gt; Fecha de estado).</a:t>
             </a:r>
           </a:p>
           <a:p>
             <a:r>
               <a:rPr lang="es-ES"/>
-              <a:t>2. Reprogramar el trabajo pendiente para que empiece después de la fecha de estado (Proyecto &gt; Actualizar proyecto). Así las fechas futuras siguen siendo una previsión realista. No cambia la línea base ni el PV.</a:t>
+              <a:t>2. Registrar el avance a la fecha de estado (no a la fecha en que se actualiza): % completado o duración real, % físico completado, comienzo y fin reales, y los hitos cumplidos al 100 %.</a:t>
             </a:r>
           </a:p>
           <a:p>
             <a:r>
               <a:rPr lang="es-ES"/>
-              <a:t>3. Costo real: se toma del ERP (devengado, con la misma fecha de corte y en la misma base que el BAC) y se carga en la hoja AC del libro, o en las de cada empresa.</a:t>
+              <a:t>3. Reprogramar el trabajo pendiente para que empiece después de la fecha de estado (Proyecto &gt; Actualizar proyecto). Así las fechas futuras siguen siendo una previsión realista. No cambia la línea base ni el PV. Si se trabaja con XML, guardar el XML al terminar.</a:t>
             </a:r>
           </a:p>
           <a:p>
             <a:r>
               <a:rPr lang="es-ES"/>
-              <a:t>4. Fijar la fecha de estado en el último día del mes (Proyecto &gt; Fecha de estado). Si se trabaja con XML, guardar el XML después de fijarla.</a:t>
+              <a:t>4. Ejecutar validar: revisa en la terminal, sin crear archivos, los códigos EDT, las fechas, los pesos y los métodos, el avance a la fecha de estado (tareas sin actualizar, fechas reales incoherentes, índice BEI) y la lógica del cronograma. Se corrige en MS Project hasta que no queden errores ni trabajo pendiente antes de la fecha de estado.</a:t>
+            </a:r>
+          </a:p>
+          <a:p>
+            <a:r>
+              <a:rPr lang="es-ES"/>
+              <a:t>El costo real no se registra en MS Project: Finanzas lo entrega del ERP (devengado, con la misma fecha de corte y en la misma base que el BAC) y se carga en la hoja AC del libro, o en las de cada empresa, después de actualizar (bloque siguiente).</a:t>
             </a:r>
           </a:p>
           <a:p/>
@@ -6293,7 +6305,7 @@
           <a:p>
             <a:r>
               <a:rPr lang="es-ES"/>
-              <a:t>Tercer bloque: la herramienta. Es un programa en Python que se ejecuta en Windows desde la línea de comandos. No hace falta saber programar: son dos comandos que se copian y se ajustan.</a:t>
+              <a:t>Tercer bloque: la herramienta. Es un programa en Python que se ejecuta en Windows desde la línea de comandos. No hace falta saber programar: son pocos comandos que se copian y se ajustan: validar, generar y actualizar; analizar y generar-fichas son de apoyo.</a:t>
             </a:r>
           </a:p>
         </p:txBody>
@@ -6382,6 +6394,16 @@
               <a:t>- actualizar: se ejecuta cada mes. Lee el avance a la fecha de estado, calcula el % ganado acumulado de cada paquete según su método y escribe el % del mes en el libro; el EV es el BAC × el %. El AC del mes se carga a mano. Indicadores y gráficos se recalculan solos.</a:t>
             </a:r>
           </a:p>
+          <a:p>
+            <a:r>
+              <a:t>- validar: antes de generar y antes de cada actualizar. Revisa el archivo de MS Project sin crear archivos: códigos EDT, fechas y duraciones, pesos de los hitos, método frente a la duración del paquete, avance a la fecha de estado y lógica del cronograma (criterios DCMA). Termina con código 1 si hay errores.</a:t>
+            </a:r>
+          </a:p>
+          <a:p>
+            <a:r>
+              <a:t>- generar-fichas (opcional): crea un documento Markdown con la ficha de cada elemento EDT del libro (fechas y duración de la línea base, predecesoras y sucesoras) para el cliente, sin importes.</a:t>
+            </a:r>
+          </a:p>
           <a:p/>
           <a:p>
             <a:r>
@@ -6481,7 +6503,7 @@
           <a:p>
             <a:r>
               <a:rPr lang="es-ES"/>
-              <a:t>Se ejecuta una vez, después de guardar la línea base. La salida en pantalla resume lo leído: planificación, filas de la EDT, horizonte de meses y el recordatorio de ingresar el BAC, más observaciones informativas.</a:t>
+              <a:t>Se ejecuta una vez, después de guardar la línea base y de revisar el archivo con validar. La salida en pantalla resume lo leído: planificación, filas de la EDT, horizonte de meses y el recordatorio de ingresar el BAC, más observaciones informativas y avisos, por ejemplo de paquetes demasiado largos para su método (0/100, 50/50...).</a:t>
             </a:r>
           </a:p>
           <a:p/>
@@ -6623,7 +6645,7 @@
           <a:p/>
           <a:p>
             <a:r>
-              <a:t>La salida de la derecha es la real del ejemplo a diciembre de 2027: los mismos indicadores que veremos en el Cuadro de Mando.</a:t>
+              <a:t>La salida de la derecha es un extracto real del ejemplo a diciembre de 2027, con el AC del mes ya cargado: los mismos indicadores que veremos en el Cuadro de Mando.</a:t>
             </a:r>
           </a:p>
         </p:txBody>
@@ -6818,7 +6840,13 @@
           <a:p>
             <a:r>
               <a:rPr lang="es-ES"/>
-              <a:t>Si vas justo de tiempo, las diapositivas marcadas como opcionales en estas notas (Earned Schedule, Forma de la curva PV e Hitos ponderados) se pueden pasar en 15 segundos cada una.</a:t>
+              <a:t>Si el tiempo es justo, las diapositivas marcadas como opcionales en estas notas (Earned Schedule, Forma de la curva PV e Hitos ponderados) se pueden pasar en 15 segundos cada una.</a:t>
+            </a:r>
+          </a:p>
+          <a:p>
+            <a:r>
+              <a:rPr lang="es-ES"/>
+              <a:t>Transición: antes de ver la herramienta, repasemos en cinco minutos el vocabulario EVM.</a:t>
             </a:r>
           </a:p>
         </p:txBody>
@@ -7325,7 +7353,7 @@
           </a:p>
           <a:p>
             <a:r>
-              <a:t>- D+3: el planificador (PMO) registra el avance en MS Project y fija la fecha de estado.</a:t>
+              <a:t>- D+3: el planificador (PMO) fija la fecha de estado, registra el avance en MS Project y ejecuta validar (sin errores ni trabajo pendiente antes de la fecha de estado).</a:t>
             </a:r>
           </a:p>
           <a:p>
@@ -7447,7 +7475,7 @@
           </a:p>
           <a:p>
             <a:r>
-              <a:t>5. Simular, revisar y actualizar; y dedicar el tiempo del cierre a analizar.</a:t>
+              <a:t>5. Validar, simular y actualizar; y dedicar el tiempo del cierre a analizar.</a:t>
             </a:r>
           </a:p>
           <a:p/>
@@ -7459,7 +7487,7 @@
           <a:p/>
           <a:p>
             <a:r>
-              <a:t>Abrir turno de preguntas (3 minutos).</a:t>
+              <a:t>Abrir turno de preguntas (4 minutos).</a:t>
             </a:r>
           </a:p>
         </p:txBody>
@@ -7663,7 +7691,7 @@
           </a:p>
           <a:p>
             <a:r>
-              <a:t>5. Cargar y verificar (PMO): el método en el campo Método EVM, los pesos en Peso hito y el criterio en las Notas del paquete o del hito. Después de generar, la hoja Validación no debe mostrar métodos por definir.</a:t>
+              <a:t>5. Cargar y verificar (PMO): el método en el campo Método EVM, los pesos en Peso hito y el criterio en las Notas del paquete o del hito. validar y, después de generar, la hoja Validación no deben mostrar métodos por definir. validar también avisa si un 0/100 dura más de 1 mes o un 50/50, 25/75 o 20/80 más de 2 meses (umbrales de la sección [validacion]), si un paquete de hitos ponderados no tiene hitos o si un método no se reconoce.</a:t>
             </a:r>
           </a:p>
           <a:p/>
@@ -8106,7 +8134,7 @@
           <a:p/>
           <a:p>
             <a:r>
-              <a:t>El semáforo es común para el CPI y el SPI y tiene umbrales inferiores y superiores: verde de 0,95 a 1,05; amarillo de 0,90 a 0,95 y de 1,05 a 1,10; rojo por debajo de 0,90 o por encima de 1,10. Un índice demasiado alto también se revisa: puede deberse a un AC incompleto o a un avance informado de más. Los umbrales se ajustan en la configuración (sección [semaforo]) y el Cuadro de Mando los muestra.</a:t>
+              <a:t>El semáforo es común para el CPI y el SPI y tiene umbrales inferiores y superiores: verde de 0,95 a 1,05; amarillo de 0,90 a 0,95 y de 1,05 a 1,10; rojo por debajo de 0,90 o por encima de 1,10. Un índice demasiado alto también se revisa: puede deberse a un AC incompleto o a un avance informado de más. Los umbrales se ajustan en la configuración (sección [semaforo]) y el Cuadro de Mando los muestra; se guardan en el libro al generarlo, así que un cambio exige regenerar el libro con --migrar-desde.</a:t>
             </a:r>
           </a:p>
           <a:p/>
@@ -8202,7 +8230,7 @@
           <a:p>
             <a:r>
               <a:rPr lang="es-ES"/>
-              <a:t>- AC + (BAC − EV): el resto se ejecutará según presupuesto; la desviación fue puntual. Es el más optimista.</a:t>
+              <a:t>- AC + (BAC − EV): el resto se ejecutará según presupuesto; la desviación fue puntual. Con un CPI menor que 1, es el más optimista.</a:t>
             </a:r>
           </a:p>
           <a:p>
@@ -8314,7 +8342,7 @@
           <a:p>
             <a:r>
               <a:rPr lang="es-ES"/>
-              <a:t>(Opcional si vas justo de tiempo: quedarse solo con la frase "el SPI tiende a 1 al final; el SPI(t) no".)</a:t>
+              <a:t>(Opcional si el tiempo es justo: quedarse solo con la frase "el SPI tiende a 1 al final; el SPI(t) no".)</a:t>
             </a:r>
           </a:p>
           <a:p/>
@@ -11455,7 +11483,7 @@
                 </a:solidFill>
                 <a:latin typeface="Calibri"/>
               </a:rPr>
-              <a:t>Conceptos clave de MS Project para planificación y costos, y el Exportador EVM para generar el informe mensual en Excel</a:t>
+              <a:t>Conceptos clave de MS Project para planificar y medir el avance, y el Exportador EVM para generar el informe mensual en Excel</a:t>
             </a:r>
             <a:endParaRPr lang="es-ES" sz="1800"/>
           </a:p>
@@ -13833,7 +13861,7 @@
                 </a:solidFill>
                 <a:latin typeface="Calibri"/>
               </a:rPr>
-              <a:t>cada condición incumplida aparece como aviso en la hoja </a:t>
+              <a:t>validar revisa el archivo de MS Project antes de exportar y generar deja los avisos del libro en la hoja </a:t>
             </a:r>
             <a:r>
               <a:rPr sz="1500" b="1" i="0" lang="es-ES">
@@ -13851,7 +13879,7 @@
                 </a:solidFill>
                 <a:latin typeface="Calibri"/>
               </a:rPr>
-              <a:t> del libro Excel, con la tarea afectada.</a:t>
+              <a:t>, con la tarea afectada.</a:t>
             </a:r>
             <a:endParaRPr lang="es-ES" sz="1500"/>
           </a:p>
@@ -15893,7 +15921,7 @@
                 </a:solidFill>
                 <a:latin typeface="Calibri"/>
               </a:rPr>
-              <a:t>Empresa y % Reparto (dos empresas)</a:t>
+              <a:t>Empresa y % Reparto (dos empresas); Visible (más o menos detalle por rama)</a:t>
             </a:r>
             <a:endParaRPr lang="es-ES" sz="1300"/>
           </a:p>
@@ -19982,7 +20010,7 @@
                 </a:solidFill>
                 <a:latin typeface="Calibri"/>
               </a:rPr>
-              <a:t>generar, ingresar el BAC y revisar la hoja % PV</a:t>
+              <a:t>validar, generar, ingresar el BAC y revisar las hojas Validación y % PV</a:t>
             </a:r>
             <a:endParaRPr lang="es-ES" sz="1300"/>
           </a:p>
@@ -22753,7 +22781,7 @@
                 </a:solidFill>
                 <a:latin typeface="Calibri"/>
               </a:rPr>
-              <a:t>% planificado y ganado leídos de MS Project</a:t>
+              <a:t>% planificado y ganado calculados con los datos de MS Project</a:t>
             </a:r>
             <a:endParaRPr lang="es-ES" sz="1600"/>
           </a:p>
@@ -22816,7 +22844,7 @@
                 </a:solidFill>
                 <a:latin typeface="Calibri"/>
               </a:rPr>
-              <a:t>Validaciones automáticas de la EDT y los pesos</a:t>
+              <a:t>Validaciones automáticas del cronograma y del libro</a:t>
             </a:r>
             <a:endParaRPr lang="es-ES" sz="1600"/>
           </a:p>
@@ -23002,7 +23030,7 @@
                 </a:solidFill>
                 <a:latin typeface="Calibri"/>
               </a:rPr>
-              <a:t>MS PROJECT · PRESUPUESTO</a:t>
+              <a:t>MS PROJECT · PREPARACIÓN</a:t>
             </a:r>
             <a:endParaRPr lang="es-ES" sz="1100"/>
           </a:p>
@@ -25756,6 +25784,19 @@
             </a:r>
             <a:endParaRPr lang="es-ES" sz="1500"/>
           </a:p>
+          <a:p>
+            <a:pPr algn="l"/>
+            <a:r>
+              <a:rPr sz="1100" b="0" i="0" lang="es-ES">
+                <a:solidFill>
+                  <a:srgbClr val="5A6577"/>
+                </a:solidFill>
+                <a:latin typeface="Calibri"/>
+              </a:rPr>
+              <a:t>si los hitos no tuvieran peso</a:t>
+            </a:r>
+            <a:endParaRPr lang="es-ES" sz="1500"/>
+          </a:p>
         </p:txBody>
       </p:sp>
       <p:sp>
@@ -29236,7 +29277,7 @@
                 </a:solidFill>
                 <a:latin typeface="Calibri"/>
               </a:rPr>
-              <a:t>Método EVM y Peso hito en MS Project, criterio en Notas; Validación sin métodos por definir</a:t>
+              <a:t>Método EVM y Peso hito en MS Project, criterio en Notas; validar sin avisos de método</a:t>
             </a:r>
             <a:endParaRPr lang="es-ES" sz="1400"/>
           </a:p>
@@ -31080,7 +31121,7 @@
                 </a:solidFill>
                 <a:latin typeface="Calibri"/>
               </a:rPr>
-              <a:t>Registrar el avance a la fecha de estado</a:t>
+              <a:t>Fijar la fecha de estado</a:t>
             </a:r>
             <a:endParaRPr lang="es-ES" sz="1700"/>
           </a:p>
@@ -31116,7 +31157,7 @@
                 </a:solidFill>
                 <a:latin typeface="Calibri"/>
               </a:rPr>
-              <a:t>% completado, % físico completado, comienzo y fin reales; hitos cumplidos al 100 %</a:t>
+              <a:t>Proyecto &gt; Fecha de estado = último día del mes. Con XML: guardar al terminar</a:t>
             </a:r>
             <a:endParaRPr lang="es-ES" sz="1400"/>
           </a:p>
@@ -31193,7 +31234,7 @@
                 </a:solidFill>
                 <a:latin typeface="Calibri"/>
               </a:rPr>
-              <a:t>Reprogramar el trabajo pendiente</a:t>
+              <a:t>Registrar el avance a la fecha de estado</a:t>
             </a:r>
             <a:endParaRPr lang="es-ES" sz="1700"/>
           </a:p>
@@ -31229,7 +31270,7 @@
                 </a:solidFill>
                 <a:latin typeface="Calibri"/>
               </a:rPr>
-              <a:t>Después de la fecha de estado (Proyecto &gt; Actualizar proyecto). No cambia la línea base</a:t>
+              <a:t>% completado, % físico completado, comienzo y fin reales; hitos cumplidos al 100 %</a:t>
             </a:r>
             <a:endParaRPr lang="es-ES" sz="1400"/>
           </a:p>
@@ -31306,7 +31347,7 @@
                 </a:solidFill>
                 <a:latin typeface="Calibri"/>
               </a:rPr>
-              <a:t>Costo real del mes</a:t>
+              <a:t>Reprogramar el trabajo pendiente</a:t>
             </a:r>
             <a:endParaRPr lang="es-ES" sz="1700"/>
           </a:p>
@@ -31342,7 +31383,7 @@
                 </a:solidFill>
                 <a:latin typeface="Calibri"/>
               </a:rPr>
-              <a:t>Del ERP (costo devengado): se carga en la hoja AC del libro</a:t>
+              <a:t>Después de la fecha de estado (Proyecto &gt; Actualizar proyecto). No cambia la línea base</a:t>
             </a:r>
             <a:endParaRPr lang="es-ES" sz="1400"/>
           </a:p>
@@ -31419,7 +31460,7 @@
                 </a:solidFill>
                 <a:latin typeface="Calibri"/>
               </a:rPr>
-              <a:t>Fijar la fecha de estado</a:t>
+              <a:t>Revisar con validar</a:t>
             </a:r>
             <a:endParaRPr lang="es-ES" sz="1700"/>
           </a:p>
@@ -31455,7 +31496,7 @@
                 </a:solidFill>
                 <a:latin typeface="Calibri"/>
               </a:rPr>
-              <a:t>Proyecto &gt; Fecha de estado = último día del mes. Con XML: guardar después</a:t>
+              <a:t>Sin errores ni trabajo pendiente antes de la fecha de estado</a:t>
             </a:r>
             <a:endParaRPr lang="es-ES" sz="1400"/>
           </a:p>
@@ -31713,7 +31754,7 @@
                 </a:solidFill>
                 <a:latin typeface="Calibri"/>
               </a:rPr>
-              <a:t>Dos comandos: generar una vez, actualizar cada mes</a:t>
+              <a:t>Validar el cronograma, generar una vez y actualizar cada mes</a:t>
             </a:r>
             <a:endParaRPr lang="es-ES" sz="2000"/>
           </a:p>
@@ -31904,7 +31945,7 @@
                 </a:solidFill>
                 <a:latin typeface="Calibri"/>
               </a:rPr>
-              <a:t>Cómo funciona: dos comandos</a:t>
+              <a:t>Cómo funciona: validar, generar y actualizar</a:t>
             </a:r>
             <a:endParaRPr lang="es-ES" sz="3200"/>
           </a:p>
@@ -32936,6 +32977,49 @@
               <a:t> indica los campos (Item EDT, Método EVM, Peso hito), la planificación, el semáforo y, si hay varios, los archivos de MS Project</a:t>
             </a:r>
             <a:endParaRPr lang="es-ES" sz="1400"/>
+          </a:p>
+        </p:txBody>
+      </p:sp>
+      <p:sp>
+        <p:nvSpPr>
+          <p:cNvPr id="26" name="validar"/>
+          <p:cNvSpPr txBox="1"/>
+          <p:nvPr/>
+        </p:nvSpPr>
+        <p:spPr>
+          <a:xfrm>
+            <a:off x="777240" y="3703320"/>
+            <a:ext cx="2450000" cy="320040"/>
+          </a:xfrm>
+          <a:prstGeom prst="rect">
+            <a:avLst/>
+          </a:prstGeom>
+          <a:noFill/>
+        </p:spPr>
+        <p:txBody>
+          <a:bodyPr wrap="square" lIns="0" rIns="0">
+            <a:spAutoFit/>
+          </a:bodyPr>
+          <a:lstStyle/>
+          <a:p>
+            <a:r>
+              <a:rPr b="1" sz="1400">
+                <a:solidFill>
+                  <a:srgbClr val="8A5A00"/>
+                </a:solidFill>
+                <a:latin typeface="Consolas"/>
+              </a:rPr>
+              <a:t>validar</a:t>
+            </a:r>
+            <a:r>
+              <a:rPr sz="1200">
+                <a:solidFill>
+                  <a:srgbClr val="5A6577"/>
+                </a:solidFill>
+                <a:latin typeface="Calibri"/>
+              </a:rPr>
+              <a:t>  antes de cada comando</a:t>
+            </a:r>
           </a:p>
         </p:txBody>
       </p:sp>
@@ -33864,7 +33948,7 @@
                 </a:solidFill>
                 <a:latin typeface="Calibri"/>
               </a:rPr>
-              <a:t>Hoja Validación </a:t>
+              <a:t>Hoja Validación: </a:t>
             </a:r>
             <a:r>
               <a:rPr sz="1400" b="0" i="0" lang="es-ES">
@@ -34948,7 +35032,24 @@
                 </a:solidFill>
                 <a:latin typeface="Consolas"/>
               </a:rPr>
-              <a:t>  4.2.2 Cierre administrativo: método no definido</a:t>
+              <a:t>  4.2.2 Cierre administrativo: método no definido:</a:t>
+            </a:r>
+            <a:endParaRPr lang="es-ES" sz="1200"/>
+          </a:p>
+          <a:p>
+            <a:pPr algn="l">
+              <a:spcAft>
+                <a:spcPts val="100"/>
+              </a:spcAft>
+            </a:pPr>
+            <a:r>
+              <a:rPr sz="1200" b="0" i="0" lang="es-ES">
+                <a:solidFill>
+                  <a:srgbClr val="F5C26B"/>
+                </a:solidFill>
+                <a:latin typeface="Consolas"/>
+              </a:rPr>
+              <a:t>        se usó % completado</a:t>
             </a:r>
             <a:endParaRPr lang="es-ES" sz="1200"/>
           </a:p>
@@ -35831,7 +35932,7 @@
                 </a:solidFill>
                 <a:latin typeface="Calibri"/>
               </a:rPr>
-              <a:t>Comandos generar y actualizar, y el libro Excel</a:t>
+              <a:t>Comandos validar, generar y actualizar, y el libro Excel</a:t>
             </a:r>
             <a:endParaRPr lang="es-ES" sz="1400"/>
           </a:p>
@@ -36533,7 +36634,7 @@
         <p:spPr>
           <a:xfrm>
             <a:off x="548640" y="1508760"/>
-            <a:ext cx="1456505" cy="411480"/>
+            <a:ext cx="1340819" cy="411480"/>
           </a:xfrm>
           <a:prstGeom prst="round2SameRect">
             <a:avLst>
@@ -36549,7 +36650,7 @@
           </a:ln>
         </p:spPr>
         <p:txBody>
-          <a:bodyPr rtlCol="0" anchor="ctr" wrap="square" lIns="0" rIns="0" tIns="0" bIns="0">
+          <a:bodyPr rtlCol="0" anchor="ctr" wrap="square" lIns="36576" rIns="36576" tIns="0" bIns="0">
             <a:noAutofit/>
           </a:bodyPr>
           <a:lstStyle/>
@@ -36576,8 +36677,8 @@
         </p:nvSpPr>
         <p:spPr>
           <a:xfrm>
-            <a:off x="2050865" y="1508760"/>
-            <a:ext cx="830538" cy="411480"/>
+            <a:off x="1926035" y="1508760"/>
+            <a:ext cx="737715" cy="411480"/>
           </a:xfrm>
           <a:prstGeom prst="round2SameRect">
             <a:avLst>
@@ -36593,7 +36694,7 @@
           </a:ln>
         </p:spPr>
         <p:txBody>
-          <a:bodyPr rtlCol="0" anchor="ctr" wrap="square" lIns="0" rIns="0" tIns="0" bIns="0">
+          <a:bodyPr rtlCol="0" anchor="ctr" wrap="square" lIns="36576" rIns="36576" tIns="0" bIns="0">
             <a:noAutofit/>
           </a:bodyPr>
           <a:lstStyle/>
@@ -36620,8 +36721,8 @@
         </p:nvSpPr>
         <p:spPr>
           <a:xfrm>
-            <a:off x="2927123" y="1508760"/>
-            <a:ext cx="439308" cy="411480"/>
+            <a:off x="2700326" y="1508760"/>
+            <a:ext cx="360775" cy="411480"/>
           </a:xfrm>
           <a:prstGeom prst="round2SameRect">
             <a:avLst>
@@ -36637,7 +36738,7 @@
           </a:ln>
         </p:spPr>
         <p:txBody>
-          <a:bodyPr rtlCol="0" anchor="ctr" wrap="square" lIns="0" rIns="0" tIns="0" bIns="0">
+          <a:bodyPr rtlCol="0" anchor="ctr" wrap="square" lIns="36576" rIns="36576" tIns="0" bIns="0">
             <a:noAutofit/>
           </a:bodyPr>
           <a:lstStyle/>
@@ -36658,14 +36759,14 @@
       </p:sp>
       <p:sp>
         <p:nvSpPr>
-          <p:cNvPr id="9" name="Round Same Side Corner Rectangle 8"/>
+          <p:cNvPr id="34" name="Pestaña % PV"/>
           <p:cNvSpPr/>
           <p:nvPr/>
         </p:nvSpPr>
         <p:spPr>
           <a:xfrm>
-            <a:off x="3412152" y="1508760"/>
-            <a:ext cx="439308" cy="411480"/>
+            <a:off x="3097677" y="1508760"/>
+            <a:ext cx="511551" cy="411480"/>
           </a:xfrm>
           <a:prstGeom prst="round2SameRect">
             <a:avLst>
@@ -36681,7 +36782,7 @@
           </a:ln>
         </p:spPr>
         <p:txBody>
-          <a:bodyPr rtlCol="0" anchor="ctr" wrap="square" lIns="0" rIns="0" tIns="0" bIns="0">
+          <a:bodyPr rtlCol="0" anchor="ctr" wrap="square" lIns="36576" rIns="36576" tIns="0" bIns="0">
             <a:noAutofit/>
           </a:bodyPr>
           <a:lstStyle/>
@@ -36694,7 +36795,7 @@
                 </a:solidFill>
                 <a:latin typeface="Calibri"/>
               </a:rPr>
-              <a:t>EV</a:t>
+              <a:t>% PV</a:t>
             </a:r>
             <a:endParaRPr lang="es-ES" sz="1200"/>
           </a:p>
@@ -36702,14 +36803,14 @@
       </p:sp>
       <p:sp>
         <p:nvSpPr>
-          <p:cNvPr id="10" name="Round Same Side Corner Rectangle 9"/>
+          <p:cNvPr id="9" name="Round Same Side Corner Rectangle 8"/>
           <p:cNvSpPr/>
           <p:nvPr/>
         </p:nvSpPr>
         <p:spPr>
           <a:xfrm>
-            <a:off x="3897180" y="1508760"/>
-            <a:ext cx="439308" cy="411480"/>
+            <a:off x="3645804" y="1508760"/>
+            <a:ext cx="360775" cy="411480"/>
           </a:xfrm>
           <a:prstGeom prst="round2SameRect">
             <a:avLst>
@@ -36725,7 +36826,95 @@
           </a:ln>
         </p:spPr>
         <p:txBody>
-          <a:bodyPr rtlCol="0" anchor="ctr" wrap="square" lIns="0" rIns="0" tIns="0" bIns="0">
+          <a:bodyPr rtlCol="0" anchor="ctr" wrap="square" lIns="36576" rIns="36576" tIns="0" bIns="0">
+            <a:noAutofit/>
+          </a:bodyPr>
+          <a:lstStyle/>
+          <a:p>
+            <a:pPr algn="ctr"/>
+            <a:r>
+              <a:rPr sz="1100" b="1" i="0" lang="es-ES">
+                <a:solidFill>
+                  <a:srgbClr val="1B2B48"/>
+                </a:solidFill>
+                <a:latin typeface="Calibri"/>
+              </a:rPr>
+              <a:t>EV</a:t>
+            </a:r>
+            <a:endParaRPr lang="es-ES" sz="1200"/>
+          </a:p>
+        </p:txBody>
+      </p:sp>
+      <p:sp>
+        <p:nvSpPr>
+          <p:cNvPr id="35" name="Pestaña % EV"/>
+          <p:cNvSpPr/>
+          <p:nvPr/>
+        </p:nvSpPr>
+        <p:spPr>
+          <a:xfrm>
+            <a:off x="4043155" y="1508760"/>
+            <a:ext cx="511551" cy="411480"/>
+          </a:xfrm>
+          <a:prstGeom prst="round2SameRect">
+            <a:avLst>
+              <a:gd name="adj1" fmla="val 22222"/>
+              <a:gd name="adj2" fmla="val 0"/>
+            </a:avLst>
+          </a:prstGeom>
+          <a:solidFill>
+            <a:srgbClr val="F2B134"/>
+          </a:solidFill>
+          <a:ln>
+            <a:noFill/>
+          </a:ln>
+        </p:spPr>
+        <p:txBody>
+          <a:bodyPr rtlCol="0" anchor="ctr" wrap="square" lIns="36576" rIns="36576" tIns="0" bIns="0">
+            <a:noAutofit/>
+          </a:bodyPr>
+          <a:lstStyle/>
+          <a:p>
+            <a:pPr algn="ctr"/>
+            <a:r>
+              <a:rPr sz="1100" b="1" i="0" lang="es-ES">
+                <a:solidFill>
+                  <a:srgbClr val="1B2B48"/>
+                </a:solidFill>
+                <a:latin typeface="Calibri"/>
+              </a:rPr>
+              <a:t>% EV</a:t>
+            </a:r>
+            <a:endParaRPr lang="es-ES" sz="1200"/>
+          </a:p>
+        </p:txBody>
+      </p:sp>
+      <p:sp>
+        <p:nvSpPr>
+          <p:cNvPr id="10" name="Round Same Side Corner Rectangle 9"/>
+          <p:cNvSpPr/>
+          <p:nvPr/>
+        </p:nvSpPr>
+        <p:spPr>
+          <a:xfrm>
+            <a:off x="4591282" y="1508760"/>
+            <a:ext cx="360775" cy="411480"/>
+          </a:xfrm>
+          <a:prstGeom prst="round2SameRect">
+            <a:avLst>
+              <a:gd name="adj1" fmla="val 22222"/>
+              <a:gd name="adj2" fmla="val 0"/>
+            </a:avLst>
+          </a:prstGeom>
+          <a:solidFill>
+            <a:srgbClr val="F2B134"/>
+          </a:solidFill>
+          <a:ln>
+            <a:noFill/>
+          </a:ln>
+        </p:spPr>
+        <p:txBody>
+          <a:bodyPr rtlCol="0" anchor="ctr" wrap="square" lIns="36576" rIns="36576" tIns="0" bIns="0">
             <a:noAutofit/>
           </a:bodyPr>
           <a:lstStyle/>
@@ -36752,8 +36941,8 @@
         </p:nvSpPr>
         <p:spPr>
           <a:xfrm>
-            <a:off x="4382209" y="1508760"/>
-            <a:ext cx="1612997" cy="411480"/>
+            <a:off x="4988633" y="1508760"/>
+            <a:ext cx="1491595" cy="411480"/>
           </a:xfrm>
           <a:prstGeom prst="round2SameRect">
             <a:avLst>
@@ -36769,7 +36958,7 @@
           </a:ln>
         </p:spPr>
         <p:txBody>
-          <a:bodyPr rtlCol="0" anchor="ctr" wrap="square" lIns="0" rIns="0" tIns="0" bIns="0">
+          <a:bodyPr rtlCol="0" anchor="ctr" wrap="square" lIns="36576" rIns="36576" tIns="0" bIns="0">
             <a:noAutofit/>
           </a:bodyPr>
           <a:lstStyle/>
@@ -36796,8 +36985,8 @@
         </p:nvSpPr>
         <p:spPr>
           <a:xfrm>
-            <a:off x="6040926" y="1508760"/>
-            <a:ext cx="1456505" cy="411480"/>
+            <a:off x="6516804" y="1508760"/>
+            <a:ext cx="1340819" cy="411480"/>
           </a:xfrm>
           <a:prstGeom prst="round2SameRect">
             <a:avLst>
@@ -36813,7 +37002,7 @@
           </a:ln>
         </p:spPr>
         <p:txBody>
-          <a:bodyPr rtlCol="0" anchor="ctr" wrap="square" lIns="0" rIns="0" tIns="0" bIns="0">
+          <a:bodyPr rtlCol="0" anchor="ctr" wrap="square" lIns="36576" rIns="36576" tIns="0" bIns="0">
             <a:noAutofit/>
           </a:bodyPr>
           <a:lstStyle/>
@@ -36840,8 +37029,8 @@
         </p:nvSpPr>
         <p:spPr>
           <a:xfrm>
-            <a:off x="7543152" y="1508760"/>
-            <a:ext cx="2160719" cy="411480"/>
+            <a:off x="7894199" y="1508760"/>
+            <a:ext cx="2019311" cy="411480"/>
           </a:xfrm>
           <a:prstGeom prst="round2SameRect">
             <a:avLst>
@@ -36857,7 +37046,7 @@
           </a:ln>
         </p:spPr>
         <p:txBody>
-          <a:bodyPr rtlCol="0" anchor="ctr" wrap="square" lIns="0" rIns="0" tIns="0" bIns="0">
+          <a:bodyPr rtlCol="0" anchor="ctr" wrap="square" lIns="36576" rIns="36576" tIns="0" bIns="0">
             <a:noAutofit/>
           </a:bodyPr>
           <a:lstStyle/>
@@ -36884,8 +37073,8 @@
         </p:nvSpPr>
         <p:spPr>
           <a:xfrm>
-            <a:off x="9749591" y="1508760"/>
-            <a:ext cx="1065276" cy="411480"/>
+            <a:off x="9950086" y="1508760"/>
+            <a:ext cx="963879" cy="411480"/>
           </a:xfrm>
           <a:prstGeom prst="round2SameRect">
             <a:avLst>
@@ -36901,7 +37090,7 @@
           </a:ln>
         </p:spPr>
         <p:txBody>
-          <a:bodyPr rtlCol="0" anchor="ctr" wrap="square" lIns="0" rIns="0" tIns="0" bIns="0">
+          <a:bodyPr rtlCol="0" anchor="ctr" wrap="square" lIns="36576" rIns="36576" tIns="0" bIns="0">
             <a:noAutofit/>
           </a:bodyPr>
           <a:lstStyle/>
@@ -36928,8 +37117,8 @@
         </p:nvSpPr>
         <p:spPr>
           <a:xfrm>
-            <a:off x="10860587" y="1508760"/>
-            <a:ext cx="752292" cy="411480"/>
+            <a:off x="10950541" y="1508760"/>
+            <a:ext cx="662338" cy="411480"/>
           </a:xfrm>
           <a:prstGeom prst="round2SameRect">
             <a:avLst>
@@ -36945,7 +37134,7 @@
           </a:ln>
         </p:spPr>
         <p:txBody>
-          <a:bodyPr rtlCol="0" anchor="ctr" wrap="square" lIns="0" rIns="0" tIns="0" bIns="0">
+          <a:bodyPr rtlCol="0" anchor="ctr" wrap="square" lIns="36576" rIns="36576" tIns="0" bIns="0">
             <a:noAutofit/>
           </a:bodyPr>
           <a:lstStyle/>
@@ -39707,7 +39896,7 @@
                 </a:solidFill>
                 <a:latin typeface="Calibri"/>
               </a:rPr>
-              <a:t>SPI = 1,00  ·  CPI = 1,10</a:t>
+              <a:t>CPI 1,10  ·  SPI 1,00</a:t>
             </a:r>
             <a:endParaRPr lang="es-ES" sz="1400"/>
           </a:p>
@@ -42345,7 +42534,7 @@
                 </a:solidFill>
                 <a:latin typeface="Calibri"/>
               </a:rPr>
-              <a:t>Registro del avance y fecha de estado</a:t>
+              <a:t>Fecha de estado, avance y validar</a:t>
             </a:r>
             <a:endParaRPr lang="es-ES" sz="1400"/>
           </a:p>
@@ -43435,7 +43624,7 @@
                 </a:solidFill>
                 <a:latin typeface="Calibri"/>
               </a:rPr>
-              <a:t>Simular, revisar, actualizar… y dedicar el cierre a analizar</a:t>
+              <a:t>Validar, simular, actualizar… y dedicar el cierre a analizar</a:t>
             </a:r>
             <a:endParaRPr lang="es-ES" sz="1600"/>
           </a:p>
@@ -47425,7 +47614,7 @@
                 </a:solidFill>
                 <a:latin typeface="Calibri"/>
               </a:rPr>
-              <a:t>Si usas MS Project en español</a:t>
+              <a:t>Con MS Project en español</a:t>
             </a:r>
             <a:endParaRPr lang="es-ES" sz="1300"/>
           </a:p>

</xml_diff>

<commit_message>
Formato de números de la consola: punto de miles y coma decimal
La consola mezclaba tres formatos: "0,95 a 1,05" en el umbral, "1.00" en los
índices y "44,210,000" en los importes. Ahora todos los números se muestran
como en Excel en español (44.210.000; SPI = 0,84; 27,4 %).

- fields.fmt_number reemplaza los formateadores de cli, indicators, wbs
  (fmt_money), workbook (fmt_decimal), validation, percent y task_cards, y
  el formato :g del reparto de multi-empresa y del umbral de PV-depuración.
- Salidas de consola actualizadas en comandos, calculo-pv-ev,
  ejemplo-paso-a-paso y analisis-desviaciones, y en la diapositiva 29
  (PDF regenerado).
- Prueba de fmt_number y pruebas ajustadas al nuevo formato.
</commit_message>
<xml_diff>
--- a/docs/presentacion-jefes-de-proyecto.pptx
+++ b/docs/presentacion-jefes-de-proyecto.pptx
@@ -35083,7 +35083,7 @@
                 </a:solidFill>
                 <a:latin typeface="Consolas"/>
               </a:rPr>
-              <a:t>BAC (EUR)        44,210,000</a:t>
+              <a:t>BAC (EUR)        44.210.000</a:t>
             </a:r>
             <a:endParaRPr lang="es-ES" sz="1200"/>
           </a:p>
@@ -35100,7 +35100,7 @@
                 </a:solidFill>
                 <a:latin typeface="Consolas"/>
               </a:rPr>
-              <a:t>PV acumulado     12,092,032   % planificado 27.4 %</a:t>
+              <a:t>PV acumulado     12.092.032   % planificado 27,4 %</a:t>
             </a:r>
             <a:endParaRPr lang="es-ES" sz="1200"/>
           </a:p>
@@ -35117,7 +35117,7 @@
                 </a:solidFill>
                 <a:latin typeface="Consolas"/>
               </a:rPr>
-              <a:t>EV acumulado     10,190,540   % completado  23.1 %</a:t>
+              <a:t>EV acumulado     10.190.540   % completado  23,1 %</a:t>
             </a:r>
             <a:endParaRPr lang="es-ES" sz="1200"/>
           </a:p>
@@ -35134,7 +35134,7 @@
                 </a:solidFill>
                 <a:latin typeface="Consolas"/>
               </a:rPr>
-              <a:t>AC acumulado     13,491,360   % gastado     30.5 %</a:t>
+              <a:t>AC acumulado     13.491.360   % gastado     30,5 %</a:t>
             </a:r>
             <a:endParaRPr lang="es-ES" sz="1200"/>
           </a:p>
@@ -35151,7 +35151,7 @@
                 </a:solidFill>
                 <a:latin typeface="Consolas"/>
               </a:rPr>
-              <a:t>SV = EV - PV     -1,901,492   SPI = 0.84</a:t>
+              <a:t>SV = EV - PV     -1.901.492   SPI = 0,84</a:t>
             </a:r>
             <a:endParaRPr lang="es-ES" sz="1200"/>
           </a:p>
@@ -35168,7 +35168,7 @@
                 </a:solidFill>
                 <a:latin typeface="Consolas"/>
               </a:rPr>
-              <a:t>CV = EV - AC     -3,300,820   CPI = 0.76</a:t>
+              <a:t>CV = EV - AC     -3.300.820   CPI = 0,76</a:t>
             </a:r>
             <a:endParaRPr lang="es-ES" sz="1200"/>
           </a:p>
@@ -35185,7 +35185,7 @@
                 </a:solidFill>
                 <a:latin typeface="Consolas"/>
               </a:rPr>
-              <a:t>EAC = BAC/CPI    58,530,071   VAC = -14,320,071</a:t>
+              <a:t>EAC = BAC/CPI    58.530.071   VAC = -14.320.071</a:t>
             </a:r>
             <a:endParaRPr lang="es-ES" sz="1200"/>
           </a:p>

</xml_diff>

<commit_message>
Versión 2.3.0: plazo según MS Project, tendencia de los índices y lista EDT
- Plazo según el cronograma de MS Project (#22): holgura total y tareas
  críticas leídas por COM y del XML; fin previsto, desvío de fin, holgura y
  crítica de cada elemento EDT en Indicadores EDT, Resumen, Cuadro de Mando,
  Análisis de desviaciones y salida de actualizar.
- Tendencia (#23): CPI y SPI de los últimos 3 meses y variación del CPI, el
  SPI y el EAC respecto del mes anterior con datos; tendencia de cada paquete
  en el análisis de desviaciones.
- Lista EDT (#27): clave [exportacion] lista_edt con los códigos que tienen
  fila en el libro, en lugar de nivel_maximo y del campo Visible.
- Códigos EDT con 0 intermedio (#28): 1.2.0.1 debajo de 1.2.0.0 es válido y
  de nivel 3.
- Versión del programa en la primera línea y barra de progreso con la tarea
  en curso, el % y el tiempo restante estimado.
- Documentación, capturas, proyecto de ejemplo y presentación actualizados.
</commit_message>
<xml_diff>
--- a/docs/presentacion-jefes-de-proyecto.pptx
+++ b/docs/presentacion-jefes-de-proyecto.pptx
@@ -7036,17 +7036,27 @@
           </a:p>
           <a:p>
             <a:r>
-              <a:t>6. Curva S.</a:t>
-            </a:r>
-          </a:p>
-          <a:p>
-            <a:r>
-              <a:t>7. Evolución de CPI y SPI sobre las zonas del semáforo (roja, amarilla, verde, amarilla y roja): mirar la tendencia más que el valor puntual. En los primeros meses los índices oscilan mucho porque los importes son pequeños.</a:t>
-            </a:r>
-          </a:p>
-          <a:p>
-            <a:r>
-              <a:t>8 y 9. Desempeño por elemento EDT: lo vemos en la siguiente diapositiva.</a:t>
+              <a:t>6. Tendencia: CPI y SPI de los últimos 3 meses (el desempeño reciente, que el acumulado diluye) y cuánto cambiaron el CPI, el SPI y el EAC respecto del mes anterior: es la frase del informe "el EAC subió X".</a:t>
+            </a:r>
+          </a:p>
+          <a:p>
+            <a:r>
+              <a:t>7. Plazo según MS Project: fin previsto frente al de la línea base, desvío de fin y paquetes críticos atrasados. El SPI no dice si el atraso afecta la fecha de fin; esta fila sí.</a:t>
+            </a:r>
+          </a:p>
+          <a:p>
+            <a:r>
+              <a:t>8. Curva S.</a:t>
+            </a:r>
+          </a:p>
+          <a:p>
+            <a:r>
+              <a:t>9. Evolución de CPI y SPI sobre las zonas del semáforo (roja, amarilla, verde, amarilla y roja): mirar la tendencia más que el valor puntual. En los primeros meses los índices oscilan mucho porque los importes son pequeños.</a:t>
+            </a:r>
+          </a:p>
+          <a:p>
+            <a:r>
+              <a:t>10 y 11. Desempeño por elemento EDT: lo vemos en la siguiente diapositiva.</a:t>
             </a:r>
           </a:p>
           <a:p/>
@@ -7569,6 +7579,11 @@
           <a:p>
             <a:r>
               <a:t>- Qué lista: cada mes, actualizar agrega los paquetes con SPI o CPI fuera del rango verde del semáforo, por debajo (atraso, sobrecosto) o por encima (por ejemplo, el CPI 1,10 de la PMO, con puestos sin cubrir). Los valores son fórmulas sobre las hojas PV, EV y AC.</a:t>
+            </a:r>
+          </a:p>
+          <a:p>
+            <a:r>
+              <a:t>- Junto a los índices, la tendencia del paquete (SPI y CPI del mes anterior: mejora, estable o empeora) y su plazo según MS Project (desvío de fin, holgura y si es crítico): ayudan a completar el impacto en plazo.</a:t>
             </a:r>
           </a:p>
           <a:p>
@@ -11564,7 +11579,7 @@
                 </a:solidFill>
                 <a:latin typeface="Calibri"/>
               </a:rPr>
-              <a:t>Versión 2.2.1</a:t>
+              <a:t>Versión 2.3.0</a:t>
             </a:r>
             <a:r>
               <a:rPr sz="1400" b="0" i="0" lang="es-ES">
@@ -38482,8 +38497,8 @@
         </p:blipFill>
         <p:spPr>
           <a:xfrm>
-            <a:off x="548640" y="1371600"/>
-            <a:ext cx="3474720" cy="4888523"/>
+            <a:off x="781570" y="1371600"/>
+            <a:ext cx="3008861" cy="4888523"/>
           </a:xfrm>
           <a:prstGeom prst="rect">
             <a:avLst/>
@@ -39047,7 +39062,7 @@
                 </a:solidFill>
                 <a:latin typeface="Calibri"/>
               </a:rPr>
-              <a:t>GRÁFICOS Y DETALLE</a:t>
+              <a:t>PLAZO, GRÁFICOS Y DETALLE</a:t>
             </a:r>
             <a:endParaRPr lang="es-ES" sz="1100"/>
           </a:p>
@@ -39088,7 +39103,7 @@
                 </a:solidFill>
                 <a:latin typeface="Calibri"/>
               </a:rPr>
-              <a:t>6</a:t>
+              <a:t>7</a:t>
             </a:r>
             <a:endParaRPr lang="es-ES" sz="1300"/>
           </a:p>
@@ -39124,7 +39139,7 @@
                 </a:solidFill>
                 <a:latin typeface="Calibri"/>
               </a:rPr>
-              <a:t>Evolución EVM</a:t>
+              <a:t>Plazo según MS Project</a:t>
             </a:r>
             <a:endParaRPr lang="es-ES" sz="1400"/>
           </a:p>
@@ -39137,7 +39152,7 @@
                 </a:solidFill>
                 <a:latin typeface="Calibri"/>
               </a:rPr>
-              <a:t>curva S con PV, EV, AC y BAC</a:t>
+              <a:t>fin previsto, desvío y paquetes críticos</a:t>
             </a:r>
             <a:endParaRPr lang="es-ES" sz="1400"/>
           </a:p>
@@ -39178,7 +39193,7 @@
                 </a:solidFill>
                 <a:latin typeface="Calibri"/>
               </a:rPr>
-              <a:t>7</a:t>
+              <a:t>8</a:t>
             </a:r>
             <a:endParaRPr lang="es-ES" sz="1300"/>
           </a:p>
@@ -39214,7 +39229,7 @@
                 </a:solidFill>
                 <a:latin typeface="Calibri"/>
               </a:rPr>
-              <a:t>Evolución de CPI y SPI</a:t>
+              <a:t>Evolución EVM</a:t>
             </a:r>
             <a:endParaRPr lang="es-ES" sz="1400"/>
           </a:p>
@@ -39227,7 +39242,7 @@
                 </a:solidFill>
                 <a:latin typeface="Calibri"/>
               </a:rPr>
-              <a:t>tendencia sobre zonas de alarma</a:t>
+              <a:t>curva S con PV, EV, AC y BAC</a:t>
             </a:r>
             <a:endParaRPr lang="es-ES" sz="1400"/>
           </a:p>
@@ -39268,7 +39283,7 @@
                 </a:solidFill>
                 <a:latin typeface="Calibri"/>
               </a:rPr>
-              <a:t>8</a:t>
+              <a:t>9</a:t>
             </a:r>
             <a:endParaRPr lang="es-ES" sz="1300"/>
           </a:p>
@@ -39304,7 +39319,7 @@
                 </a:solidFill>
                 <a:latin typeface="Calibri"/>
               </a:rPr>
-              <a:t>CPI vs SPI por elemento EDT</a:t>
+              <a:t>Evolución de CPI y SPI</a:t>
             </a:r>
             <a:endParaRPr lang="es-ES" sz="1400"/>
           </a:p>
@@ -39317,7 +39332,7 @@
                 </a:solidFill>
                 <a:latin typeface="Calibri"/>
               </a:rPr>
-              <a:t>dónde está el problema</a:t>
+              <a:t>tendencia sobre zonas de alarma</a:t>
             </a:r>
             <a:endParaRPr lang="es-ES" sz="1400"/>
           </a:p>
@@ -39358,7 +39373,7 @@
                 </a:solidFill>
                 <a:latin typeface="Calibri"/>
               </a:rPr>
-              <a:t>9</a:t>
+              <a:t>10</a:t>
             </a:r>
             <a:endParaRPr lang="es-ES" sz="1300"/>
           </a:p>
@@ -39394,7 +39409,7 @@
                 </a:solidFill>
                 <a:latin typeface="Calibri"/>
               </a:rPr>
-              <a:t>Tabla por elemento EDT</a:t>
+              <a:t>CPI vs SPI por elemento EDT</a:t>
             </a:r>
             <a:endParaRPr lang="es-ES" sz="1400"/>
           </a:p>
@@ -39407,7 +39422,7 @@
                 </a:solidFill>
                 <a:latin typeface="Calibri"/>
               </a:rPr>
-              <a:t>CPI, SPI y % completado</a:t>
+              <a:t>dónde está el problema</a:t>
             </a:r>
             <a:endParaRPr lang="es-ES" sz="1400"/>
           </a:p>
@@ -39421,8 +39436,8 @@
         </p:nvSpPr>
         <p:spPr>
           <a:xfrm>
-            <a:off x="8092440" y="4206240"/>
-            <a:ext cx="3520440" cy="1965960"/>
+            <a:off x="8092440" y="4773168"/>
+            <a:ext cx="3520440" cy="1399032"/>
           </a:xfrm>
           <a:prstGeom prst="roundRect">
             <a:avLst>
@@ -39476,7 +39491,7 @@
                 </a:solidFill>
                 <a:latin typeface="Calibri"/>
               </a:rPr>
-              <a:t>Mirar la tendencia de los últimos meses, </a:t>
+              <a:t>Mirar la tendencia y el desvío de fin, no solo el acumulado.</a:t>
             </a:r>
             <a:r>
               <a:rPr sz="1400" b="0" i="0" lang="es-ES">
@@ -39485,7 +39500,187 @@
                 </a:solidFill>
                 <a:latin typeface="Calibri"/>
               </a:rPr>
-              <a:t>no solo el valor acumulado.</a:t>
+              <a:t/>
+            </a:r>
+            <a:endParaRPr lang="es-ES" sz="1400"/>
+          </a:p>
+        </p:txBody>
+      </p:sp>
+      <p:sp>
+        <p:nvSpPr>
+          <p:cNvPr id="29" name="Oval 6 Tendencia"/>
+          <p:cNvSpPr/>
+          <p:nvPr/>
+        </p:nvSpPr>
+        <p:spPr>
+          <a:xfrm>
+            <a:off x="4443983" y="5285232"/>
+            <a:ext cx="347472" cy="347472"/>
+          </a:xfrm>
+          <a:prstGeom prst="ellipse">
+            <a:avLst/>
+          </a:prstGeom>
+          <a:solidFill>
+            <a:srgbClr val="C00000"/>
+          </a:solidFill>
+          <a:ln>
+            <a:noFill/>
+          </a:ln>
+        </p:spPr>
+        <p:txBody>
+          <a:bodyPr rtlCol="0" anchor="ctr" wrap="square" lIns="0" rIns="0" tIns="0" bIns="0">
+            <a:noAutofit/>
+          </a:bodyPr>
+          <a:lstStyle/>
+          <a:p>
+            <a:pPr algn="ctr"/>
+            <a:r>
+              <a:rPr sz="1300" b="1" i="0" lang="es-ES">
+                <a:solidFill>
+                  <a:srgbClr val="FFFFFF"/>
+                </a:solidFill>
+                <a:latin typeface="Calibri"/>
+              </a:rPr>
+              <a:t>6</a:t>
+            </a:r>
+            <a:endParaRPr lang="es-ES" sz="1300"/>
+          </a:p>
+        </p:txBody>
+      </p:sp>
+      <p:sp>
+        <p:nvSpPr>
+          <p:cNvPr id="30" name="TextBox 6 Tendencia"/>
+          <p:cNvSpPr txBox="1"/>
+          <p:nvPr/>
+        </p:nvSpPr>
+        <p:spPr>
+          <a:xfrm>
+            <a:off x="4910327" y="5239512"/>
+            <a:ext cx="3063240" cy="548640"/>
+          </a:xfrm>
+          <a:prstGeom prst="rect">
+            <a:avLst/>
+          </a:prstGeom>
+          <a:noFill/>
+        </p:spPr>
+        <p:txBody>
+          <a:bodyPr wrap="square" lIns="0" rIns="0" tIns="0" bIns="0" anchor="t">
+            <a:noAutofit/>
+          </a:bodyPr>
+          <a:lstStyle/>
+          <a:p>
+            <a:pPr algn="l"/>
+            <a:r>
+              <a:rPr sz="1400" b="1" i="0" lang="es-ES">
+                <a:solidFill>
+                  <a:srgbClr val="1B2B48"/>
+                </a:solidFill>
+                <a:latin typeface="Calibri"/>
+              </a:rPr>
+              <a:t>Tendencia</a:t>
+            </a:r>
+            <a:endParaRPr lang="es-ES" sz="1400"/>
+          </a:p>
+          <a:p>
+            <a:pPr algn="l"/>
+            <a:r>
+              <a:rPr sz="1300" b="0" i="0" lang="es-ES">
+                <a:solidFill>
+                  <a:srgbClr val="5A6577"/>
+                </a:solidFill>
+                <a:latin typeface="Calibri"/>
+              </a:rPr>
+              <a:t>CPI y SPI de 3 meses, Δ del mes anterior</a:t>
+            </a:r>
+            <a:endParaRPr lang="es-ES" sz="1400"/>
+          </a:p>
+        </p:txBody>
+      </p:sp>
+      <p:sp>
+        <p:nvSpPr>
+          <p:cNvPr id="31" name="Oval 25"/>
+          <p:cNvSpPr/>
+          <p:nvPr/>
+        </p:nvSpPr>
+        <p:spPr>
+          <a:xfrm>
+            <a:off x="8101583" y="4114800"/>
+            <a:ext cx="347472" cy="347472"/>
+          </a:xfrm>
+          <a:prstGeom prst="ellipse">
+            <a:avLst/>
+          </a:prstGeom>
+          <a:solidFill>
+            <a:srgbClr val="C00000"/>
+          </a:solidFill>
+          <a:ln>
+            <a:noFill/>
+          </a:ln>
+        </p:spPr>
+        <p:txBody>
+          <a:bodyPr rtlCol="0" anchor="ctr" wrap="square" lIns="0" rIns="0" tIns="0" bIns="0">
+            <a:noAutofit/>
+          </a:bodyPr>
+          <a:lstStyle/>
+          <a:p>
+            <a:pPr algn="ctr"/>
+            <a:r>
+              <a:rPr sz="1300" b="1" i="0" lang="es-ES">
+                <a:solidFill>
+                  <a:srgbClr val="FFFFFF"/>
+                </a:solidFill>
+                <a:latin typeface="Calibri"/>
+              </a:rPr>
+              <a:t>11</a:t>
+            </a:r>
+            <a:endParaRPr lang="es-ES" sz="1300"/>
+          </a:p>
+        </p:txBody>
+      </p:sp>
+      <p:sp>
+        <p:nvSpPr>
+          <p:cNvPr id="32" name="TextBox 26"/>
+          <p:cNvSpPr txBox="1"/>
+          <p:nvPr/>
+        </p:nvSpPr>
+        <p:spPr>
+          <a:xfrm>
+            <a:off x="8567928" y="4069080"/>
+            <a:ext cx="3063240" cy="548640"/>
+          </a:xfrm>
+          <a:prstGeom prst="rect">
+            <a:avLst/>
+          </a:prstGeom>
+          <a:noFill/>
+        </p:spPr>
+        <p:txBody>
+          <a:bodyPr wrap="square" lIns="0" rIns="0" tIns="0" bIns="0" anchor="t">
+            <a:noAutofit/>
+          </a:bodyPr>
+          <a:lstStyle/>
+          <a:p>
+            <a:pPr algn="l"/>
+            <a:r>
+              <a:rPr sz="1400" b="1" i="0" lang="es-ES">
+                <a:solidFill>
+                  <a:srgbClr val="1B2B48"/>
+                </a:solidFill>
+                <a:latin typeface="Calibri"/>
+              </a:rPr>
+              <a:t>Tabla por elemento EDT</a:t>
+            </a:r>
+            <a:endParaRPr lang="es-ES" sz="1400"/>
+          </a:p>
+          <a:p>
+            <a:pPr algn="l"/>
+            <a:r>
+              <a:rPr sz="1300" b="0" i="0" lang="es-ES">
+                <a:solidFill>
+                  <a:srgbClr val="5A6577"/>
+                </a:solidFill>
+                <a:latin typeface="Calibri"/>
+              </a:rPr>
+              <a:t>CPI, SPI y % completado</a:t>
             </a:r>
             <a:endParaRPr lang="es-ES" sz="1400"/>
           </a:p>
@@ -39677,8 +39872,8 @@
         </p:blipFill>
         <p:spPr>
           <a:xfrm>
-            <a:off x="548640" y="1463040"/>
-            <a:ext cx="6858000" cy="3498412"/>
+            <a:off x="548641" y="1463040"/>
+            <a:ext cx="6857998" cy="3498412"/>
           </a:xfrm>
           <a:prstGeom prst="rect">
             <a:avLst/>
@@ -41780,7 +41975,7 @@
         <p:spPr>
           <a:xfrm>
             <a:off x="548640" y="1417320"/>
-            <a:ext cx="11064240" cy="2633156"/>
+            <a:ext cx="11064240" cy="2262761"/>
           </a:xfrm>
           <a:prstGeom prst="rect">
             <a:avLst/>

</xml_diff>

<commit_message>
Versión 2.3.0: plazo según MS Project, tendencia de los índices y lista EDT (#29)
- Plazo según el cronograma de MS Project (#22): holgura total y tareas
  críticas leídas por COM y del XML; fin previsto, desvío de fin, holgura y
  crítica de cada elemento EDT en Indicadores EDT, Resumen, Cuadro de Mando,
  Análisis de desviaciones y salida de actualizar.
- Tendencia (#23): CPI y SPI de los últimos 3 meses y variación del CPI, el
  SPI y el EAC respecto del mes anterior con datos; tendencia de cada paquete
  en el análisis de desviaciones.
- Lista EDT (#27): clave [exportacion] lista_edt con los códigos que tienen
  fila en el libro, en lugar de nivel_maximo y del campo Visible.
- Códigos EDT con 0 intermedio (#28): 1.2.0.1 debajo de 1.2.0.0 es válido y
  de nivel 3.
- Versión del programa en la primera línea y barra de progreso con la tarea
  en curso, el % y el tiempo restante estimado.
- Documentación, capturas, proyecto de ejemplo y presentación actualizados.
</commit_message>
<xml_diff>
--- a/docs/presentacion-jefes-de-proyecto.pptx
+++ b/docs/presentacion-jefes-de-proyecto.pptx
@@ -7036,17 +7036,27 @@
           </a:p>
           <a:p>
             <a:r>
-              <a:t>6. Curva S.</a:t>
-            </a:r>
-          </a:p>
-          <a:p>
-            <a:r>
-              <a:t>7. Evolución de CPI y SPI sobre las zonas del semáforo (roja, amarilla, verde, amarilla y roja): mirar la tendencia más que el valor puntual. En los primeros meses los índices oscilan mucho porque los importes son pequeños.</a:t>
-            </a:r>
-          </a:p>
-          <a:p>
-            <a:r>
-              <a:t>8 y 9. Desempeño por elemento EDT: lo vemos en la siguiente diapositiva.</a:t>
+              <a:t>6. Tendencia: CPI y SPI de los últimos 3 meses (el desempeño reciente, que el acumulado diluye) y cuánto cambiaron el CPI, el SPI y el EAC respecto del mes anterior: es la frase del informe "el EAC subió X".</a:t>
+            </a:r>
+          </a:p>
+          <a:p>
+            <a:r>
+              <a:t>7. Plazo según MS Project: fin previsto frente al de la línea base, desvío de fin y paquetes críticos atrasados. El SPI no dice si el atraso afecta la fecha de fin; esta fila sí.</a:t>
+            </a:r>
+          </a:p>
+          <a:p>
+            <a:r>
+              <a:t>8. Curva S.</a:t>
+            </a:r>
+          </a:p>
+          <a:p>
+            <a:r>
+              <a:t>9. Evolución de CPI y SPI sobre las zonas del semáforo (roja, amarilla, verde, amarilla y roja): mirar la tendencia más que el valor puntual. En los primeros meses los índices oscilan mucho porque los importes son pequeños.</a:t>
+            </a:r>
+          </a:p>
+          <a:p>
+            <a:r>
+              <a:t>10 y 11. Desempeño por elemento EDT: lo vemos en la siguiente diapositiva.</a:t>
             </a:r>
           </a:p>
           <a:p/>
@@ -7569,6 +7579,11 @@
           <a:p>
             <a:r>
               <a:t>- Qué lista: cada mes, actualizar agrega los paquetes con SPI o CPI fuera del rango verde del semáforo, por debajo (atraso, sobrecosto) o por encima (por ejemplo, el CPI 1,10 de la PMO, con puestos sin cubrir). Los valores son fórmulas sobre las hojas PV, EV y AC.</a:t>
+            </a:r>
+          </a:p>
+          <a:p>
+            <a:r>
+              <a:t>- Junto a los índices, la tendencia del paquete (SPI y CPI del mes anterior: mejora, estable o empeora) y su plazo según MS Project (desvío de fin, holgura y si es crítico): ayudan a completar el impacto en plazo.</a:t>
             </a:r>
           </a:p>
           <a:p>
@@ -11564,7 +11579,7 @@
                 </a:solidFill>
                 <a:latin typeface="Calibri"/>
               </a:rPr>
-              <a:t>Versión 2.2.1</a:t>
+              <a:t>Versión 2.3.0</a:t>
             </a:r>
             <a:r>
               <a:rPr sz="1400" b="0" i="0" lang="es-ES">
@@ -38482,8 +38497,8 @@
         </p:blipFill>
         <p:spPr>
           <a:xfrm>
-            <a:off x="548640" y="1371600"/>
-            <a:ext cx="3474720" cy="4888523"/>
+            <a:off x="781570" y="1371600"/>
+            <a:ext cx="3008861" cy="4888523"/>
           </a:xfrm>
           <a:prstGeom prst="rect">
             <a:avLst/>
@@ -39047,7 +39062,7 @@
                 </a:solidFill>
                 <a:latin typeface="Calibri"/>
               </a:rPr>
-              <a:t>GRÁFICOS Y DETALLE</a:t>
+              <a:t>PLAZO, GRÁFICOS Y DETALLE</a:t>
             </a:r>
             <a:endParaRPr lang="es-ES" sz="1100"/>
           </a:p>
@@ -39088,7 +39103,7 @@
                 </a:solidFill>
                 <a:latin typeface="Calibri"/>
               </a:rPr>
-              <a:t>6</a:t>
+              <a:t>7</a:t>
             </a:r>
             <a:endParaRPr lang="es-ES" sz="1300"/>
           </a:p>
@@ -39124,7 +39139,7 @@
                 </a:solidFill>
                 <a:latin typeface="Calibri"/>
               </a:rPr>
-              <a:t>Evolución EVM</a:t>
+              <a:t>Plazo según MS Project</a:t>
             </a:r>
             <a:endParaRPr lang="es-ES" sz="1400"/>
           </a:p>
@@ -39137,7 +39152,7 @@
                 </a:solidFill>
                 <a:latin typeface="Calibri"/>
               </a:rPr>
-              <a:t>curva S con PV, EV, AC y BAC</a:t>
+              <a:t>fin previsto, desvío y paquetes críticos</a:t>
             </a:r>
             <a:endParaRPr lang="es-ES" sz="1400"/>
           </a:p>
@@ -39178,7 +39193,7 @@
                 </a:solidFill>
                 <a:latin typeface="Calibri"/>
               </a:rPr>
-              <a:t>7</a:t>
+              <a:t>8</a:t>
             </a:r>
             <a:endParaRPr lang="es-ES" sz="1300"/>
           </a:p>
@@ -39214,7 +39229,7 @@
                 </a:solidFill>
                 <a:latin typeface="Calibri"/>
               </a:rPr>
-              <a:t>Evolución de CPI y SPI</a:t>
+              <a:t>Evolución EVM</a:t>
             </a:r>
             <a:endParaRPr lang="es-ES" sz="1400"/>
           </a:p>
@@ -39227,7 +39242,7 @@
                 </a:solidFill>
                 <a:latin typeface="Calibri"/>
               </a:rPr>
-              <a:t>tendencia sobre zonas de alarma</a:t>
+              <a:t>curva S con PV, EV, AC y BAC</a:t>
             </a:r>
             <a:endParaRPr lang="es-ES" sz="1400"/>
           </a:p>
@@ -39268,7 +39283,7 @@
                 </a:solidFill>
                 <a:latin typeface="Calibri"/>
               </a:rPr>
-              <a:t>8</a:t>
+              <a:t>9</a:t>
             </a:r>
             <a:endParaRPr lang="es-ES" sz="1300"/>
           </a:p>
@@ -39304,7 +39319,7 @@
                 </a:solidFill>
                 <a:latin typeface="Calibri"/>
               </a:rPr>
-              <a:t>CPI vs SPI por elemento EDT</a:t>
+              <a:t>Evolución de CPI y SPI</a:t>
             </a:r>
             <a:endParaRPr lang="es-ES" sz="1400"/>
           </a:p>
@@ -39317,7 +39332,7 @@
                 </a:solidFill>
                 <a:latin typeface="Calibri"/>
               </a:rPr>
-              <a:t>dónde está el problema</a:t>
+              <a:t>tendencia sobre zonas de alarma</a:t>
             </a:r>
             <a:endParaRPr lang="es-ES" sz="1400"/>
           </a:p>
@@ -39358,7 +39373,7 @@
                 </a:solidFill>
                 <a:latin typeface="Calibri"/>
               </a:rPr>
-              <a:t>9</a:t>
+              <a:t>10</a:t>
             </a:r>
             <a:endParaRPr lang="es-ES" sz="1300"/>
           </a:p>
@@ -39394,7 +39409,7 @@
                 </a:solidFill>
                 <a:latin typeface="Calibri"/>
               </a:rPr>
-              <a:t>Tabla por elemento EDT</a:t>
+              <a:t>CPI vs SPI por elemento EDT</a:t>
             </a:r>
             <a:endParaRPr lang="es-ES" sz="1400"/>
           </a:p>
@@ -39407,7 +39422,7 @@
                 </a:solidFill>
                 <a:latin typeface="Calibri"/>
               </a:rPr>
-              <a:t>CPI, SPI y % completado</a:t>
+              <a:t>dónde está el problema</a:t>
             </a:r>
             <a:endParaRPr lang="es-ES" sz="1400"/>
           </a:p>
@@ -39421,8 +39436,8 @@
         </p:nvSpPr>
         <p:spPr>
           <a:xfrm>
-            <a:off x="8092440" y="4206240"/>
-            <a:ext cx="3520440" cy="1965960"/>
+            <a:off x="8092440" y="4773168"/>
+            <a:ext cx="3520440" cy="1399032"/>
           </a:xfrm>
           <a:prstGeom prst="roundRect">
             <a:avLst>
@@ -39476,7 +39491,7 @@
                 </a:solidFill>
                 <a:latin typeface="Calibri"/>
               </a:rPr>
-              <a:t>Mirar la tendencia de los últimos meses, </a:t>
+              <a:t>Mirar la tendencia y el desvío de fin, no solo el acumulado.</a:t>
             </a:r>
             <a:r>
               <a:rPr sz="1400" b="0" i="0" lang="es-ES">
@@ -39485,7 +39500,187 @@
                 </a:solidFill>
                 <a:latin typeface="Calibri"/>
               </a:rPr>
-              <a:t>no solo el valor acumulado.</a:t>
+              <a:t/>
+            </a:r>
+            <a:endParaRPr lang="es-ES" sz="1400"/>
+          </a:p>
+        </p:txBody>
+      </p:sp>
+      <p:sp>
+        <p:nvSpPr>
+          <p:cNvPr id="29" name="Oval 6 Tendencia"/>
+          <p:cNvSpPr/>
+          <p:nvPr/>
+        </p:nvSpPr>
+        <p:spPr>
+          <a:xfrm>
+            <a:off x="4443983" y="5285232"/>
+            <a:ext cx="347472" cy="347472"/>
+          </a:xfrm>
+          <a:prstGeom prst="ellipse">
+            <a:avLst/>
+          </a:prstGeom>
+          <a:solidFill>
+            <a:srgbClr val="C00000"/>
+          </a:solidFill>
+          <a:ln>
+            <a:noFill/>
+          </a:ln>
+        </p:spPr>
+        <p:txBody>
+          <a:bodyPr rtlCol="0" anchor="ctr" wrap="square" lIns="0" rIns="0" tIns="0" bIns="0">
+            <a:noAutofit/>
+          </a:bodyPr>
+          <a:lstStyle/>
+          <a:p>
+            <a:pPr algn="ctr"/>
+            <a:r>
+              <a:rPr sz="1300" b="1" i="0" lang="es-ES">
+                <a:solidFill>
+                  <a:srgbClr val="FFFFFF"/>
+                </a:solidFill>
+                <a:latin typeface="Calibri"/>
+              </a:rPr>
+              <a:t>6</a:t>
+            </a:r>
+            <a:endParaRPr lang="es-ES" sz="1300"/>
+          </a:p>
+        </p:txBody>
+      </p:sp>
+      <p:sp>
+        <p:nvSpPr>
+          <p:cNvPr id="30" name="TextBox 6 Tendencia"/>
+          <p:cNvSpPr txBox="1"/>
+          <p:nvPr/>
+        </p:nvSpPr>
+        <p:spPr>
+          <a:xfrm>
+            <a:off x="4910327" y="5239512"/>
+            <a:ext cx="3063240" cy="548640"/>
+          </a:xfrm>
+          <a:prstGeom prst="rect">
+            <a:avLst/>
+          </a:prstGeom>
+          <a:noFill/>
+        </p:spPr>
+        <p:txBody>
+          <a:bodyPr wrap="square" lIns="0" rIns="0" tIns="0" bIns="0" anchor="t">
+            <a:noAutofit/>
+          </a:bodyPr>
+          <a:lstStyle/>
+          <a:p>
+            <a:pPr algn="l"/>
+            <a:r>
+              <a:rPr sz="1400" b="1" i="0" lang="es-ES">
+                <a:solidFill>
+                  <a:srgbClr val="1B2B48"/>
+                </a:solidFill>
+                <a:latin typeface="Calibri"/>
+              </a:rPr>
+              <a:t>Tendencia</a:t>
+            </a:r>
+            <a:endParaRPr lang="es-ES" sz="1400"/>
+          </a:p>
+          <a:p>
+            <a:pPr algn="l"/>
+            <a:r>
+              <a:rPr sz="1300" b="0" i="0" lang="es-ES">
+                <a:solidFill>
+                  <a:srgbClr val="5A6577"/>
+                </a:solidFill>
+                <a:latin typeface="Calibri"/>
+              </a:rPr>
+              <a:t>CPI y SPI de 3 meses, Δ del mes anterior</a:t>
+            </a:r>
+            <a:endParaRPr lang="es-ES" sz="1400"/>
+          </a:p>
+        </p:txBody>
+      </p:sp>
+      <p:sp>
+        <p:nvSpPr>
+          <p:cNvPr id="31" name="Oval 25"/>
+          <p:cNvSpPr/>
+          <p:nvPr/>
+        </p:nvSpPr>
+        <p:spPr>
+          <a:xfrm>
+            <a:off x="8101583" y="4114800"/>
+            <a:ext cx="347472" cy="347472"/>
+          </a:xfrm>
+          <a:prstGeom prst="ellipse">
+            <a:avLst/>
+          </a:prstGeom>
+          <a:solidFill>
+            <a:srgbClr val="C00000"/>
+          </a:solidFill>
+          <a:ln>
+            <a:noFill/>
+          </a:ln>
+        </p:spPr>
+        <p:txBody>
+          <a:bodyPr rtlCol="0" anchor="ctr" wrap="square" lIns="0" rIns="0" tIns="0" bIns="0">
+            <a:noAutofit/>
+          </a:bodyPr>
+          <a:lstStyle/>
+          <a:p>
+            <a:pPr algn="ctr"/>
+            <a:r>
+              <a:rPr sz="1300" b="1" i="0" lang="es-ES">
+                <a:solidFill>
+                  <a:srgbClr val="FFFFFF"/>
+                </a:solidFill>
+                <a:latin typeface="Calibri"/>
+              </a:rPr>
+              <a:t>11</a:t>
+            </a:r>
+            <a:endParaRPr lang="es-ES" sz="1300"/>
+          </a:p>
+        </p:txBody>
+      </p:sp>
+      <p:sp>
+        <p:nvSpPr>
+          <p:cNvPr id="32" name="TextBox 26"/>
+          <p:cNvSpPr txBox="1"/>
+          <p:nvPr/>
+        </p:nvSpPr>
+        <p:spPr>
+          <a:xfrm>
+            <a:off x="8567928" y="4069080"/>
+            <a:ext cx="3063240" cy="548640"/>
+          </a:xfrm>
+          <a:prstGeom prst="rect">
+            <a:avLst/>
+          </a:prstGeom>
+          <a:noFill/>
+        </p:spPr>
+        <p:txBody>
+          <a:bodyPr wrap="square" lIns="0" rIns="0" tIns="0" bIns="0" anchor="t">
+            <a:noAutofit/>
+          </a:bodyPr>
+          <a:lstStyle/>
+          <a:p>
+            <a:pPr algn="l"/>
+            <a:r>
+              <a:rPr sz="1400" b="1" i="0" lang="es-ES">
+                <a:solidFill>
+                  <a:srgbClr val="1B2B48"/>
+                </a:solidFill>
+                <a:latin typeface="Calibri"/>
+              </a:rPr>
+              <a:t>Tabla por elemento EDT</a:t>
+            </a:r>
+            <a:endParaRPr lang="es-ES" sz="1400"/>
+          </a:p>
+          <a:p>
+            <a:pPr algn="l"/>
+            <a:r>
+              <a:rPr sz="1300" b="0" i="0" lang="es-ES">
+                <a:solidFill>
+                  <a:srgbClr val="5A6577"/>
+                </a:solidFill>
+                <a:latin typeface="Calibri"/>
+              </a:rPr>
+              <a:t>CPI, SPI y % completado</a:t>
             </a:r>
             <a:endParaRPr lang="es-ES" sz="1400"/>
           </a:p>
@@ -39677,8 +39872,8 @@
         </p:blipFill>
         <p:spPr>
           <a:xfrm>
-            <a:off x="548640" y="1463040"/>
-            <a:ext cx="6858000" cy="3498412"/>
+            <a:off x="548641" y="1463040"/>
+            <a:ext cx="6857998" cy="3498412"/>
           </a:xfrm>
           <a:prstGeom prst="rect">
             <a:avLst/>
@@ -41780,7 +41975,7 @@
         <p:spPr>
           <a:xfrm>
             <a:off x="548640" y="1417320"/>
-            <a:ext cx="11064240" cy="2633156"/>
+            <a:ext cx="11064240" cy="2262761"/>
           </a:xfrm>
           <a:prstGeom prst="rect">
             <a:avLst/>

</xml_diff>

<commit_message>
Versión 2.4.0: códigos de mensajes, evaluación DCMA y controles de la norma EIA-748-E
- CHANGELOG: la sección Sin publicar pasa a ser la entrada 2.4.0.
- Versión 2.4.0 en evm/__init__.py, en la portada de la presentación y en los ejemplos de salida de la
  documentación (comprobados con el tutorial de 24 meses). El tutorial explica el aviso ACT-048 de los dos
  últimos meses.
- Presentación: diapositiva nueva sobre los avisos del cierre, salidas de generar y actualizar con
  códigos, pestaña Registro de cambios, aviso del LOE y notas; PDF exportado de nuevo.
- Captura de la hoja Registro de cambios (capturas_excel.py la genera con una copia del libro del ejemplo
  con dos cambios) y nota sobre los libros anteriores a la 2.4.0 en El libro Excel.
- README: controles del cierre, códigos de los mensajes y documentos de evaluación DCMA y EIA-748-E.
</commit_message>
<xml_diff>
--- a/docs/presentacion-jefes-de-proyecto.pptx
+++ b/docs/presentacion-jefes-de-proyecto.pptx
@@ -40,6 +40,7 @@
     <p:sldId id="287" r:id="rId38"/>
     <p:sldId id="288" r:id="rId39"/>
     <p:sldId id="291" r:id="rId43"/>
+    <p:sldId id="293" r:id="rId45"/>
     <p:sldId id="289" r:id="rId40"/>
     <p:sldId id="290" r:id="rId41"/>
   </p:sldIdLst>
@@ -4573,6 +4574,12 @@
               <a:t>Las vamos a ver una a una en las siguientes diapositivas. Lo práctico: validar revisa en la terminal el archivo de MS Project (códigos EDT, fechas y duraciones, pesos, métodos, avance a la fecha de estado y lógica del cronograma), y generar deja en la hoja Validación los avisos que afectan al libro, así que no hay que revisarlo todo a mano. Lo que ningún control puede juzgar es si las duraciones y los pesos son realistas: eso es tarea del equipo.</a:t>
             </a:r>
           </a:p>
+          <a:p>
+            <a:r>
+              <a:rPr lang="es-ES"/>
+              <a:t>Cada aviso tiene un código, por ejemplo MET-004 (paquete demasiado largo para su método): en la documentación, Códigos de errores y advertencias, está la causa y qué hacer. Los avisos ya revisados se pueden silenciar en la configuración.</a:t>
+            </a:r>
+          </a:p>
         </p:txBody>
       </p:sp>
       <p:sp>
@@ -5388,14 +5395,14 @@
           <a:p>
             <a:r>
               <a:rPr lang="es-ES"/>
-              <a:t>6. Generar el libro nuevo con --migrar-desde, que conserva el BAC ingresado y el historial de EV y AC, escribir el BAC nuevo de los paquetes afectados y registrar en el informe la fecha, el motivo y la variación del BAC. Si se entregaron fichas de tareas al cliente, se vuelven a crear con generar-fichas.</a:t>
+              <a:t>6. Generar el libro nuevo con --migrar-desde, que conserva el BAC ingresado y el historial de EV y AC, escribir el BAC nuevo de los paquetes afectados y, después del siguiente actualizar, completar el motivo y el número de cambio aprobado en la hoja Registro de cambios, que registra cada cambio del BAC. Si se entregaron fichas de tareas al cliente, se vuelven a crear con generar-fichas.</a:t>
             </a:r>
           </a:p>
           <a:p/>
           <a:p>
             <a:r>
               <a:rPr lang="es-ES"/>
-              <a:t>Ojo: en las tareas cuya línea base se vuelve a guardar cambia también el PV de los meses ya informados; por eso se conserva el libro anterior como registro de lo informado.</a:t>
+              <a:t>Ojo: en las tareas cuya línea base se vuelve a guardar cambia también el PV de los meses ya informados; por eso se conserva el libro anterior como registro de lo informado. Si se guarda una línea base nueva en MS Project y se sigue actualizando el libro anterior, actualizar lo avisa (ACT-047).</a:t>
             </a:r>
           </a:p>
         </p:txBody>
@@ -5526,6 +5533,18 @@
               <a:t>- Los problemas aparecen tarde, cuando ya no hay margen para corregir.</a:t>
             </a:r>
           </a:p>
+          <a:p>
+            <a:r>
+              <a:rPr lang="es-ES"/>
+              <a:t/>
+            </a:r>
+          </a:p>
+          <a:p>
+            <a:r>
+              <a:rPr lang="es-ES"/>
+              <a:t>El programa lo detecta: actualizar compara el % planificado de la línea base de MS Project con el del libro y avisa de las filas que cambiaron, con el PV acumulado según cada una (ACT-047).</a:t>
+            </a:r>
+          </a:p>
         </p:txBody>
       </p:sp>
       <p:sp>
@@ -5722,6 +5741,18 @@
               <a:t>- El BAC sin ingresar: después de generar hay que escribir el BAC de cada paquete; si falta, el PV y el EV quedan en 0 y actualizar lo avisa.</a:t>
             </a:r>
           </a:p>
+          <a:p>
+            <a:r>
+              <a:rPr lang="es-ES"/>
+              <a:t/>
+            </a:r>
+          </a:p>
+          <a:p>
+            <a:r>
+              <a:rPr lang="es-ES"/>
+              <a:t>validar avisa también de las tareas programadas manualmente (FEC-008): sus fechas no siguen la lógica del cronograma.</a:t>
+            </a:r>
+          </a:p>
         </p:txBody>
       </p:sp>
       <p:sp>
@@ -5933,7 +5964,7 @@
           <a:p>
             <a:r>
               <a:rPr lang="es-ES"/>
-              <a:t>- Avance lineal (LOE): soporte sin entregables medibles que dura lo que dura el proyecto. Ejemplos: dirección del proyecto, PMO, control de proyectos, aseguramiento de calidad, administración de contratos, supervisión de obra, seguridad y salud. EV = PV, así que nunca muestra atraso: limitarlo a lo indispensable y no mezclarlo con trabajo medible.</a:t>
+              <a:t>- Avance lineal (LOE): soporte sin entregables medibles que dura lo que dura el proyecto. Ejemplos: dirección del proyecto, PMO, control de proyectos, aseguramiento de calidad, administración de contratos, supervisión de obra, seguridad y salud. EV = PV, así que nunca muestra atraso: limitarlo a lo indispensable y no mezclarlo con trabajo medible. actualizar avisa si las filas LOE superan el 15 % del BAC total (clave loe_maximo de la configuración).</a:t>
             </a:r>
           </a:p>
           <a:p/>
@@ -6214,7 +6245,7 @@
           <a:p>
             <a:r>
               <a:rPr lang="es-ES"/>
-              <a:t>4. Ejecutar validar: revisa en la terminal, sin crear archivos, los códigos EDT, las fechas, los pesos y los métodos, el avance a la fecha de estado (tareas sin actualizar, fechas reales incoherentes, índice BEI) y la lógica del cronograma. Se corrige en MS Project hasta que no queden errores ni trabajo pendiente antes de la fecha de estado.</a:t>
+              <a:t>4. Ejecutar validar: revisa en la terminal, sin crear archivos, los códigos EDT, las fechas, los pesos y los métodos, el avance a la fecha de estado (tareas sin actualizar, fechas reales incoherentes, avance fuera de secuencia, índice BEI y tareas incumplidas) y la lógica del cronograma (vínculos, holgura, duraciones largas, tareas manuales y camino crítico), con los criterios DCMA. Se corrige en MS Project hasta que no queden errores ni trabajo pendiente antes de la fecha de estado.</a:t>
             </a:r>
           </a:p>
           <a:p>
@@ -6227,7 +6258,7 @@
           <a:p>
             <a:r>
               <a:rPr lang="es-ES"/>
-              <a:t>Aunque el informe sea bimestral, conviene registrar el estado todos los meses: la curva S es mensual y las desviaciones se detectan antes.</a:t>
+              <a:t>Aunque el informe sea bimestral, conviene registrar el estado todos los meses: la curva S es mensual y las desviaciones se detectan antes. Si falta un mes, actualizar lo avisa.</a:t>
             </a:r>
           </a:p>
         </p:txBody>
@@ -6396,7 +6427,7 @@
           </a:p>
           <a:p>
             <a:r>
-              <a:t>- validar: antes de generar y antes de cada actualizar. Revisa el archivo de MS Project sin crear archivos: códigos EDT, fechas y duraciones, pesos de los hitos, método frente a la duración del paquete, avance a la fecha de estado y lógica del cronograma (criterios DCMA). Termina con código 1 si hay errores.</a:t>
+              <a:t>- validar: antes de generar y antes de cada actualizar. Revisa el archivo de MS Project sin crear archivos: códigos EDT, fechas y duraciones, pesos de los hitos, método frente a la duración del paquete, avance a la fecha de estado y lógica del cronograma (criterios DCMA). Termina con código 1 si hay errores. Cada observación tiene un código (por ejemplo MET-004), explicado en la documentación.</a:t>
             </a:r>
           </a:p>
           <a:p>
@@ -6425,7 +6456,7 @@
           <a:p/>
           <a:p>
             <a:r>
-              <a:t>Además de los indicadores, actualizar lista los paquetes fuera de umbral en la hoja Análisis de desviaciones (la vemos en el último bloque).</a:t>
+              <a:t>Además de los indicadores, actualizar lista los paquetes fuera de umbral en la hoja Análisis de desviaciones (la vemos en el último bloque) y avisa de los datos del cierre incoherentes o cambiados, que quedan en la hoja Registro de cambios.</a:t>
             </a:r>
           </a:p>
         </p:txBody>
@@ -6513,6 +6544,18 @@
               <a:t>En el ejemplo: 36 filas EDT, 24 de ellas de ingreso (paquetes); 14 tareas sin código (actividades e hitos) que se sumaron en su paquete, que es lo esperado; y una fila sin método de medición, que hay que completar.</a:t>
             </a:r>
           </a:p>
+          <a:p>
+            <a:r>
+              <a:rPr lang="es-ES"/>
+              <a:t/>
+            </a:r>
+          </a:p>
+          <a:p>
+            <a:r>
+              <a:rPr lang="es-ES"/>
+              <a:t>Cada observación lleva su código (EDT-022, MET-005...): en la documentación, Códigos de errores y advertencias, están la causa y qué hacer. Las que ya se revisaron se pueden silenciar en la configuración.</a:t>
+            </a:r>
+          </a:p>
           <a:p/>
           <a:p>
             <a:r>
@@ -6628,7 +6671,7 @@
           </a:p>
           <a:p>
             <a:r>
-              <a:t>2. Revisar las observaciones por fila: métodos no definidos, valores del mes negativos (por ejemplo, una corrección de avance), tareas sin fila, filas con avance y sin BAC. Si algo no es razonable, se corrige en MS Project y se vuelve a simular.</a:t>
+              <a:t>2. Revisar las observaciones por fila: métodos no definidos, valores del mes negativos (por ejemplo, una corrección de avance), tareas sin fila, filas con avance y sin BAC. Si algo no es razonable, se corrige en MS Project y se vuelve a simular. También aparecen los avisos del cierre, que vemos en el último bloque: a diciembre de 2027 el ejemplo avisa que el EAC es poco realista (ACT-048: TCPI 1,11 frente a CPI 0,76).</a:t>
             </a:r>
           </a:p>
           <a:p>
@@ -6736,7 +6779,7 @@
           </a:p>
           <a:p>
             <a:r>
-              <a:t>- Gris: control (Validación y Listas de métodos).</a:t>
+              <a:t>- Gris: control. Validación; Registro de cambios, con los cambios del BAC y de los meses ya informados que detectan actualizar y analizar (se completan a mano el motivo y el número de cambio aprobado; las filas no se borran); y Listas de métodos.</a:t>
             </a:r>
           </a:p>
           <a:p/>
@@ -6748,7 +6791,7 @@
           <a:p/>
           <a:p>
             <a:r>
-              <a:t>Las hojas ocultas (_graficos, _estructura, _meta) no se tocan. Y se recomienda archivar una copia del libro de cada informe emitido.</a:t>
+              <a:t>Las hojas ocultas (_graficos, _estructura, _meta, _registro) no se tocan. Y se recomienda archivar una copia del libro de cada informe emitido.</a:t>
             </a:r>
           </a:p>
         </p:txBody>
@@ -6994,7 +7037,7 @@
           <a:lstStyle/>
           <a:p>
             <a:r>
-              <a:t>Tiempo: 0:55 min  ·  Acumulado: 22:55 min</a:t>
+              <a:t>Tiempo: 0:50 min  ·  Acumulado: 22:50 min</a:t>
             </a:r>
           </a:p>
           <a:p/>
@@ -7132,7 +7175,7 @@
           <a:lstStyle/>
           <a:p>
             <a:r>
-              <a:t>Tiempo: 0:40 min  ·  Acumulado: 23:35 min</a:t>
+              <a:t>Tiempo: 0:35 min  ·  Acumulado: 23:25 min</a:t>
             </a:r>
           </a:p>
           <a:p/>
@@ -7235,7 +7278,7 @@
           <a:lstStyle/>
           <a:p>
             <a:r>
-              <a:t>Tiempo: 0:40 min  ·  Acumulado: 24:15 min</a:t>
+              <a:t>Tiempo: 0:35 min  ·  Acumulado: 24:00 min</a:t>
             </a:r>
           </a:p>
           <a:p/>
@@ -7261,7 +7304,7 @@
           </a:p>
           <a:p>
             <a:r>
-              <a:t>- TCPI muy superior al CPI: terminar en el BAC exige una eficiencia irreal; una regla práctica es una diferencia mayor de 0,05 a 0,10. Informar el EAC y evaluar un cambio de línea base o de alcance.</a:t>
+              <a:t>- TCPI muy superior al CPI: terminar en el BAC exige una eficiencia irreal; una regla práctica es una diferencia mayor de 0,05 a 0,10; desde el 20 % completado, actualizar avisa si supera 0,10. Revisar e informar el EAC y evaluar un cambio de línea base o de alcance.</a:t>
             </a:r>
           </a:p>
           <a:p>
@@ -7271,7 +7314,7 @@
           </a:p>
           <a:p>
             <a:r>
-              <a:t>- EV con AC cero en una fila: costo real aún no registrado (facturas pendientes, AC del ERP).</a:t>
+              <a:t>- EV con AC cero en una fila: costo real aún no registrado (facturas pendientes, AC del ERP). actualizar y analizar lo avisan.</a:t>
             </a:r>
           </a:p>
         </p:txBody>
@@ -7341,7 +7384,7 @@
           <a:lstStyle/>
           <a:p>
             <a:r>
-              <a:t>Tiempo: 0:30 min  ·  Acumulado: 25:30 min</a:t>
+              <a:t>Tiempo: 0:20 min  ·  Acumulado: 25:30 min</a:t>
             </a:r>
           </a:p>
           <a:p/>
@@ -7368,12 +7411,12 @@
           </a:p>
           <a:p>
             <a:r>
-              <a:t>- D+4: actualizar --simular, revisión de observaciones, actualizar, carga del AC del ERP en el libro y analizar.</a:t>
-            </a:r>
-          </a:p>
-          <a:p>
-            <a:r>
-              <a:t>- D+5 a D+6: el Jefe de Proyecto analiza las desviaciones fuera de umbral con los responsables, en la hoja Análisis de desviaciones (causa, impacto, acción con responsable y fecha) y revisa el EAC.</a:t>
+              <a:t>- D+4: actualizar --simular, revisión de observaciones, actualizar, carga del AC del ERP en el libro y analizar, con la revisión de sus avisos (diapositiva anterior).</a:t>
+            </a:r>
+          </a:p>
+          <a:p>
+            <a:r>
+              <a:t>- D+5 a D+6: el Jefe de Proyecto analiza las desviaciones fuera de umbral con los responsables, en la hoja Análisis de desviaciones (causa, impacto, acción con responsable y fecha) y revisa el EAC. Se completan el motivo y el número de cambio de las filas nuevas de la hoja Registro de cambios.</a:t>
             </a:r>
           </a:p>
           <a:p>
@@ -7567,7 +7610,7 @@
           <a:lstStyle/>
           <a:p>
             <a:r>
-              <a:t>Tiempo: 0:45 min  ·  Acumulado: 25:00 min</a:t>
+              <a:t>Tiempo: 0:40 min  ·  Acumulado: 24:40 min</a:t>
             </a:r>
           </a:p>
           <a:p/>
@@ -7594,6 +7637,11 @@
           <a:p>
             <a:r>
               <a:t>- Qué se conserva: lo escrito se mantiene al repetir actualizar y al regenerar el libro con --migrar-desde. Si un paquete sigue fuera de umbral el mes siguiente, su texto se copia con la marca "se debe revisar", para actualizarlo en lugar de escribirlo de nuevo.</a:t>
+            </a:r>
+          </a:p>
+          <a:p>
+            <a:r>
+              <a:t>- En el cierre siguiente, actualizar avisa de las filas del mes anterior sin causa o sin acción, y de las acciones con la fecha compromiso vencida en paquetes que siguen fuera de umbral.</a:t>
             </a:r>
           </a:p>
           <a:p/>
@@ -7701,7 +7749,7 @@
           </a:p>
           <a:p>
             <a:r>
-              <a:t>4. Aprobar con la línea base (Jefe de Proyecto). Antes se revisa el conjunto: cuánto del BAC queda en LOE y en % completado (conviene acordar un tope), al menos un hito por mes y ningún paquete largo con 0/100. Si el EVM se informa al cliente, conviene acordar con él los criterios de medición.</a:t>
+              <a:t>4. Aprobar con la línea base (Jefe de Proyecto). Antes se revisa el conjunto: cuánto del BAC queda en LOE y en % completado (conviene acordar un tope: actualizar avisa si el LOE supera el 15 % del BAC, ajustable con loe_maximo), al menos un hito por mes y ningún paquete largo con 0/100. Si el EVM se informa al cliente, conviene acordar con él los criterios de medición.</a:t>
             </a:r>
           </a:p>
           <a:p>
@@ -7725,6 +7773,126 @@
           <a:p>
             <a:r>
               <a:t>Detalle en la documentación: Métodos de medición, sección 5.</a:t>
+            </a:r>
+          </a:p>
+        </p:txBody>
+      </p:sp>
+      <p:sp>
+        <p:nvSpPr>
+          <p:cNvPr id="4" name="Slide Number Placeholder 3"/>
+          <p:cNvSpPr>
+            <a:spLocks noGrp="1"/>
+          </p:cNvSpPr>
+          <p:nvPr>
+            <p:ph type="sldNum" idx="5" sz="quarter"/>
+          </p:nvPr>
+        </p:nvSpPr>
+        <p:spPr/>
+      </p:sp>
+    </p:spTree>
+  </p:cSld>
+  <p:clrMapOvr>
+    <a:masterClrMapping/>
+  </p:clrMapOvr>
+</p:notes>
+</file>
+
+<file path=ppt/notesSlides/notesSlide38.xml><?xml version="1.0" encoding="utf-8"?>
+<p:notes xmlns:a="http://schemas.openxmlformats.org/drawingml/2006/main" xmlns:p="http://schemas.openxmlformats.org/presentationml/2006/main" xmlns:r="http://schemas.openxmlformats.org/officeDocument/2006/relationships">
+  <p:cSld>
+    <p:spTree>
+      <p:nvGrpSpPr>
+        <p:cNvPr id="1" name=""/>
+        <p:cNvGrpSpPr/>
+        <p:nvPr/>
+      </p:nvGrpSpPr>
+      <p:grpSpPr>
+        <a:xfrm>
+          <a:off x="0" y="0"/>
+          <a:ext cx="0" cy="0"/>
+          <a:chOff x="0" y="0"/>
+          <a:chExt cx="0" cy="0"/>
+        </a:xfrm>
+      </p:grpSpPr>
+      <p:sp>
+        <p:nvSpPr>
+          <p:cNvPr id="2" name="Slide Image Placeholder 1"/>
+          <p:cNvSpPr>
+            <a:spLocks noGrp="1"/>
+          </p:cNvSpPr>
+          <p:nvPr>
+            <p:ph type="sldImg" idx="2"/>
+          </p:nvPr>
+        </p:nvSpPr>
+        <p:spPr/>
+      </p:sp>
+      <p:sp>
+        <p:nvSpPr>
+          <p:cNvPr id="3" name="Notes Placeholder 2"/>
+          <p:cNvSpPr>
+            <a:spLocks noGrp="1"/>
+          </p:cNvSpPr>
+          <p:nvPr>
+            <p:ph type="body" idx="3" sz="quarter"/>
+          </p:nvPr>
+        </p:nvSpPr>
+        <p:spPr/>
+        <p:txBody>
+          <a:bodyPr/>
+          <a:lstStyle/>
+          <a:p>
+            <a:r>
+              <a:t>Tiempo: 0:30 min  ·  Acumulado: 25:10 min</a:t>
+            </a:r>
+          </a:p>
+          <a:p>
+            <a:r>
+              <a:t/>
+            </a:r>
+          </a:p>
+          <a:p>
+            <a:r>
+              <a:t>Además de los indicadores, actualizar y analizar revisan que los datos del cierre sean coherentes y que los cambios queden registrados, como pide la norma EIA-748-E para un sistema EVM. Son advertencias en la pantalla, cada una con su código, explicado en la documentación (Códigos de errores y advertencias).</a:t>
+            </a:r>
+          </a:p>
+          <a:p>
+            <a:r>
+              <a:t>- Registro de cambios: si cambia el BAC de un paquete o un valor de un mes ya informado (% ganado o AC), el cambio se agrega a la hoja Registro de cambios, con el valor anterior y el nuevo. Se completan el motivo y el número de cambio aprobado. Un BAC nuevo recalcula el PV y el EV de todos los meses del paquete: por eso se avisa.</a:t>
+            </a:r>
+          </a:p>
+          <a:p>
+            <a:r>
+              <a:t>- Línea base distinta: se guardó una línea base nueva en MS Project y el libro sigue con la anterior. Si el cambio está aprobado, se genera el libro nuevo con --migrar-desde; si no, se restaura la línea base.</a:t>
+            </a:r>
+          </a:p>
+          <a:p>
+            <a:r>
+              <a:t>- EV y AC incoherentes: paquetes con avance y sin costo (AC aún no registrado), con costo y sin avance (avance sin registrar o costo mal imputado) o con costo después de terminar.</a:t>
+            </a:r>
+          </a:p>
+          <a:p>
+            <a:r>
+              <a:t>- Meses sin informe: meses sin % ganado entre el último cierre y el actual. Aunque el informe sea bimestral, el avance se registra todos los meses.</a:t>
+            </a:r>
+          </a:p>
+          <a:p>
+            <a:r>
+              <a:t>- Análisis incompleto: desviaciones del mes anterior sin causa o sin acción, y acciones con la fecha compromiso vencida en paquetes que siguen fuera de umbral.</a:t>
+            </a:r>
+          </a:p>
+          <a:p>
+            <a:r>
+              <a:t>- EAC poco realista: desde el 20 % completado, el TCPI supera al CPI en más de 0,10. En el ejemplo, a diciembre de 2027: TCPI 1,11 frente a CPI 0,76. Se revisa el EAC y, si el desvío se confirma, se evalúa una línea base por encima del objetivo (OTB, Over Target Baseline), por control de cambios.</a:t>
+            </a:r>
+          </a:p>
+          <a:p>
+            <a:r>
+              <a:t/>
+            </a:r>
+          </a:p>
+          <a:p>
+            <a:r>
+              <a:t>Mensaje: el programa no corrige estos datos; avisa para que se revisen antes de emitir el informe.</a:t>
             </a:r>
           </a:p>
         </p:txBody>
@@ -11579,7 +11747,7 @@
                 </a:solidFill>
                 <a:latin typeface="Calibri"/>
               </a:rPr>
-              <a:t>Versión 2.3.0</a:t>
+              <a:t>Versión 2.4.0</a:t>
             </a:r>
             <a:r>
               <a:rPr sz="1400" b="0" i="0" lang="es-ES">
@@ -13876,7 +14044,7 @@
                 </a:solidFill>
                 <a:latin typeface="Calibri"/>
               </a:rPr>
-              <a:t>validar revisa el archivo de MS Project antes de exportar y generar deja los avisos del libro en la hoja </a:t>
+              <a:t>validar revisa el archivo de MS Project antes de exportar, con los criterios DCMA, y generar deja los avisos en la hoja </a:t>
             </a:r>
             <a:r>
               <a:rPr sz="1500" b="1" i="0" lang="es-ES">
@@ -13894,7 +14062,7 @@
                 </a:solidFill>
                 <a:latin typeface="Calibri"/>
               </a:rPr>
-              <a:t>, con la tarea afectada.</a:t>
+              <a:t>. Cada aviso tiene un código (MET-004...) con su causa y qué hacer.</a:t>
             </a:r>
             <a:endParaRPr lang="es-ES" sz="1500"/>
           </a:p>
@@ -27557,7 +27725,7 @@
                 </a:solidFill>
                 <a:latin typeface="Calibri"/>
               </a:rPr>
-              <a:t>siempre SPI = 1, diluye el atraso del proyecto.</a:t>
+              <a:t>siempre SPI = 1, diluye el atraso. actualizar avisa si supera el 15 % del BAC.</a:t>
             </a:r>
             <a:endParaRPr lang="es-ES" sz="1400"/>
           </a:p>
@@ -33411,7 +33579,7 @@
                 </a:solidFill>
                 <a:latin typeface="Consolas"/>
               </a:rPr>
-              <a:t>  [i] 14 tareas sin código EDT se agregaron en su</a:t>
+              <a:t>  [i] EDT-022 14 tareas sin código EDT se agregaron</a:t>
             </a:r>
             <a:endParaRPr lang="es-ES" sz="1200"/>
           </a:p>
@@ -33428,7 +33596,7 @@
                 </a:solidFill>
                 <a:latin typeface="Consolas"/>
               </a:rPr>
-              <a:t>      elemento EDT superior</a:t>
+              <a:t>      en su elemento EDT superior</a:t>
             </a:r>
             <a:endParaRPr lang="es-ES" sz="1200"/>
           </a:p>
@@ -33445,7 +33613,7 @@
                 </a:solidFill>
                 <a:latin typeface="Consolas"/>
               </a:rPr>
-              <a:t>  [i] 1 fila sin método de medición definido</a:t>
+              <a:t>  [i] MET-005 1 fila sin método de medición definido</a:t>
             </a:r>
             <a:endParaRPr lang="es-ES" sz="1200"/>
           </a:p>
@@ -34087,7 +34255,7 @@
                 </a:solidFill>
                 <a:latin typeface="Calibri"/>
               </a:rPr>
-              <a:t>14 tareas sin código EDT se agregaron en su elemento superior</a:t>
+              <a:t>EDT-022 · 14 tareas sin código EDT se agregaron en su elemento superior</a:t>
             </a:r>
             <a:endParaRPr lang="es-ES" sz="1200"/>
           </a:p>
@@ -34166,7 +34334,7 @@
                 </a:solidFill>
                 <a:latin typeface="Calibri"/>
               </a:rPr>
-              <a:t>Tareas sin fechas de línea base: se usan las actuales</a:t>
+              <a:t>FEC-010 · Tareas sin fechas de línea base: se usan las actuales</a:t>
             </a:r>
             <a:endParaRPr lang="es-ES" sz="1200"/>
           </a:p>
@@ -34245,7 +34413,7 @@
                 </a:solidFill>
                 <a:latin typeface="Calibri"/>
               </a:rPr>
-              <a:t>Pesos de hitos que suman más de 100: se escalan</a:t>
+              <a:t>HIT-007 · Pesos de hitos que suman más de 100: se escalan</a:t>
             </a:r>
             <a:endParaRPr lang="es-ES" sz="1200"/>
           </a:p>
@@ -34735,7 +34903,7 @@
                 </a:solidFill>
                 <a:latin typeface="Calibri"/>
               </a:rPr>
-              <a:t>Métodos sin definir, valores del mes negativos, tareas sin fila, filas sin BAC</a:t>
+              <a:t>Métodos sin definir, tareas sin fila, filas sin BAC y avisos del cierre (EAC, cambios, AC)</a:t>
             </a:r>
             <a:endParaRPr lang="es-ES" sz="1300"/>
           </a:p>
@@ -35047,7 +35215,7 @@
                 </a:solidFill>
                 <a:latin typeface="Consolas"/>
               </a:rPr>
-              <a:t>  4.2.2 Cierre administrativo: método no definido:</a:t>
+              <a:t>  [i] ACT-034 4.2.2 Cierre administrativo: método</a:t>
             </a:r>
             <a:endParaRPr lang="es-ES" sz="1200"/>
           </a:p>
@@ -35064,7 +35232,7 @@
                 </a:solidFill>
                 <a:latin typeface="Consolas"/>
               </a:rPr>
-              <a:t>        se usó % completado</a:t>
+              <a:t>        no definido: se usó % completado</a:t>
             </a:r>
             <a:endParaRPr lang="es-ES" sz="1200"/>
           </a:p>
@@ -35077,11 +35245,11 @@
             <a:r>
               <a:rPr sz="1200" b="0" i="0" lang="es-ES">
                 <a:solidFill>
-                  <a:srgbClr val="D7DEE9"/>
+                  <a:srgbClr val="F5C26B"/>
                 </a:solidFill>
                 <a:latin typeface="Consolas"/>
               </a:rPr>
-              <a:t/>
+              <a:t>  [!] ACT-048 TCPI 1,11 frente a CPI 0,76 a 12/2027</a:t>
             </a:r>
             <a:endParaRPr lang="es-ES" sz="1200"/>
           </a:p>
@@ -36649,7 +36817,7 @@
         <p:spPr>
           <a:xfrm>
             <a:off x="548640" y="1508760"/>
-            <a:ext cx="1340819" cy="411480"/>
+            <a:ext cx="1182315" cy="411480"/>
           </a:xfrm>
           <a:prstGeom prst="round2SameRect">
             <a:avLst>
@@ -36672,7 +36840,7 @@
           <a:p>
             <a:pPr algn="ctr"/>
             <a:r>
-              <a:rPr sz="1100" b="1" i="0" lang="es-ES">
+              <a:rPr sz="1000" b="1" i="0" lang="es-ES">
                 <a:solidFill>
                   <a:srgbClr val="FFFFFF"/>
                 </a:solidFill>
@@ -36692,8 +36860,8 @@
         </p:nvSpPr>
         <p:spPr>
           <a:xfrm>
-            <a:off x="1926035" y="1508760"/>
-            <a:ext cx="737715" cy="411480"/>
+            <a:off x="1767531" y="1508760"/>
+            <a:ext cx="624107" cy="411480"/>
           </a:xfrm>
           <a:prstGeom prst="round2SameRect">
             <a:avLst>
@@ -36716,7 +36884,7 @@
           <a:p>
             <a:pPr algn="ctr"/>
             <a:r>
-              <a:rPr sz="1100" b="1" i="0" lang="es-ES">
+              <a:rPr sz="1000" b="1" i="0" lang="es-ES">
                 <a:solidFill>
                   <a:srgbClr val="FFFFFF"/>
                 </a:solidFill>
@@ -36736,8 +36904,8 @@
         </p:nvSpPr>
         <p:spPr>
           <a:xfrm>
-            <a:off x="2700326" y="1508760"/>
-            <a:ext cx="360775" cy="411480"/>
+            <a:off x="2428214" y="1508760"/>
+            <a:ext cx="275227" cy="411480"/>
           </a:xfrm>
           <a:prstGeom prst="round2SameRect">
             <a:avLst>
@@ -36760,7 +36928,7 @@
           <a:p>
             <a:pPr algn="ctr"/>
             <a:r>
-              <a:rPr sz="1100" b="1" i="0" lang="es-ES">
+              <a:rPr sz="1000" b="1" i="0" lang="es-ES">
                 <a:solidFill>
                   <a:srgbClr val="1B2B48"/>
                 </a:solidFill>
@@ -36780,8 +36948,8 @@
         </p:nvSpPr>
         <p:spPr>
           <a:xfrm>
-            <a:off x="3097677" y="1508760"/>
-            <a:ext cx="511551" cy="411480"/>
+            <a:off x="2740017" y="1508760"/>
+            <a:ext cx="414779" cy="411480"/>
           </a:xfrm>
           <a:prstGeom prst="round2SameRect">
             <a:avLst>
@@ -36804,7 +36972,7 @@
           <a:p>
             <a:pPr algn="ctr"/>
             <a:r>
-              <a:rPr sz="1100" b="1" i="0" lang="es-ES">
+              <a:rPr sz="1000" b="1" i="0" lang="es-ES">
                 <a:solidFill>
                   <a:srgbClr val="1B2B48"/>
                 </a:solidFill>
@@ -36824,8 +36992,8 @@
         </p:nvSpPr>
         <p:spPr>
           <a:xfrm>
-            <a:off x="3645804" y="1508760"/>
-            <a:ext cx="360775" cy="411480"/>
+            <a:off x="3191372" y="1508760"/>
+            <a:ext cx="275227" cy="411480"/>
           </a:xfrm>
           <a:prstGeom prst="round2SameRect">
             <a:avLst>
@@ -36848,7 +37016,7 @@
           <a:p>
             <a:pPr algn="ctr"/>
             <a:r>
-              <a:rPr sz="1100" b="1" i="0" lang="es-ES">
+              <a:rPr sz="1000" b="1" i="0" lang="es-ES">
                 <a:solidFill>
                   <a:srgbClr val="1B2B48"/>
                 </a:solidFill>
@@ -36868,8 +37036,8 @@
         </p:nvSpPr>
         <p:spPr>
           <a:xfrm>
-            <a:off x="4043155" y="1508760"/>
-            <a:ext cx="511551" cy="411480"/>
+            <a:off x="3503175" y="1508760"/>
+            <a:ext cx="414779" cy="411480"/>
           </a:xfrm>
           <a:prstGeom prst="round2SameRect">
             <a:avLst>
@@ -36892,7 +37060,7 @@
           <a:p>
             <a:pPr algn="ctr"/>
             <a:r>
-              <a:rPr sz="1100" b="1" i="0" lang="es-ES">
+              <a:rPr sz="1000" b="1" i="0" lang="es-ES">
                 <a:solidFill>
                   <a:srgbClr val="1B2B48"/>
                 </a:solidFill>
@@ -36912,8 +37080,8 @@
         </p:nvSpPr>
         <p:spPr>
           <a:xfrm>
-            <a:off x="4591282" y="1508760"/>
-            <a:ext cx="360775" cy="411480"/>
+            <a:off x="3954530" y="1508760"/>
+            <a:ext cx="275227" cy="411480"/>
           </a:xfrm>
           <a:prstGeom prst="round2SameRect">
             <a:avLst>
@@ -36936,7 +37104,7 @@
           <a:p>
             <a:pPr algn="ctr"/>
             <a:r>
-              <a:rPr sz="1100" b="1" i="0" lang="es-ES">
+              <a:rPr sz="1000" b="1" i="0" lang="es-ES">
                 <a:solidFill>
                   <a:srgbClr val="1B2B48"/>
                 </a:solidFill>
@@ -36956,8 +37124,8 @@
         </p:nvSpPr>
         <p:spPr>
           <a:xfrm>
-            <a:off x="4988633" y="1508760"/>
-            <a:ext cx="1491595" cy="411480"/>
+            <a:off x="4266333" y="1508760"/>
+            <a:ext cx="1321867" cy="411480"/>
           </a:xfrm>
           <a:prstGeom prst="round2SameRect">
             <a:avLst>
@@ -36980,7 +37148,7 @@
           <a:p>
             <a:pPr algn="ctr"/>
             <a:r>
-              <a:rPr sz="1100" b="1" i="0" lang="es-ES">
+              <a:rPr sz="1000" b="1" i="0" lang="es-ES">
                 <a:solidFill>
                   <a:srgbClr val="FFFFFF"/>
                 </a:solidFill>
@@ -37000,8 +37168,8 @@
         </p:nvSpPr>
         <p:spPr>
           <a:xfrm>
-            <a:off x="6516804" y="1508760"/>
-            <a:ext cx="1340819" cy="411480"/>
+            <a:off x="5624776" y="1508760"/>
+            <a:ext cx="1182315" cy="411480"/>
           </a:xfrm>
           <a:prstGeom prst="round2SameRect">
             <a:avLst>
@@ -37024,7 +37192,7 @@
           <a:p>
             <a:pPr algn="ctr"/>
             <a:r>
-              <a:rPr sz="1100" b="1" i="0" lang="es-ES">
+              <a:rPr sz="1000" b="1" i="0" lang="es-ES">
                 <a:solidFill>
                   <a:srgbClr val="FFFFFF"/>
                 </a:solidFill>
@@ -37044,8 +37212,8 @@
         </p:nvSpPr>
         <p:spPr>
           <a:xfrm>
-            <a:off x="7894199" y="1508760"/>
-            <a:ext cx="2019311" cy="411480"/>
+            <a:off x="6843667" y="1508760"/>
+            <a:ext cx="1810298" cy="411480"/>
           </a:xfrm>
           <a:prstGeom prst="round2SameRect">
             <a:avLst>
@@ -37068,7 +37236,7 @@
           <a:p>
             <a:pPr algn="ctr"/>
             <a:r>
-              <a:rPr sz="1100" b="1" i="0" lang="es-ES">
+              <a:rPr sz="1000" b="1" i="0" lang="es-ES">
                 <a:solidFill>
                   <a:srgbClr val="FFFFFF"/>
                 </a:solidFill>
@@ -37082,14 +37250,14 @@
       </p:sp>
       <p:sp>
         <p:nvSpPr>
-          <p:cNvPr id="13" name="Round Same Side Corner Rectangle 12"/>
+          <p:cNvPr id="36" name="Pestaña Registro de cambios"/>
           <p:cNvSpPr/>
           <p:nvPr/>
         </p:nvSpPr>
         <p:spPr>
           <a:xfrm>
-            <a:off x="9950086" y="1508760"/>
-            <a:ext cx="963879" cy="411480"/>
+            <a:off x="8690541" y="1508760"/>
+            <a:ext cx="1461419" cy="411480"/>
           </a:xfrm>
           <a:prstGeom prst="round2SameRect">
             <a:avLst>
@@ -37112,13 +37280,13 @@
           <a:p>
             <a:pPr algn="ctr"/>
             <a:r>
-              <a:rPr sz="1100" b="1" i="0" lang="es-ES">
+              <a:rPr sz="1000" b="1" i="0" lang="es-ES">
                 <a:solidFill>
                   <a:srgbClr val="1B2B48"/>
                 </a:solidFill>
                 <a:latin typeface="Calibri"/>
               </a:rPr>
-              <a:t>Validación</a:t>
+              <a:t>Registro de cambios</a:t>
             </a:r>
             <a:endParaRPr lang="es-ES" sz="1200"/>
           </a:p>
@@ -37126,14 +37294,14 @@
       </p:sp>
       <p:sp>
         <p:nvSpPr>
-          <p:cNvPr id="14" name="Round Same Side Corner Rectangle 13"/>
+          <p:cNvPr id="13" name="Round Same Side Corner Rectangle 12"/>
           <p:cNvSpPr/>
           <p:nvPr/>
         </p:nvSpPr>
         <p:spPr>
           <a:xfrm>
-            <a:off x="10950541" y="1508760"/>
-            <a:ext cx="662338" cy="411480"/>
+            <a:off x="10188536" y="1508760"/>
+            <a:ext cx="833435" cy="411480"/>
           </a:xfrm>
           <a:prstGeom prst="round2SameRect">
             <a:avLst>
@@ -37156,7 +37324,51 @@
           <a:p>
             <a:pPr algn="ctr"/>
             <a:r>
-              <a:rPr sz="1100" b="1" i="0" lang="es-ES">
+              <a:rPr sz="1000" b="1" i="0" lang="es-ES">
+                <a:solidFill>
+                  <a:srgbClr val="1B2B48"/>
+                </a:solidFill>
+                <a:latin typeface="Calibri"/>
+              </a:rPr>
+              <a:t>Validación</a:t>
+            </a:r>
+            <a:endParaRPr lang="es-ES" sz="1200"/>
+          </a:p>
+        </p:txBody>
+      </p:sp>
+      <p:sp>
+        <p:nvSpPr>
+          <p:cNvPr id="14" name="Round Same Side Corner Rectangle 13"/>
+          <p:cNvSpPr/>
+          <p:nvPr/>
+        </p:nvSpPr>
+        <p:spPr>
+          <a:xfrm>
+            <a:off x="11058547" y="1508760"/>
+            <a:ext cx="554333" cy="411480"/>
+          </a:xfrm>
+          <a:prstGeom prst="round2SameRect">
+            <a:avLst>
+              <a:gd name="adj1" fmla="val 22222"/>
+              <a:gd name="adj2" fmla="val 0"/>
+            </a:avLst>
+          </a:prstGeom>
+          <a:solidFill>
+            <a:srgbClr val="AEB7C6"/>
+          </a:solidFill>
+          <a:ln>
+            <a:noFill/>
+          </a:ln>
+        </p:spPr>
+        <p:txBody>
+          <a:bodyPr rtlCol="0" anchor="ctr" wrap="square" lIns="36576" rIns="36576" tIns="0" bIns="0">
+            <a:noAutofit/>
+          </a:bodyPr>
+          <a:lstStyle/>
+          <a:p>
+            <a:pPr algn="ctr"/>
+            <a:r>
+              <a:rPr sz="1000" b="1" i="0" lang="es-ES">
                 <a:solidFill>
                   <a:srgbClr val="1B2B48"/>
                 </a:solidFill>
@@ -41998,6 +42210,1452 @@
 <file path=ppt/slides/slide36.xml><?xml version="1.0" encoding="utf-8"?>
 <p:sld xmlns:a="http://schemas.openxmlformats.org/drawingml/2006/main" xmlns:p="http://schemas.openxmlformats.org/presentationml/2006/main" xmlns:r="http://schemas.openxmlformats.org/officeDocument/2006/relationships">
   <p:cSld>
+    <p:spTree>
+      <p:nvGrpSpPr>
+        <p:cNvPr id="1" name=""/>
+        <p:cNvGrpSpPr/>
+        <p:nvPr/>
+      </p:nvGrpSpPr>
+      <p:grpSpPr/>
+      <p:sp>
+        <p:nvSpPr>
+          <p:cNvPr id="2" name="Title 1"/>
+          <p:cNvSpPr>
+            <a:spLocks noGrp="1"/>
+          </p:cNvSpPr>
+          <p:nvPr>
+            <p:ph type="title"/>
+          </p:nvPr>
+        </p:nvSpPr>
+        <p:spPr>
+          <a:xfrm>
+            <a:off x="548640" y="566928"/>
+            <a:ext cx="11064240" cy="685800"/>
+          </a:xfrm>
+        </p:spPr>
+        <p:txBody>
+          <a:bodyPr wrap="square" lIns="0" rIns="0" tIns="0" bIns="0" anchor="t">
+            <a:noAutofit/>
+          </a:bodyPr>
+          <a:lstStyle/>
+          <a:p>
+            <a:pPr algn="l"/>
+            <a:r>
+              <a:rPr sz="3200" b="1" i="0" lang="es-ES">
+                <a:solidFill>
+                  <a:srgbClr val="1B2B48"/>
+                </a:solidFill>
+                <a:latin typeface="Calibri"/>
+              </a:rPr>
+              <a:t>Los avisos del cierre: datos coherentes y trazables</a:t>
+            </a:r>
+            <a:endParaRPr lang="es-ES" sz="3200"/>
+          </a:p>
+        </p:txBody>
+      </p:sp>
+      <p:sp>
+        <p:nvSpPr>
+          <p:cNvPr id="3" name="TextBox 2"/>
+          <p:cNvSpPr txBox="1"/>
+          <p:nvPr/>
+        </p:nvSpPr>
+        <p:spPr>
+          <a:xfrm>
+            <a:off x="548640" y="274320"/>
+            <a:ext cx="7315200" cy="274320"/>
+          </a:xfrm>
+          <a:prstGeom prst="rect">
+            <a:avLst/>
+          </a:prstGeom>
+          <a:noFill/>
+        </p:spPr>
+        <p:txBody>
+          <a:bodyPr wrap="square" lIns="0" rIns="0" tIns="0" bIns="0" anchor="t">
+            <a:noAutofit/>
+          </a:bodyPr>
+          <a:lstStyle/>
+          <a:p>
+            <a:pPr algn="l"/>
+            <a:r>
+              <a:rPr sz="1100" b="1" i="0" lang="es-ES" spc="120">
+                <a:solidFill>
+                  <a:srgbClr val="8A5A00"/>
+                </a:solidFill>
+                <a:latin typeface="Calibri"/>
+              </a:rPr>
+              <a:t>PROCESO</a:t>
+            </a:r>
+            <a:endParaRPr lang="es-ES" sz="1100"/>
+          </a:p>
+        </p:txBody>
+      </p:sp>
+      <p:sp>
+        <p:nvSpPr>
+          <p:cNvPr id="4" name="TextBox 3"/>
+          <p:cNvSpPr txBox="1"/>
+          <p:nvPr/>
+        </p:nvSpPr>
+        <p:spPr>
+          <a:xfrm>
+            <a:off x="548640" y="6400800"/>
+            <a:ext cx="7315200" cy="274320"/>
+          </a:xfrm>
+          <a:prstGeom prst="rect">
+            <a:avLst/>
+          </a:prstGeom>
+          <a:noFill/>
+        </p:spPr>
+        <p:txBody>
+          <a:bodyPr wrap="square" lIns="0" rIns="0" tIns="0" bIns="0" anchor="t">
+            <a:noAutofit/>
+          </a:bodyPr>
+          <a:lstStyle/>
+          <a:p>
+            <a:pPr algn="l"/>
+            <a:r>
+              <a:rPr sz="1000" b="0" i="0" lang="es-ES">
+                <a:solidFill>
+                  <a:srgbClr val="5A6577"/>
+                </a:solidFill>
+                <a:latin typeface="Calibri"/>
+              </a:rPr>
+              <a:t>Exportador EVM · Sesión para equipo de proyecto</a:t>
+            </a:r>
+            <a:endParaRPr lang="es-ES" sz="1000"/>
+          </a:p>
+        </p:txBody>
+      </p:sp>
+      <p:sp>
+        <p:nvSpPr>
+          <p:cNvPr id="5" name="TextBox 4"/>
+          <p:cNvSpPr txBox="1"/>
+          <p:nvPr/>
+        </p:nvSpPr>
+        <p:spPr>
+          <a:xfrm>
+            <a:off x="10725912" y="6400800"/>
+            <a:ext cx="914400" cy="274320"/>
+          </a:xfrm>
+          <a:prstGeom prst="rect">
+            <a:avLst/>
+          </a:prstGeom>
+          <a:noFill/>
+        </p:spPr>
+        <p:txBody>
+          <a:bodyPr wrap="square" lIns="0" rIns="0" tIns="0" bIns="0" anchor="t">
+            <a:noAutofit/>
+          </a:bodyPr>
+          <a:lstStyle/>
+          <a:p>
+            <a:pPr algn="r"/>
+            <a:fld id="{B6F15528-21DE-4FAA-801E-634DDDAF4B2B}" type="slidenum">
+              <a:rPr lang="es-ES" sz="1000">
+                <a:solidFill>
+                  <a:srgbClr val="5A6577"/>
+                </a:solidFill>
+                <a:latin typeface="Calibri"/>
+              </a:rPr>
+              <a:t>36</a:t>
+            </a:fld>
+            <a:endParaRPr lang="es-ES" sz="1000"/>
+          </a:p>
+        </p:txBody>
+      </p:sp>
+      <p:sp>
+        <p:nvSpPr>
+          <p:cNvPr id="6" name="TextBox 5"/>
+          <p:cNvSpPr txBox="1"/>
+          <p:nvPr/>
+        </p:nvSpPr>
+        <p:spPr>
+          <a:xfrm>
+            <a:off x="731520" y="1463040"/>
+            <a:ext cx="3200400" cy="320040"/>
+          </a:xfrm>
+          <a:prstGeom prst="rect">
+            <a:avLst/>
+          </a:prstGeom>
+          <a:noFill/>
+        </p:spPr>
+        <p:txBody>
+          <a:bodyPr wrap="square" lIns="0" rIns="0" tIns="0" bIns="0" anchor="t">
+            <a:noAutofit/>
+          </a:bodyPr>
+          <a:lstStyle/>
+          <a:p>
+            <a:pPr algn="l"/>
+            <a:r>
+              <a:rPr sz="1200" b="1" i="0" lang="es-ES">
+                <a:solidFill>
+                  <a:srgbClr val="5A6577"/>
+                </a:solidFill>
+                <a:latin typeface="Calibri"/>
+              </a:rPr>
+              <a:t>AVISO</a:t>
+            </a:r>
+            <a:endParaRPr lang="es-ES" sz="1200"/>
+          </a:p>
+        </p:txBody>
+      </p:sp>
+      <p:sp>
+        <p:nvSpPr>
+          <p:cNvPr id="7" name="TextBox 6"/>
+          <p:cNvSpPr txBox="1"/>
+          <p:nvPr/>
+        </p:nvSpPr>
+        <p:spPr>
+          <a:xfrm>
+            <a:off x="4023360" y="1463040"/>
+            <a:ext cx="4114800" cy="320040"/>
+          </a:xfrm>
+          <a:prstGeom prst="rect">
+            <a:avLst/>
+          </a:prstGeom>
+          <a:noFill/>
+        </p:spPr>
+        <p:txBody>
+          <a:bodyPr wrap="square" lIns="0" rIns="0" tIns="0" bIns="0" anchor="t">
+            <a:noAutofit/>
+          </a:bodyPr>
+          <a:lstStyle/>
+          <a:p>
+            <a:pPr algn="l"/>
+            <a:r>
+              <a:rPr sz="1200" b="1" i="0" lang="es-ES">
+                <a:solidFill>
+                  <a:srgbClr val="5A6577"/>
+                </a:solidFill>
+                <a:latin typeface="Calibri"/>
+              </a:rPr>
+              <a:t>QUÉ DETECTA</a:t>
+            </a:r>
+            <a:endParaRPr lang="es-ES" sz="1200"/>
+          </a:p>
+        </p:txBody>
+      </p:sp>
+      <p:sp>
+        <p:nvSpPr>
+          <p:cNvPr id="8" name="TextBox 7"/>
+          <p:cNvSpPr txBox="1"/>
+          <p:nvPr/>
+        </p:nvSpPr>
+        <p:spPr>
+          <a:xfrm>
+            <a:off x="8229600" y="1463040"/>
+            <a:ext cx="3566160" cy="320040"/>
+          </a:xfrm>
+          <a:prstGeom prst="rect">
+            <a:avLst/>
+          </a:prstGeom>
+          <a:noFill/>
+        </p:spPr>
+        <p:txBody>
+          <a:bodyPr wrap="square" lIns="0" rIns="0" tIns="0" bIns="0" anchor="t">
+            <a:noAutofit/>
+          </a:bodyPr>
+          <a:lstStyle/>
+          <a:p>
+            <a:pPr algn="l"/>
+            <a:r>
+              <a:rPr sz="1200" b="1" i="0" lang="es-ES">
+                <a:solidFill>
+                  <a:srgbClr val="5A6577"/>
+                </a:solidFill>
+                <a:latin typeface="Calibri"/>
+              </a:rPr>
+              <a:t>QUÉ HACER</a:t>
+            </a:r>
+            <a:endParaRPr lang="es-ES" sz="1200"/>
+          </a:p>
+        </p:txBody>
+      </p:sp>
+      <p:sp>
+        <p:nvSpPr>
+          <p:cNvPr id="9" name="Rounded Rectangle 8"/>
+          <p:cNvSpPr/>
+          <p:nvPr/>
+        </p:nvSpPr>
+        <p:spPr>
+          <a:xfrm>
+            <a:off x="548640" y="1810512"/>
+            <a:ext cx="11064240" cy="658368"/>
+          </a:xfrm>
+          <a:prstGeom prst="roundRect">
+            <a:avLst>
+              <a:gd name="adj" fmla="val 11111"/>
+            </a:avLst>
+          </a:prstGeom>
+          <a:solidFill>
+            <a:srgbClr val="F3F5F9"/>
+          </a:solidFill>
+          <a:ln>
+            <a:noFill/>
+          </a:ln>
+        </p:spPr>
+        <p:txBody>
+          <a:bodyPr rtlCol="0" anchor="ctr" wrap="square" lIns="73152" rIns="73152" tIns="73152" bIns="73152">
+            <a:noAutofit/>
+          </a:bodyPr>
+          <a:lstStyle/>
+          <a:p>
+            <a:pPr algn="ctr"/>
+          </a:p>
+        </p:txBody>
+      </p:sp>
+      <p:sp>
+        <p:nvSpPr>
+          <p:cNvPr id="10" name="Oval 9"/>
+          <p:cNvSpPr/>
+          <p:nvPr/>
+        </p:nvSpPr>
+        <p:spPr>
+          <a:xfrm>
+            <a:off x="685800" y="2020824"/>
+            <a:ext cx="237744" cy="237744"/>
+          </a:xfrm>
+          <a:prstGeom prst="ellipse">
+            <a:avLst/>
+          </a:prstGeom>
+          <a:solidFill>
+            <a:srgbClr val="F2C14E"/>
+          </a:solidFill>
+          <a:ln>
+            <a:noFill/>
+          </a:ln>
+        </p:spPr>
+        <p:txBody>
+          <a:bodyPr rtlCol="0" anchor="ctr" wrap="square" lIns="0" rIns="0" tIns="0" bIns="0">
+            <a:noAutofit/>
+          </a:bodyPr>
+          <a:lstStyle/>
+          <a:p>
+            <a:pPr algn="ctr"/>
+            <a:r>
+              <a:rPr sz="1400" b="1" i="0" lang="es-ES">
+                <a:solidFill>
+                  <a:srgbClr val="FFFFFF"/>
+                </a:solidFill>
+                <a:latin typeface="Calibri"/>
+              </a:rPr>
+              <a:t/>
+            </a:r>
+            <a:endParaRPr lang="es-ES" sz="1400"/>
+          </a:p>
+        </p:txBody>
+      </p:sp>
+      <p:sp>
+        <p:nvSpPr>
+          <p:cNvPr id="11" name="TextBox 10"/>
+          <p:cNvSpPr txBox="1"/>
+          <p:nvPr/>
+        </p:nvSpPr>
+        <p:spPr>
+          <a:xfrm>
+            <a:off x="1051560" y="1810512"/>
+            <a:ext cx="2743200" cy="658368"/>
+          </a:xfrm>
+          <a:prstGeom prst="rect">
+            <a:avLst/>
+          </a:prstGeom>
+          <a:noFill/>
+        </p:spPr>
+        <p:txBody>
+          <a:bodyPr wrap="square" lIns="0" rIns="0" tIns="0" bIns="0" anchor="ctr">
+            <a:noAutofit/>
+          </a:bodyPr>
+          <a:lstStyle/>
+          <a:p>
+            <a:pPr algn="l"/>
+            <a:r>
+              <a:rPr sz="1400" b="1" i="0" lang="es-ES">
+                <a:solidFill>
+                  <a:srgbClr val="1B2B48"/>
+                </a:solidFill>
+                <a:latin typeface="Calibri"/>
+              </a:rPr>
+              <a:t>Registro de cambios</a:t>
+            </a:r>
+            <a:endParaRPr lang="es-ES" sz="1400"/>
+          </a:p>
+          <a:p>
+            <a:pPr algn="l"/>
+            <a:r>
+              <a:rPr sz="1100" b="0" i="0" lang="es-ES">
+                <a:solidFill>
+                  <a:srgbClr val="5A6577"/>
+                </a:solidFill>
+                <a:latin typeface="Calibri"/>
+              </a:rPr>
+              <a:t>ACT-036 · ACT-037</a:t>
+            </a:r>
+            <a:endParaRPr lang="es-ES" sz="1400"/>
+          </a:p>
+        </p:txBody>
+      </p:sp>
+      <p:sp>
+        <p:nvSpPr>
+          <p:cNvPr id="12" name="TextBox 11"/>
+          <p:cNvSpPr txBox="1"/>
+          <p:nvPr/>
+        </p:nvSpPr>
+        <p:spPr>
+          <a:xfrm>
+            <a:off x="4023360" y="1810512"/>
+            <a:ext cx="3931920" cy="658368"/>
+          </a:xfrm>
+          <a:prstGeom prst="rect">
+            <a:avLst/>
+          </a:prstGeom>
+          <a:noFill/>
+        </p:spPr>
+        <p:txBody>
+          <a:bodyPr wrap="square" lIns="0" rIns="0" tIns="0" bIns="0" anchor="ctr">
+            <a:noAutofit/>
+          </a:bodyPr>
+          <a:lstStyle/>
+          <a:p>
+            <a:pPr algn="l"/>
+            <a:r>
+              <a:rPr sz="1400" b="0" i="0" lang="es-ES">
+                <a:solidFill>
+                  <a:srgbClr val="5A6577"/>
+                </a:solidFill>
+                <a:latin typeface="Calibri"/>
+              </a:rPr>
+              <a:t>Cambió el BAC o un valor de un mes ya informado</a:t>
+            </a:r>
+            <a:endParaRPr lang="es-ES" sz="1400"/>
+          </a:p>
+        </p:txBody>
+      </p:sp>
+      <p:sp>
+        <p:nvSpPr>
+          <p:cNvPr id="13" name="TextBox 12"/>
+          <p:cNvSpPr txBox="1"/>
+          <p:nvPr/>
+        </p:nvSpPr>
+        <p:spPr>
+          <a:xfrm>
+            <a:off x="8229600" y="1810512"/>
+            <a:ext cx="3291840" cy="658368"/>
+          </a:xfrm>
+          <a:prstGeom prst="rect">
+            <a:avLst/>
+          </a:prstGeom>
+          <a:noFill/>
+        </p:spPr>
+        <p:txBody>
+          <a:bodyPr wrap="square" lIns="0" rIns="0" tIns="0" bIns="0" anchor="ctr">
+            <a:noAutofit/>
+          </a:bodyPr>
+          <a:lstStyle/>
+          <a:p>
+            <a:pPr algn="l"/>
+            <a:r>
+              <a:rPr sz="1400" b="0" i="0" lang="es-ES">
+                <a:solidFill>
+                  <a:srgbClr val="1B2B48"/>
+                </a:solidFill>
+                <a:latin typeface="Calibri"/>
+              </a:rPr>
+              <a:t>Anotar motivo y n.º de cambio aprobado</a:t>
+            </a:r>
+            <a:endParaRPr lang="es-ES" sz="1400"/>
+          </a:p>
+        </p:txBody>
+      </p:sp>
+      <p:sp>
+        <p:nvSpPr>
+          <p:cNvPr id="14" name="Rounded Rectangle 13"/>
+          <p:cNvSpPr/>
+          <p:nvPr/>
+        </p:nvSpPr>
+        <p:spPr>
+          <a:xfrm>
+            <a:off x="548640" y="2532888"/>
+            <a:ext cx="11064240" cy="658368"/>
+          </a:xfrm>
+          <a:prstGeom prst="roundRect">
+            <a:avLst>
+              <a:gd name="adj" fmla="val 11111"/>
+            </a:avLst>
+          </a:prstGeom>
+          <a:solidFill>
+            <a:srgbClr val="FFFFFF"/>
+          </a:solidFill>
+          <a:ln w="12700">
+            <a:solidFill>
+              <a:srgbClr val="D5DBE5"/>
+            </a:solidFill>
+          </a:ln>
+        </p:spPr>
+        <p:txBody>
+          <a:bodyPr rtlCol="0" anchor="ctr" wrap="square" lIns="73152" rIns="73152" tIns="73152" bIns="73152">
+            <a:noAutofit/>
+          </a:bodyPr>
+          <a:lstStyle/>
+          <a:p>
+            <a:pPr algn="ctr"/>
+          </a:p>
+        </p:txBody>
+      </p:sp>
+      <p:sp>
+        <p:nvSpPr>
+          <p:cNvPr id="15" name="Oval 14"/>
+          <p:cNvSpPr/>
+          <p:nvPr/>
+        </p:nvSpPr>
+        <p:spPr>
+          <a:xfrm>
+            <a:off x="685800" y="2743200"/>
+            <a:ext cx="237744" cy="237744"/>
+          </a:xfrm>
+          <a:prstGeom prst="ellipse">
+            <a:avLst/>
+          </a:prstGeom>
+          <a:solidFill>
+            <a:srgbClr val="F2C14E"/>
+          </a:solidFill>
+          <a:ln>
+            <a:noFill/>
+          </a:ln>
+        </p:spPr>
+        <p:txBody>
+          <a:bodyPr rtlCol="0" anchor="ctr" wrap="square" lIns="0" rIns="0" tIns="0" bIns="0">
+            <a:noAutofit/>
+          </a:bodyPr>
+          <a:lstStyle/>
+          <a:p>
+            <a:pPr algn="ctr"/>
+            <a:r>
+              <a:rPr sz="1400" b="1" i="0" lang="es-ES">
+                <a:solidFill>
+                  <a:srgbClr val="FFFFFF"/>
+                </a:solidFill>
+                <a:latin typeface="Calibri"/>
+              </a:rPr>
+              <a:t/>
+            </a:r>
+            <a:endParaRPr lang="es-ES" sz="1400"/>
+          </a:p>
+        </p:txBody>
+      </p:sp>
+      <p:sp>
+        <p:nvSpPr>
+          <p:cNvPr id="16" name="TextBox 15"/>
+          <p:cNvSpPr txBox="1"/>
+          <p:nvPr/>
+        </p:nvSpPr>
+        <p:spPr>
+          <a:xfrm>
+            <a:off x="1051560" y="2532888"/>
+            <a:ext cx="2743200" cy="658368"/>
+          </a:xfrm>
+          <a:prstGeom prst="rect">
+            <a:avLst/>
+          </a:prstGeom>
+          <a:noFill/>
+        </p:spPr>
+        <p:txBody>
+          <a:bodyPr wrap="square" lIns="0" rIns="0" tIns="0" bIns="0" anchor="ctr">
+            <a:noAutofit/>
+          </a:bodyPr>
+          <a:lstStyle/>
+          <a:p>
+            <a:pPr algn="l"/>
+            <a:r>
+              <a:rPr sz="1400" b="1" i="0" lang="es-ES">
+                <a:solidFill>
+                  <a:srgbClr val="1B2B48"/>
+                </a:solidFill>
+                <a:latin typeface="Calibri"/>
+              </a:rPr>
+              <a:t>Línea base distinta</a:t>
+            </a:r>
+            <a:endParaRPr lang="es-ES" sz="1400"/>
+          </a:p>
+          <a:p>
+            <a:pPr algn="l"/>
+            <a:r>
+              <a:rPr sz="1100" b="0" i="0" lang="es-ES">
+                <a:solidFill>
+                  <a:srgbClr val="5A6577"/>
+                </a:solidFill>
+                <a:latin typeface="Calibri"/>
+              </a:rPr>
+              <a:t>ACT-047</a:t>
+            </a:r>
+            <a:endParaRPr lang="es-ES" sz="1400"/>
+          </a:p>
+        </p:txBody>
+      </p:sp>
+      <p:sp>
+        <p:nvSpPr>
+          <p:cNvPr id="17" name="TextBox 16"/>
+          <p:cNvSpPr txBox="1"/>
+          <p:nvPr/>
+        </p:nvSpPr>
+        <p:spPr>
+          <a:xfrm>
+            <a:off x="4023360" y="2532888"/>
+            <a:ext cx="3931920" cy="658368"/>
+          </a:xfrm>
+          <a:prstGeom prst="rect">
+            <a:avLst/>
+          </a:prstGeom>
+          <a:noFill/>
+        </p:spPr>
+        <p:txBody>
+          <a:bodyPr wrap="square" lIns="0" rIns="0" tIns="0" bIns="0" anchor="ctr">
+            <a:noAutofit/>
+          </a:bodyPr>
+          <a:lstStyle/>
+          <a:p>
+            <a:pPr algn="l"/>
+            <a:r>
+              <a:rPr sz="1400" b="0" i="0" lang="es-ES">
+                <a:solidFill>
+                  <a:srgbClr val="5A6577"/>
+                </a:solidFill>
+                <a:latin typeface="Calibri"/>
+              </a:rPr>
+              <a:t>Se guardó una línea base nueva en MS Project</a:t>
+            </a:r>
+            <a:endParaRPr lang="es-ES" sz="1400"/>
+          </a:p>
+        </p:txBody>
+      </p:sp>
+      <p:sp>
+        <p:nvSpPr>
+          <p:cNvPr id="18" name="TextBox 17"/>
+          <p:cNvSpPr txBox="1"/>
+          <p:nvPr/>
+        </p:nvSpPr>
+        <p:spPr>
+          <a:xfrm>
+            <a:off x="8229600" y="2532888"/>
+            <a:ext cx="3291840" cy="658368"/>
+          </a:xfrm>
+          <a:prstGeom prst="rect">
+            <a:avLst/>
+          </a:prstGeom>
+          <a:noFill/>
+        </p:spPr>
+        <p:txBody>
+          <a:bodyPr wrap="square" lIns="0" rIns="0" tIns="0" bIns="0" anchor="ctr">
+            <a:noAutofit/>
+          </a:bodyPr>
+          <a:lstStyle/>
+          <a:p>
+            <a:pPr algn="l"/>
+            <a:r>
+              <a:rPr sz="1400" b="0" i="0" lang="es-ES">
+                <a:solidFill>
+                  <a:srgbClr val="1B2B48"/>
+                </a:solidFill>
+                <a:latin typeface="Calibri"/>
+              </a:rPr>
+              <a:t>Aprobada: generar --migrar-desde. Si no, restaurarla</a:t>
+            </a:r>
+            <a:endParaRPr lang="es-ES" sz="1400"/>
+          </a:p>
+        </p:txBody>
+      </p:sp>
+      <p:sp>
+        <p:nvSpPr>
+          <p:cNvPr id="19" name="Rounded Rectangle 18"/>
+          <p:cNvSpPr/>
+          <p:nvPr/>
+        </p:nvSpPr>
+        <p:spPr>
+          <a:xfrm>
+            <a:off x="548640" y="3255264"/>
+            <a:ext cx="11064240" cy="658368"/>
+          </a:xfrm>
+          <a:prstGeom prst="roundRect">
+            <a:avLst>
+              <a:gd name="adj" fmla="val 11111"/>
+            </a:avLst>
+          </a:prstGeom>
+          <a:solidFill>
+            <a:srgbClr val="F3F5F9"/>
+          </a:solidFill>
+          <a:ln>
+            <a:noFill/>
+          </a:ln>
+        </p:spPr>
+        <p:txBody>
+          <a:bodyPr rtlCol="0" anchor="ctr" wrap="square" lIns="73152" rIns="73152" tIns="73152" bIns="73152">
+            <a:noAutofit/>
+          </a:bodyPr>
+          <a:lstStyle/>
+          <a:p>
+            <a:pPr algn="ctr"/>
+          </a:p>
+        </p:txBody>
+      </p:sp>
+      <p:sp>
+        <p:nvSpPr>
+          <p:cNvPr id="20" name="Oval 19"/>
+          <p:cNvSpPr/>
+          <p:nvPr/>
+        </p:nvSpPr>
+        <p:spPr>
+          <a:xfrm>
+            <a:off x="685800" y="3465576"/>
+            <a:ext cx="237744" cy="237744"/>
+          </a:xfrm>
+          <a:prstGeom prst="ellipse">
+            <a:avLst/>
+          </a:prstGeom>
+          <a:solidFill>
+            <a:srgbClr val="F2C14E"/>
+          </a:solidFill>
+          <a:ln>
+            <a:noFill/>
+          </a:ln>
+        </p:spPr>
+        <p:txBody>
+          <a:bodyPr rtlCol="0" anchor="ctr" wrap="square" lIns="0" rIns="0" tIns="0" bIns="0">
+            <a:noAutofit/>
+          </a:bodyPr>
+          <a:lstStyle/>
+          <a:p>
+            <a:pPr algn="ctr"/>
+            <a:r>
+              <a:rPr sz="1400" b="1" i="0" lang="es-ES">
+                <a:solidFill>
+                  <a:srgbClr val="FFFFFF"/>
+                </a:solidFill>
+                <a:latin typeface="Calibri"/>
+              </a:rPr>
+              <a:t/>
+            </a:r>
+            <a:endParaRPr lang="es-ES" sz="1400"/>
+          </a:p>
+        </p:txBody>
+      </p:sp>
+      <p:sp>
+        <p:nvSpPr>
+          <p:cNvPr id="21" name="TextBox 20"/>
+          <p:cNvSpPr txBox="1"/>
+          <p:nvPr/>
+        </p:nvSpPr>
+        <p:spPr>
+          <a:xfrm>
+            <a:off x="1051560" y="3255264"/>
+            <a:ext cx="2743200" cy="658368"/>
+          </a:xfrm>
+          <a:prstGeom prst="rect">
+            <a:avLst/>
+          </a:prstGeom>
+          <a:noFill/>
+        </p:spPr>
+        <p:txBody>
+          <a:bodyPr wrap="square" lIns="0" rIns="0" tIns="0" bIns="0" anchor="ctr">
+            <a:noAutofit/>
+          </a:bodyPr>
+          <a:lstStyle/>
+          <a:p>
+            <a:pPr algn="l"/>
+            <a:r>
+              <a:rPr sz="1400" b="1" i="0" lang="es-ES">
+                <a:solidFill>
+                  <a:srgbClr val="1B2B48"/>
+                </a:solidFill>
+                <a:latin typeface="Calibri"/>
+              </a:rPr>
+              <a:t>EV y AC incoherentes</a:t>
+            </a:r>
+            <a:endParaRPr lang="es-ES" sz="1400"/>
+          </a:p>
+          <a:p>
+            <a:pPr algn="l"/>
+            <a:r>
+              <a:rPr sz="1100" b="0" i="0" lang="es-ES">
+                <a:solidFill>
+                  <a:srgbClr val="5A6577"/>
+                </a:solidFill>
+                <a:latin typeface="Calibri"/>
+              </a:rPr>
+              <a:t>ACT-039 a ACT-041</a:t>
+            </a:r>
+            <a:endParaRPr lang="es-ES" sz="1400"/>
+          </a:p>
+        </p:txBody>
+      </p:sp>
+      <p:sp>
+        <p:nvSpPr>
+          <p:cNvPr id="22" name="TextBox 21"/>
+          <p:cNvSpPr txBox="1"/>
+          <p:nvPr/>
+        </p:nvSpPr>
+        <p:spPr>
+          <a:xfrm>
+            <a:off x="4023360" y="3255264"/>
+            <a:ext cx="3931920" cy="658368"/>
+          </a:xfrm>
+          <a:prstGeom prst="rect">
+            <a:avLst/>
+          </a:prstGeom>
+          <a:noFill/>
+        </p:spPr>
+        <p:txBody>
+          <a:bodyPr wrap="square" lIns="0" rIns="0" tIns="0" bIns="0" anchor="ctr">
+            <a:noAutofit/>
+          </a:bodyPr>
+          <a:lstStyle/>
+          <a:p>
+            <a:pPr algn="l"/>
+            <a:r>
+              <a:rPr sz="1400" b="0" i="0" lang="es-ES">
+                <a:solidFill>
+                  <a:srgbClr val="5A6577"/>
+                </a:solidFill>
+                <a:latin typeface="Calibri"/>
+              </a:rPr>
+              <a:t>Avance sin costo, costo sin avance o costo después del 100 %</a:t>
+            </a:r>
+            <a:endParaRPr lang="es-ES" sz="1400"/>
+          </a:p>
+        </p:txBody>
+      </p:sp>
+      <p:sp>
+        <p:nvSpPr>
+          <p:cNvPr id="23" name="TextBox 22"/>
+          <p:cNvSpPr txBox="1"/>
+          <p:nvPr/>
+        </p:nvSpPr>
+        <p:spPr>
+          <a:xfrm>
+            <a:off x="8229600" y="3255264"/>
+            <a:ext cx="3291840" cy="658368"/>
+          </a:xfrm>
+          <a:prstGeom prst="rect">
+            <a:avLst/>
+          </a:prstGeom>
+          <a:noFill/>
+        </p:spPr>
+        <p:txBody>
+          <a:bodyPr wrap="square" lIns="0" rIns="0" tIns="0" bIns="0" anchor="ctr">
+            <a:noAutofit/>
+          </a:bodyPr>
+          <a:lstStyle/>
+          <a:p>
+            <a:pPr algn="l"/>
+            <a:r>
+              <a:rPr sz="1400" b="0" i="0" lang="es-ES">
+                <a:solidFill>
+                  <a:srgbClr val="1B2B48"/>
+                </a:solidFill>
+                <a:latin typeface="Calibri"/>
+              </a:rPr>
+              <a:t>Revisar el avance y la imputación del AC</a:t>
+            </a:r>
+            <a:endParaRPr lang="es-ES" sz="1400"/>
+          </a:p>
+        </p:txBody>
+      </p:sp>
+      <p:sp>
+        <p:nvSpPr>
+          <p:cNvPr id="24" name="Rounded Rectangle 23"/>
+          <p:cNvSpPr/>
+          <p:nvPr/>
+        </p:nvSpPr>
+        <p:spPr>
+          <a:xfrm>
+            <a:off x="548640" y="3977639"/>
+            <a:ext cx="11064240" cy="658368"/>
+          </a:xfrm>
+          <a:prstGeom prst="roundRect">
+            <a:avLst>
+              <a:gd name="adj" fmla="val 11111"/>
+            </a:avLst>
+          </a:prstGeom>
+          <a:solidFill>
+            <a:srgbClr val="FFFFFF"/>
+          </a:solidFill>
+          <a:ln w="12700">
+            <a:solidFill>
+              <a:srgbClr val="D5DBE5"/>
+            </a:solidFill>
+          </a:ln>
+        </p:spPr>
+        <p:txBody>
+          <a:bodyPr rtlCol="0" anchor="ctr" wrap="square" lIns="73152" rIns="73152" tIns="73152" bIns="73152">
+            <a:noAutofit/>
+          </a:bodyPr>
+          <a:lstStyle/>
+          <a:p>
+            <a:pPr algn="ctr"/>
+          </a:p>
+        </p:txBody>
+      </p:sp>
+      <p:sp>
+        <p:nvSpPr>
+          <p:cNvPr id="25" name="Oval 24"/>
+          <p:cNvSpPr/>
+          <p:nvPr/>
+        </p:nvSpPr>
+        <p:spPr>
+          <a:xfrm>
+            <a:off x="685800" y="4187952"/>
+            <a:ext cx="237744" cy="237744"/>
+          </a:xfrm>
+          <a:prstGeom prst="ellipse">
+            <a:avLst/>
+          </a:prstGeom>
+          <a:solidFill>
+            <a:srgbClr val="F2C14E"/>
+          </a:solidFill>
+          <a:ln>
+            <a:noFill/>
+          </a:ln>
+        </p:spPr>
+        <p:txBody>
+          <a:bodyPr rtlCol="0" anchor="ctr" wrap="square" lIns="0" rIns="0" tIns="0" bIns="0">
+            <a:noAutofit/>
+          </a:bodyPr>
+          <a:lstStyle/>
+          <a:p>
+            <a:pPr algn="ctr"/>
+            <a:r>
+              <a:rPr sz="1400" b="1" i="0" lang="es-ES">
+                <a:solidFill>
+                  <a:srgbClr val="FFFFFF"/>
+                </a:solidFill>
+                <a:latin typeface="Calibri"/>
+              </a:rPr>
+              <a:t/>
+            </a:r>
+            <a:endParaRPr lang="es-ES" sz="1400"/>
+          </a:p>
+        </p:txBody>
+      </p:sp>
+      <p:sp>
+        <p:nvSpPr>
+          <p:cNvPr id="26" name="TextBox 25"/>
+          <p:cNvSpPr txBox="1"/>
+          <p:nvPr/>
+        </p:nvSpPr>
+        <p:spPr>
+          <a:xfrm>
+            <a:off x="1051560" y="3977639"/>
+            <a:ext cx="2743200" cy="658368"/>
+          </a:xfrm>
+          <a:prstGeom prst="rect">
+            <a:avLst/>
+          </a:prstGeom>
+          <a:noFill/>
+        </p:spPr>
+        <p:txBody>
+          <a:bodyPr wrap="square" lIns="0" rIns="0" tIns="0" bIns="0" anchor="ctr">
+            <a:noAutofit/>
+          </a:bodyPr>
+          <a:lstStyle/>
+          <a:p>
+            <a:pPr algn="l"/>
+            <a:r>
+              <a:rPr sz="1400" b="1" i="0" lang="es-ES">
+                <a:solidFill>
+                  <a:srgbClr val="1B2B48"/>
+                </a:solidFill>
+                <a:latin typeface="Calibri"/>
+              </a:rPr>
+              <a:t>Meses sin informe</a:t>
+            </a:r>
+            <a:endParaRPr lang="es-ES" sz="1400"/>
+          </a:p>
+          <a:p>
+            <a:pPr algn="l"/>
+            <a:r>
+              <a:rPr sz="1100" b="0" i="0" lang="es-ES">
+                <a:solidFill>
+                  <a:srgbClr val="5A6577"/>
+                </a:solidFill>
+                <a:latin typeface="Calibri"/>
+              </a:rPr>
+              <a:t>ACT-046</a:t>
+            </a:r>
+            <a:endParaRPr lang="es-ES" sz="1400"/>
+          </a:p>
+        </p:txBody>
+      </p:sp>
+      <p:sp>
+        <p:nvSpPr>
+          <p:cNvPr id="27" name="TextBox 26"/>
+          <p:cNvSpPr txBox="1"/>
+          <p:nvPr/>
+        </p:nvSpPr>
+        <p:spPr>
+          <a:xfrm>
+            <a:off x="4023360" y="3977639"/>
+            <a:ext cx="3931920" cy="658368"/>
+          </a:xfrm>
+          <a:prstGeom prst="rect">
+            <a:avLst/>
+          </a:prstGeom>
+          <a:noFill/>
+        </p:spPr>
+        <p:txBody>
+          <a:bodyPr wrap="square" lIns="0" rIns="0" tIns="0" bIns="0" anchor="ctr">
+            <a:noAutofit/>
+          </a:bodyPr>
+          <a:lstStyle/>
+          <a:p>
+            <a:pPr algn="l"/>
+            <a:r>
+              <a:rPr sz="1400" b="0" i="0" lang="es-ES">
+                <a:solidFill>
+                  <a:srgbClr val="5A6577"/>
+                </a:solidFill>
+                <a:latin typeface="Calibri"/>
+              </a:rPr>
+              <a:t>Meses sin % ganado entre dos cierres</a:t>
+            </a:r>
+            <a:endParaRPr lang="es-ES" sz="1400"/>
+          </a:p>
+        </p:txBody>
+      </p:sp>
+      <p:sp>
+        <p:nvSpPr>
+          <p:cNvPr id="28" name="TextBox 27"/>
+          <p:cNvSpPr txBox="1"/>
+          <p:nvPr/>
+        </p:nvSpPr>
+        <p:spPr>
+          <a:xfrm>
+            <a:off x="8229600" y="3977639"/>
+            <a:ext cx="3291840" cy="658368"/>
+          </a:xfrm>
+          <a:prstGeom prst="rect">
+            <a:avLst/>
+          </a:prstGeom>
+          <a:noFill/>
+        </p:spPr>
+        <p:txBody>
+          <a:bodyPr wrap="square" lIns="0" rIns="0" tIns="0" bIns="0" anchor="ctr">
+            <a:noAutofit/>
+          </a:bodyPr>
+          <a:lstStyle/>
+          <a:p>
+            <a:pPr algn="l"/>
+            <a:r>
+              <a:rPr sz="1400" b="0" i="0" lang="es-ES">
+                <a:solidFill>
+                  <a:srgbClr val="1B2B48"/>
+                </a:solidFill>
+                <a:latin typeface="Calibri"/>
+              </a:rPr>
+              <a:t>Registrar el avance todos los meses</a:t>
+            </a:r>
+            <a:endParaRPr lang="es-ES" sz="1400"/>
+          </a:p>
+        </p:txBody>
+      </p:sp>
+      <p:sp>
+        <p:nvSpPr>
+          <p:cNvPr id="29" name="Rounded Rectangle 28"/>
+          <p:cNvSpPr/>
+          <p:nvPr/>
+        </p:nvSpPr>
+        <p:spPr>
+          <a:xfrm>
+            <a:off x="548640" y="4700016"/>
+            <a:ext cx="11064240" cy="658368"/>
+          </a:xfrm>
+          <a:prstGeom prst="roundRect">
+            <a:avLst>
+              <a:gd name="adj" fmla="val 11111"/>
+            </a:avLst>
+          </a:prstGeom>
+          <a:solidFill>
+            <a:srgbClr val="F3F5F9"/>
+          </a:solidFill>
+          <a:ln>
+            <a:noFill/>
+          </a:ln>
+        </p:spPr>
+        <p:txBody>
+          <a:bodyPr rtlCol="0" anchor="ctr" wrap="square" lIns="73152" rIns="73152" tIns="73152" bIns="73152">
+            <a:noAutofit/>
+          </a:bodyPr>
+          <a:lstStyle/>
+          <a:p>
+            <a:pPr algn="ctr"/>
+          </a:p>
+        </p:txBody>
+      </p:sp>
+      <p:sp>
+        <p:nvSpPr>
+          <p:cNvPr id="30" name="Oval 29"/>
+          <p:cNvSpPr/>
+          <p:nvPr/>
+        </p:nvSpPr>
+        <p:spPr>
+          <a:xfrm>
+            <a:off x="685800" y="4910328"/>
+            <a:ext cx="237744" cy="237744"/>
+          </a:xfrm>
+          <a:prstGeom prst="ellipse">
+            <a:avLst/>
+          </a:prstGeom>
+          <a:solidFill>
+            <a:srgbClr val="F2C14E"/>
+          </a:solidFill>
+          <a:ln>
+            <a:noFill/>
+          </a:ln>
+        </p:spPr>
+        <p:txBody>
+          <a:bodyPr rtlCol="0" anchor="ctr" wrap="square" lIns="0" rIns="0" tIns="0" bIns="0">
+            <a:noAutofit/>
+          </a:bodyPr>
+          <a:lstStyle/>
+          <a:p>
+            <a:pPr algn="ctr"/>
+            <a:r>
+              <a:rPr sz="1400" b="1" i="0" lang="es-ES">
+                <a:solidFill>
+                  <a:srgbClr val="FFFFFF"/>
+                </a:solidFill>
+                <a:latin typeface="Calibri"/>
+              </a:rPr>
+              <a:t/>
+            </a:r>
+            <a:endParaRPr lang="es-ES" sz="1400"/>
+          </a:p>
+        </p:txBody>
+      </p:sp>
+      <p:sp>
+        <p:nvSpPr>
+          <p:cNvPr id="31" name="TextBox 30"/>
+          <p:cNvSpPr txBox="1"/>
+          <p:nvPr/>
+        </p:nvSpPr>
+        <p:spPr>
+          <a:xfrm>
+            <a:off x="1051560" y="4700016"/>
+            <a:ext cx="2743200" cy="658368"/>
+          </a:xfrm>
+          <a:prstGeom prst="rect">
+            <a:avLst/>
+          </a:prstGeom>
+          <a:noFill/>
+        </p:spPr>
+        <p:txBody>
+          <a:bodyPr wrap="square" lIns="0" rIns="0" tIns="0" bIns="0" anchor="ctr">
+            <a:noAutofit/>
+          </a:bodyPr>
+          <a:lstStyle/>
+          <a:p>
+            <a:pPr algn="l"/>
+            <a:r>
+              <a:rPr sz="1400" b="1" i="0" lang="es-ES">
+                <a:solidFill>
+                  <a:srgbClr val="1B2B48"/>
+                </a:solidFill>
+                <a:latin typeface="Calibri"/>
+              </a:rPr>
+              <a:t>Análisis incompleto</a:t>
+            </a:r>
+            <a:endParaRPr lang="es-ES" sz="1400"/>
+          </a:p>
+          <a:p>
+            <a:pPr algn="l"/>
+            <a:r>
+              <a:rPr sz="1100" b="0" i="0" lang="es-ES">
+                <a:solidFill>
+                  <a:srgbClr val="5A6577"/>
+                </a:solidFill>
+                <a:latin typeface="Calibri"/>
+              </a:rPr>
+              <a:t>ACT-043 a ACT-045</a:t>
+            </a:r>
+            <a:endParaRPr lang="es-ES" sz="1400"/>
+          </a:p>
+        </p:txBody>
+      </p:sp>
+      <p:sp>
+        <p:nvSpPr>
+          <p:cNvPr id="32" name="TextBox 31"/>
+          <p:cNvSpPr txBox="1"/>
+          <p:nvPr/>
+        </p:nvSpPr>
+        <p:spPr>
+          <a:xfrm>
+            <a:off x="4023360" y="4700016"/>
+            <a:ext cx="3931920" cy="658368"/>
+          </a:xfrm>
+          <a:prstGeom prst="rect">
+            <a:avLst/>
+          </a:prstGeom>
+          <a:noFill/>
+        </p:spPr>
+        <p:txBody>
+          <a:bodyPr wrap="square" lIns="0" rIns="0" tIns="0" bIns="0" anchor="ctr">
+            <a:noAutofit/>
+          </a:bodyPr>
+          <a:lstStyle/>
+          <a:p>
+            <a:pPr algn="l"/>
+            <a:r>
+              <a:rPr sz="1400" b="0" i="0" lang="es-ES">
+                <a:solidFill>
+                  <a:srgbClr val="5A6577"/>
+                </a:solidFill>
+                <a:latin typeface="Calibri"/>
+              </a:rPr>
+              <a:t>Desviaciones sin causa o sin acción; acciones vencidas</a:t>
+            </a:r>
+            <a:endParaRPr lang="es-ES" sz="1400"/>
+          </a:p>
+        </p:txBody>
+      </p:sp>
+      <p:sp>
+        <p:nvSpPr>
+          <p:cNvPr id="33" name="TextBox 32"/>
+          <p:cNvSpPr txBox="1"/>
+          <p:nvPr/>
+        </p:nvSpPr>
+        <p:spPr>
+          <a:xfrm>
+            <a:off x="8229600" y="4700016"/>
+            <a:ext cx="3291840" cy="658368"/>
+          </a:xfrm>
+          <a:prstGeom prst="rect">
+            <a:avLst/>
+          </a:prstGeom>
+          <a:noFill/>
+        </p:spPr>
+        <p:txBody>
+          <a:bodyPr wrap="square" lIns="0" rIns="0" tIns="0" bIns="0" anchor="ctr">
+            <a:noAutofit/>
+          </a:bodyPr>
+          <a:lstStyle/>
+          <a:p>
+            <a:pPr algn="l"/>
+            <a:r>
+              <a:rPr sz="1400" b="0" i="0" lang="es-ES">
+                <a:solidFill>
+                  <a:srgbClr val="1B2B48"/>
+                </a:solidFill>
+                <a:latin typeface="Calibri"/>
+              </a:rPr>
+              <a:t>Completarlo antes del cierre siguiente</a:t>
+            </a:r>
+            <a:endParaRPr lang="es-ES" sz="1400"/>
+          </a:p>
+        </p:txBody>
+      </p:sp>
+      <p:sp>
+        <p:nvSpPr>
+          <p:cNvPr id="34" name="Rounded Rectangle 33"/>
+          <p:cNvSpPr/>
+          <p:nvPr/>
+        </p:nvSpPr>
+        <p:spPr>
+          <a:xfrm>
+            <a:off x="548640" y="5422392"/>
+            <a:ext cx="11064240" cy="658368"/>
+          </a:xfrm>
+          <a:prstGeom prst="roundRect">
+            <a:avLst>
+              <a:gd name="adj" fmla="val 11111"/>
+            </a:avLst>
+          </a:prstGeom>
+          <a:solidFill>
+            <a:srgbClr val="FFFFFF"/>
+          </a:solidFill>
+          <a:ln w="12700">
+            <a:solidFill>
+              <a:srgbClr val="D5DBE5"/>
+            </a:solidFill>
+          </a:ln>
+        </p:spPr>
+        <p:txBody>
+          <a:bodyPr rtlCol="0" anchor="ctr" wrap="square" lIns="73152" rIns="73152" tIns="73152" bIns="73152">
+            <a:noAutofit/>
+          </a:bodyPr>
+          <a:lstStyle/>
+          <a:p>
+            <a:pPr algn="ctr"/>
+          </a:p>
+        </p:txBody>
+      </p:sp>
+      <p:sp>
+        <p:nvSpPr>
+          <p:cNvPr id="35" name="Oval 34"/>
+          <p:cNvSpPr/>
+          <p:nvPr/>
+        </p:nvSpPr>
+        <p:spPr>
+          <a:xfrm>
+            <a:off x="685800" y="5632704"/>
+            <a:ext cx="237744" cy="237744"/>
+          </a:xfrm>
+          <a:prstGeom prst="ellipse">
+            <a:avLst/>
+          </a:prstGeom>
+          <a:solidFill>
+            <a:srgbClr val="F2C14E"/>
+          </a:solidFill>
+          <a:ln>
+            <a:noFill/>
+          </a:ln>
+        </p:spPr>
+        <p:txBody>
+          <a:bodyPr rtlCol="0" anchor="ctr" wrap="square" lIns="0" rIns="0" tIns="0" bIns="0">
+            <a:noAutofit/>
+          </a:bodyPr>
+          <a:lstStyle/>
+          <a:p>
+            <a:pPr algn="ctr"/>
+            <a:r>
+              <a:rPr sz="1400" b="1" i="0" lang="es-ES">
+                <a:solidFill>
+                  <a:srgbClr val="FFFFFF"/>
+                </a:solidFill>
+                <a:latin typeface="Calibri"/>
+              </a:rPr>
+              <a:t/>
+            </a:r>
+            <a:endParaRPr lang="es-ES" sz="1400"/>
+          </a:p>
+        </p:txBody>
+      </p:sp>
+      <p:sp>
+        <p:nvSpPr>
+          <p:cNvPr id="36" name="TextBox 35"/>
+          <p:cNvSpPr txBox="1"/>
+          <p:nvPr/>
+        </p:nvSpPr>
+        <p:spPr>
+          <a:xfrm>
+            <a:off x="1051560" y="5422392"/>
+            <a:ext cx="2743200" cy="658368"/>
+          </a:xfrm>
+          <a:prstGeom prst="rect">
+            <a:avLst/>
+          </a:prstGeom>
+          <a:noFill/>
+        </p:spPr>
+        <p:txBody>
+          <a:bodyPr wrap="square" lIns="0" rIns="0" tIns="0" bIns="0" anchor="ctr">
+            <a:noAutofit/>
+          </a:bodyPr>
+          <a:lstStyle/>
+          <a:p>
+            <a:pPr algn="l"/>
+            <a:r>
+              <a:rPr sz="1400" b="1" i="0" lang="es-ES">
+                <a:solidFill>
+                  <a:srgbClr val="1B2B48"/>
+                </a:solidFill>
+                <a:latin typeface="Calibri"/>
+              </a:rPr>
+              <a:t>EAC poco realista</a:t>
+            </a:r>
+            <a:endParaRPr lang="es-ES" sz="1400"/>
+          </a:p>
+          <a:p>
+            <a:pPr algn="l"/>
+            <a:r>
+              <a:rPr sz="1100" b="0" i="0" lang="es-ES">
+                <a:solidFill>
+                  <a:srgbClr val="5A6577"/>
+                </a:solidFill>
+                <a:latin typeface="Calibri"/>
+              </a:rPr>
+              <a:t>ACT-048</a:t>
+            </a:r>
+            <a:endParaRPr lang="es-ES" sz="1400"/>
+          </a:p>
+        </p:txBody>
+      </p:sp>
+      <p:sp>
+        <p:nvSpPr>
+          <p:cNvPr id="37" name="TextBox 36"/>
+          <p:cNvSpPr txBox="1"/>
+          <p:nvPr/>
+        </p:nvSpPr>
+        <p:spPr>
+          <a:xfrm>
+            <a:off x="4023360" y="5422392"/>
+            <a:ext cx="3931920" cy="658368"/>
+          </a:xfrm>
+          <a:prstGeom prst="rect">
+            <a:avLst/>
+          </a:prstGeom>
+          <a:noFill/>
+        </p:spPr>
+        <p:txBody>
+          <a:bodyPr wrap="square" lIns="0" rIns="0" tIns="0" bIns="0" anchor="ctr">
+            <a:noAutofit/>
+          </a:bodyPr>
+          <a:lstStyle/>
+          <a:p>
+            <a:pPr algn="l"/>
+            <a:r>
+              <a:rPr sz="1400" b="0" i="0" lang="es-ES">
+                <a:solidFill>
+                  <a:srgbClr val="5A6577"/>
+                </a:solidFill>
+                <a:latin typeface="Calibri"/>
+              </a:rPr>
+              <a:t>TCPI (BAC) más de 0,10 por encima del CPI, desde el 20 % completado</a:t>
+            </a:r>
+            <a:endParaRPr lang="es-ES" sz="1400"/>
+          </a:p>
+        </p:txBody>
+      </p:sp>
+      <p:sp>
+        <p:nvSpPr>
+          <p:cNvPr id="38" name="TextBox 37"/>
+          <p:cNvSpPr txBox="1"/>
+          <p:nvPr/>
+        </p:nvSpPr>
+        <p:spPr>
+          <a:xfrm>
+            <a:off x="8229600" y="5422392"/>
+            <a:ext cx="3291840" cy="658368"/>
+          </a:xfrm>
+          <a:prstGeom prst="rect">
+            <a:avLst/>
+          </a:prstGeom>
+          <a:noFill/>
+        </p:spPr>
+        <p:txBody>
+          <a:bodyPr wrap="square" lIns="0" rIns="0" tIns="0" bIns="0" anchor="ctr">
+            <a:noAutofit/>
+          </a:bodyPr>
+          <a:lstStyle/>
+          <a:p>
+            <a:pPr algn="l"/>
+            <a:r>
+              <a:rPr sz="1400" b="0" i="0" lang="es-ES">
+                <a:solidFill>
+                  <a:srgbClr val="1B2B48"/>
+                </a:solidFill>
+                <a:latin typeface="Calibri"/>
+              </a:rPr>
+              <a:t>Revisar el EAC; evaluar una línea base por encima del objetivo</a:t>
+            </a:r>
+            <a:endParaRPr lang="es-ES" sz="1400"/>
+          </a:p>
+        </p:txBody>
+      </p:sp>
+    </p:spTree>
+  </p:cSld>
+  <p:clrMapOvr>
+    <a:masterClrMapping/>
+  </p:clrMapOvr>
+</p:sld>
+</file>
+
+<file path=ppt/slides/slide37.xml><?xml version="1.0" encoding="utf-8"?>
+<p:sld xmlns:a="http://schemas.openxmlformats.org/drawingml/2006/main" xmlns:p="http://schemas.openxmlformats.org/presentationml/2006/main" xmlns:r="http://schemas.openxmlformats.org/officeDocument/2006/relationships">
+  <p:cSld>
     <p:bg>
       <p:bgPr>
         <a:solidFill>
@@ -42151,7 +43809,7 @@
                 </a:solidFill>
                 <a:latin typeface="Calibri"/>
               </a:rPr>
-              <a:t>36</a:t>
+              <a:t>37</a:t>
             </a:fld>
             <a:endParaRPr lang="es-ES" sz="1000"/>
           </a:p>
@@ -43278,7 +44936,7 @@
 </p:sld>
 </file>
 
-<file path=ppt/slides/slide37.xml><?xml version="1.0" encoding="utf-8"?>
+<file path=ppt/slides/slide38.xml><?xml version="1.0" encoding="utf-8"?>
 <p:sld xmlns:a="http://schemas.openxmlformats.org/drawingml/2006/main" xmlns:p="http://schemas.openxmlformats.org/presentationml/2006/main" xmlns:r="http://schemas.openxmlformats.org/officeDocument/2006/relationships">
   <p:cSld>
     <p:bg>
@@ -43434,7 +45092,7 @@
                 </a:solidFill>
                 <a:latin typeface="Calibri"/>
               </a:rPr>
-              <a:t>37</a:t>
+              <a:t>38</a:t>
             </a:fld>
             <a:endParaRPr lang="es-ES" sz="1000"/>
           </a:p>

</xml_diff>